<commit_message>
Add test evidence to competition deck
</commit_message>
<xml_diff>
--- a/GeoWatch-AI/submission/GeoWatch_AI_Competition_Deck_Final.pptx
+++ b/GeoWatch-AI/submission/GeoWatch_AI_Competition_Deck_Final.pptx
@@ -15,6 +15,7 @@
     <p:sldId id="263" r:id="rId9"/>
     <p:sldId id="264" r:id="rId10"/>
     <p:sldId id="265" r:id="rId11"/>
+    <p:sldId id="266" r:id="rId12"/>
   </p:sldIdLst>
   <p:sldSz cx="16256000" cy="9144000"/>
   <p:notesSz cx="6858000" cy="9144000"/>
@@ -138,7 +139,7 @@
           <p:cNvPr id="2" name="Title 1">
             <a:extLst>
               <a:ext uri="{FF2B5EF4-FFF2-40B4-BE49-F238E27FC236}">
-                <a16:creationId xmlns:a16="http://schemas.microsoft.com/office/drawing/2014/main" id="{109CA415-D356-AA6B-BDBB-205316B29A03}"/>
+                <a16:creationId xmlns:a16="http://schemas.microsoft.com/office/drawing/2014/main" id="{AB061985-ECDD-8D78-9A73-E8D9979967DF}"/>
               </a:ext>
             </a:extLst>
           </p:cNvPr>
@@ -176,7 +177,7 @@
           <p:cNvPr id="3" name="Subtitle 2">
             <a:extLst>
               <a:ext uri="{FF2B5EF4-FFF2-40B4-BE49-F238E27FC236}">
-                <a16:creationId xmlns:a16="http://schemas.microsoft.com/office/drawing/2014/main" id="{8419A81B-8DB6-1FD5-99F7-1FCBA3AA8905}"/>
+                <a16:creationId xmlns:a16="http://schemas.microsoft.com/office/drawing/2014/main" id="{0B2BB265-2416-AD02-4378-7A798D830BE4}"/>
               </a:ext>
             </a:extLst>
           </p:cNvPr>
@@ -247,7 +248,7 @@
           <p:cNvPr id="4" name="Date Placeholder 3">
             <a:extLst>
               <a:ext uri="{FF2B5EF4-FFF2-40B4-BE49-F238E27FC236}">
-                <a16:creationId xmlns:a16="http://schemas.microsoft.com/office/drawing/2014/main" id="{96B6FD1C-719A-CB92-B165-3D7539FFF482}"/>
+                <a16:creationId xmlns:a16="http://schemas.microsoft.com/office/drawing/2014/main" id="{9794AD0B-8957-FE98-2CEC-79BB449699C2}"/>
               </a:ext>
             </a:extLst>
           </p:cNvPr>
@@ -263,7 +264,7 @@
           <a:bodyPr/>
           <a:lstStyle/>
           <a:p>
-            <a:fld id="{D4051D6F-EB83-4791-9603-9BFA514B43E5}" type="datetimeFigureOut">
+            <a:fld id="{BA1A73AE-57F4-4E25-ACDC-6E406F4E1640}" type="datetimeFigureOut">
               <a:rPr lang="ru-KZ" smtClean="0"/>
               <a:t>11.09.2026</a:t>
             </a:fld>
@@ -276,7 +277,7 @@
           <p:cNvPr id="5" name="Footer Placeholder 4">
             <a:extLst>
               <a:ext uri="{FF2B5EF4-FFF2-40B4-BE49-F238E27FC236}">
-                <a16:creationId xmlns:a16="http://schemas.microsoft.com/office/drawing/2014/main" id="{1C3F0D33-329E-D376-0E83-80BF116DDF06}"/>
+                <a16:creationId xmlns:a16="http://schemas.microsoft.com/office/drawing/2014/main" id="{E070DC9F-622B-23FD-3641-6EDFB5660214}"/>
               </a:ext>
             </a:extLst>
           </p:cNvPr>
@@ -301,7 +302,7 @@
           <p:cNvPr id="6" name="Slide Number Placeholder 5">
             <a:extLst>
               <a:ext uri="{FF2B5EF4-FFF2-40B4-BE49-F238E27FC236}">
-                <a16:creationId xmlns:a16="http://schemas.microsoft.com/office/drawing/2014/main" id="{F79189BF-2BC2-0B9C-DC44-4E8C460309DF}"/>
+                <a16:creationId xmlns:a16="http://schemas.microsoft.com/office/drawing/2014/main" id="{C048E077-1387-B6B5-9FC7-A143FB6F9484}"/>
               </a:ext>
             </a:extLst>
           </p:cNvPr>
@@ -317,7 +318,7 @@
           <a:bodyPr/>
           <a:lstStyle/>
           <a:p>
-            <a:fld id="{21271898-F9C6-488E-B99E-0EA1E1C1DD53}" type="slidenum">
+            <a:fld id="{07362F00-6D5B-489D-B048-14A4A912D4F4}" type="slidenum">
               <a:rPr lang="ru-KZ" smtClean="0"/>
               <a:t>‹#›</a:t>
             </a:fld>
@@ -328,7 +329,7 @@
     </p:spTree>
     <p:extLst>
       <p:ext uri="{BB962C8B-B14F-4D97-AF65-F5344CB8AC3E}">
-        <p14:creationId xmlns:p14="http://schemas.microsoft.com/office/powerpoint/2010/main" val="3582202195"/>
+        <p14:creationId xmlns:p14="http://schemas.microsoft.com/office/powerpoint/2010/main" val="4125469184"/>
       </p:ext>
     </p:extLst>
   </p:cSld>
@@ -360,7 +361,7 @@
           <p:cNvPr id="2" name="Title 1">
             <a:extLst>
               <a:ext uri="{FF2B5EF4-FFF2-40B4-BE49-F238E27FC236}">
-                <a16:creationId xmlns:a16="http://schemas.microsoft.com/office/drawing/2014/main" id="{04D61FC7-57F4-5069-053E-E2ABB9C72DDF}"/>
+                <a16:creationId xmlns:a16="http://schemas.microsoft.com/office/drawing/2014/main" id="{98FB38B0-DED9-4720-5FB8-C43012C2678D}"/>
               </a:ext>
             </a:extLst>
           </p:cNvPr>
@@ -389,7 +390,7 @@
           <p:cNvPr id="3" name="Vertical Text Placeholder 2">
             <a:extLst>
               <a:ext uri="{FF2B5EF4-FFF2-40B4-BE49-F238E27FC236}">
-                <a16:creationId xmlns:a16="http://schemas.microsoft.com/office/drawing/2014/main" id="{B481EC9E-E5B1-F3B9-C281-BBAF4A8731E0}"/>
+                <a16:creationId xmlns:a16="http://schemas.microsoft.com/office/drawing/2014/main" id="{9A5B14BF-1936-226F-AB65-7715769A705E}"/>
               </a:ext>
             </a:extLst>
           </p:cNvPr>
@@ -447,7 +448,7 @@
           <p:cNvPr id="4" name="Date Placeholder 3">
             <a:extLst>
               <a:ext uri="{FF2B5EF4-FFF2-40B4-BE49-F238E27FC236}">
-                <a16:creationId xmlns:a16="http://schemas.microsoft.com/office/drawing/2014/main" id="{6799F5D8-DB70-B9EF-9558-008D4404328F}"/>
+                <a16:creationId xmlns:a16="http://schemas.microsoft.com/office/drawing/2014/main" id="{6FA72E92-59AB-F45F-2B1C-B86ECDB0004A}"/>
               </a:ext>
             </a:extLst>
           </p:cNvPr>
@@ -463,7 +464,7 @@
           <a:bodyPr/>
           <a:lstStyle/>
           <a:p>
-            <a:fld id="{D4051D6F-EB83-4791-9603-9BFA514B43E5}" type="datetimeFigureOut">
+            <a:fld id="{BA1A73AE-57F4-4E25-ACDC-6E406F4E1640}" type="datetimeFigureOut">
               <a:rPr lang="ru-KZ" smtClean="0"/>
               <a:t>11.09.2026</a:t>
             </a:fld>
@@ -476,7 +477,7 @@
           <p:cNvPr id="5" name="Footer Placeholder 4">
             <a:extLst>
               <a:ext uri="{FF2B5EF4-FFF2-40B4-BE49-F238E27FC236}">
-                <a16:creationId xmlns:a16="http://schemas.microsoft.com/office/drawing/2014/main" id="{44084E70-A3E5-6733-CACA-8E5E88B81C56}"/>
+                <a16:creationId xmlns:a16="http://schemas.microsoft.com/office/drawing/2014/main" id="{326056B5-7B46-505C-7E39-C5FF6A6B8008}"/>
               </a:ext>
             </a:extLst>
           </p:cNvPr>
@@ -501,7 +502,7 @@
           <p:cNvPr id="6" name="Slide Number Placeholder 5">
             <a:extLst>
               <a:ext uri="{FF2B5EF4-FFF2-40B4-BE49-F238E27FC236}">
-                <a16:creationId xmlns:a16="http://schemas.microsoft.com/office/drawing/2014/main" id="{E9491882-761E-7C0E-AF86-6BFC3C97102F}"/>
+                <a16:creationId xmlns:a16="http://schemas.microsoft.com/office/drawing/2014/main" id="{1A62EF39-B10B-FCA0-8AA3-595F02250351}"/>
               </a:ext>
             </a:extLst>
           </p:cNvPr>
@@ -517,7 +518,7 @@
           <a:bodyPr/>
           <a:lstStyle/>
           <a:p>
-            <a:fld id="{21271898-F9C6-488E-B99E-0EA1E1C1DD53}" type="slidenum">
+            <a:fld id="{07362F00-6D5B-489D-B048-14A4A912D4F4}" type="slidenum">
               <a:rPr lang="ru-KZ" smtClean="0"/>
               <a:t>‹#›</a:t>
             </a:fld>
@@ -528,7 +529,7 @@
     </p:spTree>
     <p:extLst>
       <p:ext uri="{BB962C8B-B14F-4D97-AF65-F5344CB8AC3E}">
-        <p14:creationId xmlns:p14="http://schemas.microsoft.com/office/powerpoint/2010/main" val="3466164456"/>
+        <p14:creationId xmlns:p14="http://schemas.microsoft.com/office/powerpoint/2010/main" val="2341713499"/>
       </p:ext>
     </p:extLst>
   </p:cSld>
@@ -560,7 +561,7 @@
           <p:cNvPr id="2" name="Vertical Title 1">
             <a:extLst>
               <a:ext uri="{FF2B5EF4-FFF2-40B4-BE49-F238E27FC236}">
-                <a16:creationId xmlns:a16="http://schemas.microsoft.com/office/drawing/2014/main" id="{991828C8-BDF5-938C-03D3-00B500913BCA}"/>
+                <a16:creationId xmlns:a16="http://schemas.microsoft.com/office/drawing/2014/main" id="{6A2711E3-2CB6-07F4-847A-C61D7C5C316E}"/>
               </a:ext>
             </a:extLst>
           </p:cNvPr>
@@ -594,7 +595,7 @@
           <p:cNvPr id="3" name="Vertical Text Placeholder 2">
             <a:extLst>
               <a:ext uri="{FF2B5EF4-FFF2-40B4-BE49-F238E27FC236}">
-                <a16:creationId xmlns:a16="http://schemas.microsoft.com/office/drawing/2014/main" id="{E1584751-75C7-8DC3-5370-5D256862C700}"/>
+                <a16:creationId xmlns:a16="http://schemas.microsoft.com/office/drawing/2014/main" id="{79D18214-3CA7-6070-17F1-00DC588B2E96}"/>
               </a:ext>
             </a:extLst>
           </p:cNvPr>
@@ -657,7 +658,7 @@
           <p:cNvPr id="4" name="Date Placeholder 3">
             <a:extLst>
               <a:ext uri="{FF2B5EF4-FFF2-40B4-BE49-F238E27FC236}">
-                <a16:creationId xmlns:a16="http://schemas.microsoft.com/office/drawing/2014/main" id="{BDEB2DFD-EBEB-5E06-7CBD-347E7C65FF90}"/>
+                <a16:creationId xmlns:a16="http://schemas.microsoft.com/office/drawing/2014/main" id="{6B1459CC-23C1-D1AA-FB77-DF266889BF8E}"/>
               </a:ext>
             </a:extLst>
           </p:cNvPr>
@@ -673,7 +674,7 @@
           <a:bodyPr/>
           <a:lstStyle/>
           <a:p>
-            <a:fld id="{D4051D6F-EB83-4791-9603-9BFA514B43E5}" type="datetimeFigureOut">
+            <a:fld id="{BA1A73AE-57F4-4E25-ACDC-6E406F4E1640}" type="datetimeFigureOut">
               <a:rPr lang="ru-KZ" smtClean="0"/>
               <a:t>11.09.2026</a:t>
             </a:fld>
@@ -686,7 +687,7 @@
           <p:cNvPr id="5" name="Footer Placeholder 4">
             <a:extLst>
               <a:ext uri="{FF2B5EF4-FFF2-40B4-BE49-F238E27FC236}">
-                <a16:creationId xmlns:a16="http://schemas.microsoft.com/office/drawing/2014/main" id="{BFA42087-4907-0FF5-29AA-7410DF509B0C}"/>
+                <a16:creationId xmlns:a16="http://schemas.microsoft.com/office/drawing/2014/main" id="{36D4F543-A1DB-D82B-EBB9-74721D8171F1}"/>
               </a:ext>
             </a:extLst>
           </p:cNvPr>
@@ -711,7 +712,7 @@
           <p:cNvPr id="6" name="Slide Number Placeholder 5">
             <a:extLst>
               <a:ext uri="{FF2B5EF4-FFF2-40B4-BE49-F238E27FC236}">
-                <a16:creationId xmlns:a16="http://schemas.microsoft.com/office/drawing/2014/main" id="{680F07E3-F3C5-AFC3-6E2E-B7D85EE40A19}"/>
+                <a16:creationId xmlns:a16="http://schemas.microsoft.com/office/drawing/2014/main" id="{F84BE3CC-B453-F9D6-FA68-613166473FB5}"/>
               </a:ext>
             </a:extLst>
           </p:cNvPr>
@@ -727,7 +728,7 @@
           <a:bodyPr/>
           <a:lstStyle/>
           <a:p>
-            <a:fld id="{21271898-F9C6-488E-B99E-0EA1E1C1DD53}" type="slidenum">
+            <a:fld id="{07362F00-6D5B-489D-B048-14A4A912D4F4}" type="slidenum">
               <a:rPr lang="ru-KZ" smtClean="0"/>
               <a:t>‹#›</a:t>
             </a:fld>
@@ -738,7 +739,7 @@
     </p:spTree>
     <p:extLst>
       <p:ext uri="{BB962C8B-B14F-4D97-AF65-F5344CB8AC3E}">
-        <p14:creationId xmlns:p14="http://schemas.microsoft.com/office/powerpoint/2010/main" val="505864383"/>
+        <p14:creationId xmlns:p14="http://schemas.microsoft.com/office/powerpoint/2010/main" val="1682388206"/>
       </p:ext>
     </p:extLst>
   </p:cSld>
@@ -770,7 +771,7 @@
           <p:cNvPr id="2" name="Title 1">
             <a:extLst>
               <a:ext uri="{FF2B5EF4-FFF2-40B4-BE49-F238E27FC236}">
-                <a16:creationId xmlns:a16="http://schemas.microsoft.com/office/drawing/2014/main" id="{140BE46A-77F9-B27A-A567-EAAF5A4E84FA}"/>
+                <a16:creationId xmlns:a16="http://schemas.microsoft.com/office/drawing/2014/main" id="{783585B4-5A01-E318-5456-7555E6175B6E}"/>
               </a:ext>
             </a:extLst>
           </p:cNvPr>
@@ -799,7 +800,7 @@
           <p:cNvPr id="3" name="Content Placeholder 2">
             <a:extLst>
               <a:ext uri="{FF2B5EF4-FFF2-40B4-BE49-F238E27FC236}">
-                <a16:creationId xmlns:a16="http://schemas.microsoft.com/office/drawing/2014/main" id="{B28F087E-C151-4B8A-9ED4-3962430870F7}"/>
+                <a16:creationId xmlns:a16="http://schemas.microsoft.com/office/drawing/2014/main" id="{AD6BEABF-F6B8-E590-430E-9D68D7D2E4C0}"/>
               </a:ext>
             </a:extLst>
           </p:cNvPr>
@@ -857,7 +858,7 @@
           <p:cNvPr id="4" name="Date Placeholder 3">
             <a:extLst>
               <a:ext uri="{FF2B5EF4-FFF2-40B4-BE49-F238E27FC236}">
-                <a16:creationId xmlns:a16="http://schemas.microsoft.com/office/drawing/2014/main" id="{8ACDD9F8-9EBD-118C-7758-0A0922B6545A}"/>
+                <a16:creationId xmlns:a16="http://schemas.microsoft.com/office/drawing/2014/main" id="{6D98A989-811C-41E3-BBBB-5B081CA5E77F}"/>
               </a:ext>
             </a:extLst>
           </p:cNvPr>
@@ -873,7 +874,7 @@
           <a:bodyPr/>
           <a:lstStyle/>
           <a:p>
-            <a:fld id="{D4051D6F-EB83-4791-9603-9BFA514B43E5}" type="datetimeFigureOut">
+            <a:fld id="{BA1A73AE-57F4-4E25-ACDC-6E406F4E1640}" type="datetimeFigureOut">
               <a:rPr lang="ru-KZ" smtClean="0"/>
               <a:t>11.09.2026</a:t>
             </a:fld>
@@ -886,7 +887,7 @@
           <p:cNvPr id="5" name="Footer Placeholder 4">
             <a:extLst>
               <a:ext uri="{FF2B5EF4-FFF2-40B4-BE49-F238E27FC236}">
-                <a16:creationId xmlns:a16="http://schemas.microsoft.com/office/drawing/2014/main" id="{C5AF4E3D-EB3C-E66B-E615-7EB5B3677244}"/>
+                <a16:creationId xmlns:a16="http://schemas.microsoft.com/office/drawing/2014/main" id="{138A92B6-0027-39D7-0BBC-C2EF88515BD5}"/>
               </a:ext>
             </a:extLst>
           </p:cNvPr>
@@ -911,7 +912,7 @@
           <p:cNvPr id="6" name="Slide Number Placeholder 5">
             <a:extLst>
               <a:ext uri="{FF2B5EF4-FFF2-40B4-BE49-F238E27FC236}">
-                <a16:creationId xmlns:a16="http://schemas.microsoft.com/office/drawing/2014/main" id="{3F235B08-AE23-9316-6F7D-F7DFFC903244}"/>
+                <a16:creationId xmlns:a16="http://schemas.microsoft.com/office/drawing/2014/main" id="{657F729C-97A9-3E35-BFE0-A82299591DE6}"/>
               </a:ext>
             </a:extLst>
           </p:cNvPr>
@@ -927,7 +928,7 @@
           <a:bodyPr/>
           <a:lstStyle/>
           <a:p>
-            <a:fld id="{21271898-F9C6-488E-B99E-0EA1E1C1DD53}" type="slidenum">
+            <a:fld id="{07362F00-6D5B-489D-B048-14A4A912D4F4}" type="slidenum">
               <a:rPr lang="ru-KZ" smtClean="0"/>
               <a:t>‹#›</a:t>
             </a:fld>
@@ -938,7 +939,7 @@
     </p:spTree>
     <p:extLst>
       <p:ext uri="{BB962C8B-B14F-4D97-AF65-F5344CB8AC3E}">
-        <p14:creationId xmlns:p14="http://schemas.microsoft.com/office/powerpoint/2010/main" val="401812633"/>
+        <p14:creationId xmlns:p14="http://schemas.microsoft.com/office/powerpoint/2010/main" val="4033045513"/>
       </p:ext>
     </p:extLst>
   </p:cSld>
@@ -970,7 +971,7 @@
           <p:cNvPr id="2" name="Title 1">
             <a:extLst>
               <a:ext uri="{FF2B5EF4-FFF2-40B4-BE49-F238E27FC236}">
-                <a16:creationId xmlns:a16="http://schemas.microsoft.com/office/drawing/2014/main" id="{143B9EE4-FF77-9892-29CF-03BDA1424EA0}"/>
+                <a16:creationId xmlns:a16="http://schemas.microsoft.com/office/drawing/2014/main" id="{A65BD5B3-21E8-C8A1-1292-4967EF562DF9}"/>
               </a:ext>
             </a:extLst>
           </p:cNvPr>
@@ -1008,7 +1009,7 @@
           <p:cNvPr id="3" name="Text Placeholder 2">
             <a:extLst>
               <a:ext uri="{FF2B5EF4-FFF2-40B4-BE49-F238E27FC236}">
-                <a16:creationId xmlns:a16="http://schemas.microsoft.com/office/drawing/2014/main" id="{73BAE221-704A-C877-A111-4D9D4E7B2FD9}"/>
+                <a16:creationId xmlns:a16="http://schemas.microsoft.com/office/drawing/2014/main" id="{A4FEB39A-F8BD-FC3F-CCF9-6C9B67C489D5}"/>
               </a:ext>
             </a:extLst>
           </p:cNvPr>
@@ -1133,7 +1134,7 @@
           <p:cNvPr id="4" name="Date Placeholder 3">
             <a:extLst>
               <a:ext uri="{FF2B5EF4-FFF2-40B4-BE49-F238E27FC236}">
-                <a16:creationId xmlns:a16="http://schemas.microsoft.com/office/drawing/2014/main" id="{15E67890-F3EF-92AD-2A16-18088EA59FE1}"/>
+                <a16:creationId xmlns:a16="http://schemas.microsoft.com/office/drawing/2014/main" id="{1569BC73-4A9F-C639-3543-A9C64952EF8A}"/>
               </a:ext>
             </a:extLst>
           </p:cNvPr>
@@ -1149,7 +1150,7 @@
           <a:bodyPr/>
           <a:lstStyle/>
           <a:p>
-            <a:fld id="{D4051D6F-EB83-4791-9603-9BFA514B43E5}" type="datetimeFigureOut">
+            <a:fld id="{BA1A73AE-57F4-4E25-ACDC-6E406F4E1640}" type="datetimeFigureOut">
               <a:rPr lang="ru-KZ" smtClean="0"/>
               <a:t>11.09.2026</a:t>
             </a:fld>
@@ -1162,7 +1163,7 @@
           <p:cNvPr id="5" name="Footer Placeholder 4">
             <a:extLst>
               <a:ext uri="{FF2B5EF4-FFF2-40B4-BE49-F238E27FC236}">
-                <a16:creationId xmlns:a16="http://schemas.microsoft.com/office/drawing/2014/main" id="{E2DBDAB1-64F0-DDC4-26C2-B501C02C7B90}"/>
+                <a16:creationId xmlns:a16="http://schemas.microsoft.com/office/drawing/2014/main" id="{C3C9BE53-D8B5-D1B5-CBA4-C0530FD71A47}"/>
               </a:ext>
             </a:extLst>
           </p:cNvPr>
@@ -1187,7 +1188,7 @@
           <p:cNvPr id="6" name="Slide Number Placeholder 5">
             <a:extLst>
               <a:ext uri="{FF2B5EF4-FFF2-40B4-BE49-F238E27FC236}">
-                <a16:creationId xmlns:a16="http://schemas.microsoft.com/office/drawing/2014/main" id="{6F240BDE-D7E0-A2C5-8A4B-177E48386912}"/>
+                <a16:creationId xmlns:a16="http://schemas.microsoft.com/office/drawing/2014/main" id="{1DA49C88-FE22-F060-14FF-9E80A56A8888}"/>
               </a:ext>
             </a:extLst>
           </p:cNvPr>
@@ -1203,7 +1204,7 @@
           <a:bodyPr/>
           <a:lstStyle/>
           <a:p>
-            <a:fld id="{21271898-F9C6-488E-B99E-0EA1E1C1DD53}" type="slidenum">
+            <a:fld id="{07362F00-6D5B-489D-B048-14A4A912D4F4}" type="slidenum">
               <a:rPr lang="ru-KZ" smtClean="0"/>
               <a:t>‹#›</a:t>
             </a:fld>
@@ -1214,7 +1215,7 @@
     </p:spTree>
     <p:extLst>
       <p:ext uri="{BB962C8B-B14F-4D97-AF65-F5344CB8AC3E}">
-        <p14:creationId xmlns:p14="http://schemas.microsoft.com/office/powerpoint/2010/main" val="2886153986"/>
+        <p14:creationId xmlns:p14="http://schemas.microsoft.com/office/powerpoint/2010/main" val="3208115042"/>
       </p:ext>
     </p:extLst>
   </p:cSld>
@@ -1246,7 +1247,7 @@
           <p:cNvPr id="2" name="Title 1">
             <a:extLst>
               <a:ext uri="{FF2B5EF4-FFF2-40B4-BE49-F238E27FC236}">
-                <a16:creationId xmlns:a16="http://schemas.microsoft.com/office/drawing/2014/main" id="{E251CEB0-EA1F-5249-98E4-742D92237EFD}"/>
+                <a16:creationId xmlns:a16="http://schemas.microsoft.com/office/drawing/2014/main" id="{70D1868B-F561-7AA7-1C25-B612D4BD4A41}"/>
               </a:ext>
             </a:extLst>
           </p:cNvPr>
@@ -1275,7 +1276,7 @@
           <p:cNvPr id="3" name="Content Placeholder 2">
             <a:extLst>
               <a:ext uri="{FF2B5EF4-FFF2-40B4-BE49-F238E27FC236}">
-                <a16:creationId xmlns:a16="http://schemas.microsoft.com/office/drawing/2014/main" id="{3F26F5EC-90B4-9380-901E-7989B15A1361}"/>
+                <a16:creationId xmlns:a16="http://schemas.microsoft.com/office/drawing/2014/main" id="{28F5900F-FAC6-4A62-F5B6-ACCED605C105}"/>
               </a:ext>
             </a:extLst>
           </p:cNvPr>
@@ -1338,7 +1339,7 @@
           <p:cNvPr id="4" name="Content Placeholder 3">
             <a:extLst>
               <a:ext uri="{FF2B5EF4-FFF2-40B4-BE49-F238E27FC236}">
-                <a16:creationId xmlns:a16="http://schemas.microsoft.com/office/drawing/2014/main" id="{E09AF6A6-5DFA-7F06-D523-7E3D328B5DA3}"/>
+                <a16:creationId xmlns:a16="http://schemas.microsoft.com/office/drawing/2014/main" id="{D7AD6F69-2B18-4DB8-BC12-2E949C3ABD73}"/>
               </a:ext>
             </a:extLst>
           </p:cNvPr>
@@ -1401,7 +1402,7 @@
           <p:cNvPr id="5" name="Date Placeholder 4">
             <a:extLst>
               <a:ext uri="{FF2B5EF4-FFF2-40B4-BE49-F238E27FC236}">
-                <a16:creationId xmlns:a16="http://schemas.microsoft.com/office/drawing/2014/main" id="{259F2E2A-1199-A48C-5144-2B9AAF7705C4}"/>
+                <a16:creationId xmlns:a16="http://schemas.microsoft.com/office/drawing/2014/main" id="{834806B1-5E9C-3DD1-6F33-32EE79572139}"/>
               </a:ext>
             </a:extLst>
           </p:cNvPr>
@@ -1417,7 +1418,7 @@
           <a:bodyPr/>
           <a:lstStyle/>
           <a:p>
-            <a:fld id="{D4051D6F-EB83-4791-9603-9BFA514B43E5}" type="datetimeFigureOut">
+            <a:fld id="{BA1A73AE-57F4-4E25-ACDC-6E406F4E1640}" type="datetimeFigureOut">
               <a:rPr lang="ru-KZ" smtClean="0"/>
               <a:t>11.09.2026</a:t>
             </a:fld>
@@ -1430,7 +1431,7 @@
           <p:cNvPr id="6" name="Footer Placeholder 5">
             <a:extLst>
               <a:ext uri="{FF2B5EF4-FFF2-40B4-BE49-F238E27FC236}">
-                <a16:creationId xmlns:a16="http://schemas.microsoft.com/office/drawing/2014/main" id="{DF298155-E08E-80C5-A4E4-1EC72293A39F}"/>
+                <a16:creationId xmlns:a16="http://schemas.microsoft.com/office/drawing/2014/main" id="{AF8D2345-D5D0-FACA-BFF0-418920C8DD5D}"/>
               </a:ext>
             </a:extLst>
           </p:cNvPr>
@@ -1455,7 +1456,7 @@
           <p:cNvPr id="7" name="Slide Number Placeholder 6">
             <a:extLst>
               <a:ext uri="{FF2B5EF4-FFF2-40B4-BE49-F238E27FC236}">
-                <a16:creationId xmlns:a16="http://schemas.microsoft.com/office/drawing/2014/main" id="{D2B0AB47-5368-0C2F-1F0D-B2D6C130A06B}"/>
+                <a16:creationId xmlns:a16="http://schemas.microsoft.com/office/drawing/2014/main" id="{73A9FA31-D47B-E4C1-E861-9A9608D70B89}"/>
               </a:ext>
             </a:extLst>
           </p:cNvPr>
@@ -1471,7 +1472,7 @@
           <a:bodyPr/>
           <a:lstStyle/>
           <a:p>
-            <a:fld id="{21271898-F9C6-488E-B99E-0EA1E1C1DD53}" type="slidenum">
+            <a:fld id="{07362F00-6D5B-489D-B048-14A4A912D4F4}" type="slidenum">
               <a:rPr lang="ru-KZ" smtClean="0"/>
               <a:t>‹#›</a:t>
             </a:fld>
@@ -1482,7 +1483,7 @@
     </p:spTree>
     <p:extLst>
       <p:ext uri="{BB962C8B-B14F-4D97-AF65-F5344CB8AC3E}">
-        <p14:creationId xmlns:p14="http://schemas.microsoft.com/office/powerpoint/2010/main" val="1118490418"/>
+        <p14:creationId xmlns:p14="http://schemas.microsoft.com/office/powerpoint/2010/main" val="39142844"/>
       </p:ext>
     </p:extLst>
   </p:cSld>
@@ -1514,7 +1515,7 @@
           <p:cNvPr id="2" name="Title 1">
             <a:extLst>
               <a:ext uri="{FF2B5EF4-FFF2-40B4-BE49-F238E27FC236}">
-                <a16:creationId xmlns:a16="http://schemas.microsoft.com/office/drawing/2014/main" id="{5301CE9E-5A3E-88C4-6A1B-3D3092C14399}"/>
+                <a16:creationId xmlns:a16="http://schemas.microsoft.com/office/drawing/2014/main" id="{C2BFC1AE-B9A9-A7EE-D741-36ABE4245460}"/>
               </a:ext>
             </a:extLst>
           </p:cNvPr>
@@ -1548,7 +1549,7 @@
           <p:cNvPr id="3" name="Text Placeholder 2">
             <a:extLst>
               <a:ext uri="{FF2B5EF4-FFF2-40B4-BE49-F238E27FC236}">
-                <a16:creationId xmlns:a16="http://schemas.microsoft.com/office/drawing/2014/main" id="{2670F13D-3065-DB74-960B-1F64AAE0D3C4}"/>
+                <a16:creationId xmlns:a16="http://schemas.microsoft.com/office/drawing/2014/main" id="{97D3D19F-B3D2-7FA9-A538-520AE7EEA426}"/>
               </a:ext>
             </a:extLst>
           </p:cNvPr>
@@ -1619,7 +1620,7 @@
           <p:cNvPr id="4" name="Content Placeholder 3">
             <a:extLst>
               <a:ext uri="{FF2B5EF4-FFF2-40B4-BE49-F238E27FC236}">
-                <a16:creationId xmlns:a16="http://schemas.microsoft.com/office/drawing/2014/main" id="{580C0F23-AF08-209E-7DAF-DED9B12C7823}"/>
+                <a16:creationId xmlns:a16="http://schemas.microsoft.com/office/drawing/2014/main" id="{84002D82-19DE-02DB-93CE-ECC7ED242A73}"/>
               </a:ext>
             </a:extLst>
           </p:cNvPr>
@@ -1682,7 +1683,7 @@
           <p:cNvPr id="5" name="Text Placeholder 4">
             <a:extLst>
               <a:ext uri="{FF2B5EF4-FFF2-40B4-BE49-F238E27FC236}">
-                <a16:creationId xmlns:a16="http://schemas.microsoft.com/office/drawing/2014/main" id="{A14A5630-8B85-B137-DEF5-0D48487C204E}"/>
+                <a16:creationId xmlns:a16="http://schemas.microsoft.com/office/drawing/2014/main" id="{B2F470D4-E17D-7B63-26AA-34C4AA599D90}"/>
               </a:ext>
             </a:extLst>
           </p:cNvPr>
@@ -1753,7 +1754,7 @@
           <p:cNvPr id="6" name="Content Placeholder 5">
             <a:extLst>
               <a:ext uri="{FF2B5EF4-FFF2-40B4-BE49-F238E27FC236}">
-                <a16:creationId xmlns:a16="http://schemas.microsoft.com/office/drawing/2014/main" id="{29450F9B-BFE2-7C1E-D866-E334E0DBB600}"/>
+                <a16:creationId xmlns:a16="http://schemas.microsoft.com/office/drawing/2014/main" id="{A0FCD784-244B-66F6-6CD1-D60F9FB95443}"/>
               </a:ext>
             </a:extLst>
           </p:cNvPr>
@@ -1816,7 +1817,7 @@
           <p:cNvPr id="7" name="Date Placeholder 6">
             <a:extLst>
               <a:ext uri="{FF2B5EF4-FFF2-40B4-BE49-F238E27FC236}">
-                <a16:creationId xmlns:a16="http://schemas.microsoft.com/office/drawing/2014/main" id="{7775004D-8058-7E1D-D898-0F7B0C76A0DA}"/>
+                <a16:creationId xmlns:a16="http://schemas.microsoft.com/office/drawing/2014/main" id="{CA9F3329-4BA7-9516-6A31-D569534DBFAE}"/>
               </a:ext>
             </a:extLst>
           </p:cNvPr>
@@ -1832,7 +1833,7 @@
           <a:bodyPr/>
           <a:lstStyle/>
           <a:p>
-            <a:fld id="{D4051D6F-EB83-4791-9603-9BFA514B43E5}" type="datetimeFigureOut">
+            <a:fld id="{BA1A73AE-57F4-4E25-ACDC-6E406F4E1640}" type="datetimeFigureOut">
               <a:rPr lang="ru-KZ" smtClean="0"/>
               <a:t>11.09.2026</a:t>
             </a:fld>
@@ -1845,7 +1846,7 @@
           <p:cNvPr id="8" name="Footer Placeholder 7">
             <a:extLst>
               <a:ext uri="{FF2B5EF4-FFF2-40B4-BE49-F238E27FC236}">
-                <a16:creationId xmlns:a16="http://schemas.microsoft.com/office/drawing/2014/main" id="{C9B01618-A73C-4B56-2FB7-8ACBC4FD56FA}"/>
+                <a16:creationId xmlns:a16="http://schemas.microsoft.com/office/drawing/2014/main" id="{C3B3701A-D0E5-8C01-82FF-D0FF052EE5A0}"/>
               </a:ext>
             </a:extLst>
           </p:cNvPr>
@@ -1870,7 +1871,7 @@
           <p:cNvPr id="9" name="Slide Number Placeholder 8">
             <a:extLst>
               <a:ext uri="{FF2B5EF4-FFF2-40B4-BE49-F238E27FC236}">
-                <a16:creationId xmlns:a16="http://schemas.microsoft.com/office/drawing/2014/main" id="{4F2E5AF9-6FF4-F323-A8FB-C6B9FCFA4FB1}"/>
+                <a16:creationId xmlns:a16="http://schemas.microsoft.com/office/drawing/2014/main" id="{3B3CFF86-1E2E-C766-695E-9E2B74B3163F}"/>
               </a:ext>
             </a:extLst>
           </p:cNvPr>
@@ -1886,7 +1887,7 @@
           <a:bodyPr/>
           <a:lstStyle/>
           <a:p>
-            <a:fld id="{21271898-F9C6-488E-B99E-0EA1E1C1DD53}" type="slidenum">
+            <a:fld id="{07362F00-6D5B-489D-B048-14A4A912D4F4}" type="slidenum">
               <a:rPr lang="ru-KZ" smtClean="0"/>
               <a:t>‹#›</a:t>
             </a:fld>
@@ -1897,7 +1898,7 @@
     </p:spTree>
     <p:extLst>
       <p:ext uri="{BB962C8B-B14F-4D97-AF65-F5344CB8AC3E}">
-        <p14:creationId xmlns:p14="http://schemas.microsoft.com/office/powerpoint/2010/main" val="3046962588"/>
+        <p14:creationId xmlns:p14="http://schemas.microsoft.com/office/powerpoint/2010/main" val="1229626854"/>
       </p:ext>
     </p:extLst>
   </p:cSld>
@@ -1929,7 +1930,7 @@
           <p:cNvPr id="2" name="Title 1">
             <a:extLst>
               <a:ext uri="{FF2B5EF4-FFF2-40B4-BE49-F238E27FC236}">
-                <a16:creationId xmlns:a16="http://schemas.microsoft.com/office/drawing/2014/main" id="{BFD1628A-9400-9E6A-5A81-9F7EFF0018BD}"/>
+                <a16:creationId xmlns:a16="http://schemas.microsoft.com/office/drawing/2014/main" id="{6799D948-B334-C1EF-D976-C00F58F601FC}"/>
               </a:ext>
             </a:extLst>
           </p:cNvPr>
@@ -1958,7 +1959,7 @@
           <p:cNvPr id="3" name="Date Placeholder 2">
             <a:extLst>
               <a:ext uri="{FF2B5EF4-FFF2-40B4-BE49-F238E27FC236}">
-                <a16:creationId xmlns:a16="http://schemas.microsoft.com/office/drawing/2014/main" id="{AFE1A70A-083A-7378-E778-ED430998B5D1}"/>
+                <a16:creationId xmlns:a16="http://schemas.microsoft.com/office/drawing/2014/main" id="{F0E3652B-39CA-6839-A281-CDC94D0C5602}"/>
               </a:ext>
             </a:extLst>
           </p:cNvPr>
@@ -1974,7 +1975,7 @@
           <a:bodyPr/>
           <a:lstStyle/>
           <a:p>
-            <a:fld id="{D4051D6F-EB83-4791-9603-9BFA514B43E5}" type="datetimeFigureOut">
+            <a:fld id="{BA1A73AE-57F4-4E25-ACDC-6E406F4E1640}" type="datetimeFigureOut">
               <a:rPr lang="ru-KZ" smtClean="0"/>
               <a:t>11.09.2026</a:t>
             </a:fld>
@@ -1987,7 +1988,7 @@
           <p:cNvPr id="4" name="Footer Placeholder 3">
             <a:extLst>
               <a:ext uri="{FF2B5EF4-FFF2-40B4-BE49-F238E27FC236}">
-                <a16:creationId xmlns:a16="http://schemas.microsoft.com/office/drawing/2014/main" id="{0862819C-65B3-D024-E623-3E3821477E1C}"/>
+                <a16:creationId xmlns:a16="http://schemas.microsoft.com/office/drawing/2014/main" id="{6DFA1EE0-9992-8855-914B-E40C43D6B11E}"/>
               </a:ext>
             </a:extLst>
           </p:cNvPr>
@@ -2012,7 +2013,7 @@
           <p:cNvPr id="5" name="Slide Number Placeholder 4">
             <a:extLst>
               <a:ext uri="{FF2B5EF4-FFF2-40B4-BE49-F238E27FC236}">
-                <a16:creationId xmlns:a16="http://schemas.microsoft.com/office/drawing/2014/main" id="{8A4CD7E6-8D94-D699-CA89-616FC903D476}"/>
+                <a16:creationId xmlns:a16="http://schemas.microsoft.com/office/drawing/2014/main" id="{235E2582-F8BF-C7CE-F7CD-4FD7DE7CC5AC}"/>
               </a:ext>
             </a:extLst>
           </p:cNvPr>
@@ -2028,7 +2029,7 @@
           <a:bodyPr/>
           <a:lstStyle/>
           <a:p>
-            <a:fld id="{21271898-F9C6-488E-B99E-0EA1E1C1DD53}" type="slidenum">
+            <a:fld id="{07362F00-6D5B-489D-B048-14A4A912D4F4}" type="slidenum">
               <a:rPr lang="ru-KZ" smtClean="0"/>
               <a:t>‹#›</a:t>
             </a:fld>
@@ -2039,7 +2040,7 @@
     </p:spTree>
     <p:extLst>
       <p:ext uri="{BB962C8B-B14F-4D97-AF65-F5344CB8AC3E}">
-        <p14:creationId xmlns:p14="http://schemas.microsoft.com/office/powerpoint/2010/main" val="767812039"/>
+        <p14:creationId xmlns:p14="http://schemas.microsoft.com/office/powerpoint/2010/main" val="4164158528"/>
       </p:ext>
     </p:extLst>
   </p:cSld>
@@ -2071,7 +2072,7 @@
           <p:cNvPr id="2" name="Date Placeholder 1">
             <a:extLst>
               <a:ext uri="{FF2B5EF4-FFF2-40B4-BE49-F238E27FC236}">
-                <a16:creationId xmlns:a16="http://schemas.microsoft.com/office/drawing/2014/main" id="{52FEDA82-6CDD-CC5B-3E5E-DB0687BFC5C5}"/>
+                <a16:creationId xmlns:a16="http://schemas.microsoft.com/office/drawing/2014/main" id="{26F4E599-D955-2264-0510-E38F98EFEB86}"/>
               </a:ext>
             </a:extLst>
           </p:cNvPr>
@@ -2087,7 +2088,7 @@
           <a:bodyPr/>
           <a:lstStyle/>
           <a:p>
-            <a:fld id="{D4051D6F-EB83-4791-9603-9BFA514B43E5}" type="datetimeFigureOut">
+            <a:fld id="{BA1A73AE-57F4-4E25-ACDC-6E406F4E1640}" type="datetimeFigureOut">
               <a:rPr lang="ru-KZ" smtClean="0"/>
               <a:t>11.09.2026</a:t>
             </a:fld>
@@ -2100,7 +2101,7 @@
           <p:cNvPr id="3" name="Footer Placeholder 2">
             <a:extLst>
               <a:ext uri="{FF2B5EF4-FFF2-40B4-BE49-F238E27FC236}">
-                <a16:creationId xmlns:a16="http://schemas.microsoft.com/office/drawing/2014/main" id="{3C527A15-0841-59A2-84A8-26CACCD35AD5}"/>
+                <a16:creationId xmlns:a16="http://schemas.microsoft.com/office/drawing/2014/main" id="{77055783-3D84-E02E-4210-A5813C490B68}"/>
               </a:ext>
             </a:extLst>
           </p:cNvPr>
@@ -2125,7 +2126,7 @@
           <p:cNvPr id="4" name="Slide Number Placeholder 3">
             <a:extLst>
               <a:ext uri="{FF2B5EF4-FFF2-40B4-BE49-F238E27FC236}">
-                <a16:creationId xmlns:a16="http://schemas.microsoft.com/office/drawing/2014/main" id="{A95404C5-FF6F-0B5F-C872-C054C382F3F4}"/>
+                <a16:creationId xmlns:a16="http://schemas.microsoft.com/office/drawing/2014/main" id="{DF271A76-63EA-C101-9B8F-E3FE3EF0AFC4}"/>
               </a:ext>
             </a:extLst>
           </p:cNvPr>
@@ -2141,7 +2142,7 @@
           <a:bodyPr/>
           <a:lstStyle/>
           <a:p>
-            <a:fld id="{21271898-F9C6-488E-B99E-0EA1E1C1DD53}" type="slidenum">
+            <a:fld id="{07362F00-6D5B-489D-B048-14A4A912D4F4}" type="slidenum">
               <a:rPr lang="ru-KZ" smtClean="0"/>
               <a:t>‹#›</a:t>
             </a:fld>
@@ -2152,7 +2153,7 @@
     </p:spTree>
     <p:extLst>
       <p:ext uri="{BB962C8B-B14F-4D97-AF65-F5344CB8AC3E}">
-        <p14:creationId xmlns:p14="http://schemas.microsoft.com/office/powerpoint/2010/main" val="942782497"/>
+        <p14:creationId xmlns:p14="http://schemas.microsoft.com/office/powerpoint/2010/main" val="3953499262"/>
       </p:ext>
     </p:extLst>
   </p:cSld>
@@ -2184,7 +2185,7 @@
           <p:cNvPr id="2" name="Title 1">
             <a:extLst>
               <a:ext uri="{FF2B5EF4-FFF2-40B4-BE49-F238E27FC236}">
-                <a16:creationId xmlns:a16="http://schemas.microsoft.com/office/drawing/2014/main" id="{7EE3B1B2-8FC7-D016-9EAD-9120826CF37B}"/>
+                <a16:creationId xmlns:a16="http://schemas.microsoft.com/office/drawing/2014/main" id="{8037235E-BE64-6097-8A7D-AEFE6DD446B5}"/>
               </a:ext>
             </a:extLst>
           </p:cNvPr>
@@ -2222,7 +2223,7 @@
           <p:cNvPr id="3" name="Content Placeholder 2">
             <a:extLst>
               <a:ext uri="{FF2B5EF4-FFF2-40B4-BE49-F238E27FC236}">
-                <a16:creationId xmlns:a16="http://schemas.microsoft.com/office/drawing/2014/main" id="{C76E324A-A756-5AA8-DA4A-DC9355EE92E0}"/>
+                <a16:creationId xmlns:a16="http://schemas.microsoft.com/office/drawing/2014/main" id="{A88509DE-332E-5379-C439-A87612B0FE1C}"/>
               </a:ext>
             </a:extLst>
           </p:cNvPr>
@@ -2313,7 +2314,7 @@
           <p:cNvPr id="4" name="Text Placeholder 3">
             <a:extLst>
               <a:ext uri="{FF2B5EF4-FFF2-40B4-BE49-F238E27FC236}">
-                <a16:creationId xmlns:a16="http://schemas.microsoft.com/office/drawing/2014/main" id="{93D8E004-01BC-379F-7D95-8201225C5649}"/>
+                <a16:creationId xmlns:a16="http://schemas.microsoft.com/office/drawing/2014/main" id="{08EBC0E4-136C-64E5-B7D8-655022DE14C4}"/>
               </a:ext>
             </a:extLst>
           </p:cNvPr>
@@ -2384,7 +2385,7 @@
           <p:cNvPr id="5" name="Date Placeholder 4">
             <a:extLst>
               <a:ext uri="{FF2B5EF4-FFF2-40B4-BE49-F238E27FC236}">
-                <a16:creationId xmlns:a16="http://schemas.microsoft.com/office/drawing/2014/main" id="{677FF3DF-55F8-96CE-0BA9-8E51BBDB509F}"/>
+                <a16:creationId xmlns:a16="http://schemas.microsoft.com/office/drawing/2014/main" id="{47BC24F6-559F-96A1-3F66-5C8E9E1562ED}"/>
               </a:ext>
             </a:extLst>
           </p:cNvPr>
@@ -2400,7 +2401,7 @@
           <a:bodyPr/>
           <a:lstStyle/>
           <a:p>
-            <a:fld id="{D4051D6F-EB83-4791-9603-9BFA514B43E5}" type="datetimeFigureOut">
+            <a:fld id="{BA1A73AE-57F4-4E25-ACDC-6E406F4E1640}" type="datetimeFigureOut">
               <a:rPr lang="ru-KZ" smtClean="0"/>
               <a:t>11.09.2026</a:t>
             </a:fld>
@@ -2413,7 +2414,7 @@
           <p:cNvPr id="6" name="Footer Placeholder 5">
             <a:extLst>
               <a:ext uri="{FF2B5EF4-FFF2-40B4-BE49-F238E27FC236}">
-                <a16:creationId xmlns:a16="http://schemas.microsoft.com/office/drawing/2014/main" id="{61DC6A6E-DB39-D413-BB0B-DC7BFA094CE4}"/>
+                <a16:creationId xmlns:a16="http://schemas.microsoft.com/office/drawing/2014/main" id="{76801ACA-8942-BD2D-94CF-FF5FF2A3E5D5}"/>
               </a:ext>
             </a:extLst>
           </p:cNvPr>
@@ -2438,7 +2439,7 @@
           <p:cNvPr id="7" name="Slide Number Placeholder 6">
             <a:extLst>
               <a:ext uri="{FF2B5EF4-FFF2-40B4-BE49-F238E27FC236}">
-                <a16:creationId xmlns:a16="http://schemas.microsoft.com/office/drawing/2014/main" id="{B0B4788E-FECE-0861-D58E-D5B678B9F311}"/>
+                <a16:creationId xmlns:a16="http://schemas.microsoft.com/office/drawing/2014/main" id="{F236CA69-7DE5-C25D-D14B-AEFA64DDD4D8}"/>
               </a:ext>
             </a:extLst>
           </p:cNvPr>
@@ -2454,7 +2455,7 @@
           <a:bodyPr/>
           <a:lstStyle/>
           <a:p>
-            <a:fld id="{21271898-F9C6-488E-B99E-0EA1E1C1DD53}" type="slidenum">
+            <a:fld id="{07362F00-6D5B-489D-B048-14A4A912D4F4}" type="slidenum">
               <a:rPr lang="ru-KZ" smtClean="0"/>
               <a:t>‹#›</a:t>
             </a:fld>
@@ -2465,7 +2466,7 @@
     </p:spTree>
     <p:extLst>
       <p:ext uri="{BB962C8B-B14F-4D97-AF65-F5344CB8AC3E}">
-        <p14:creationId xmlns:p14="http://schemas.microsoft.com/office/powerpoint/2010/main" val="585795102"/>
+        <p14:creationId xmlns:p14="http://schemas.microsoft.com/office/powerpoint/2010/main" val="1119186371"/>
       </p:ext>
     </p:extLst>
   </p:cSld>
@@ -2497,7 +2498,7 @@
           <p:cNvPr id="2" name="Title 1">
             <a:extLst>
               <a:ext uri="{FF2B5EF4-FFF2-40B4-BE49-F238E27FC236}">
-                <a16:creationId xmlns:a16="http://schemas.microsoft.com/office/drawing/2014/main" id="{7C5CF3F8-DE26-53D5-F9CD-4CD8A44074B2}"/>
+                <a16:creationId xmlns:a16="http://schemas.microsoft.com/office/drawing/2014/main" id="{38A3E006-77CC-125C-DF37-133CB019F0E3}"/>
               </a:ext>
             </a:extLst>
           </p:cNvPr>
@@ -2535,7 +2536,7 @@
           <p:cNvPr id="3" name="Picture Placeholder 2">
             <a:extLst>
               <a:ext uri="{FF2B5EF4-FFF2-40B4-BE49-F238E27FC236}">
-                <a16:creationId xmlns:a16="http://schemas.microsoft.com/office/drawing/2014/main" id="{9F089C22-7C4F-9CB7-2D65-428D13A7916B}"/>
+                <a16:creationId xmlns:a16="http://schemas.microsoft.com/office/drawing/2014/main" id="{4EBC6198-12F9-2D13-D1EC-54F8E0C699D6}"/>
               </a:ext>
             </a:extLst>
           </p:cNvPr>
@@ -2602,7 +2603,7 @@
           <p:cNvPr id="4" name="Text Placeholder 3">
             <a:extLst>
               <a:ext uri="{FF2B5EF4-FFF2-40B4-BE49-F238E27FC236}">
-                <a16:creationId xmlns:a16="http://schemas.microsoft.com/office/drawing/2014/main" id="{4C49DA4C-A813-444A-BF4C-DF69F75F7350}"/>
+                <a16:creationId xmlns:a16="http://schemas.microsoft.com/office/drawing/2014/main" id="{55815C1F-CDC9-6E6C-34CB-2B3D161981A6}"/>
               </a:ext>
             </a:extLst>
           </p:cNvPr>
@@ -2673,7 +2674,7 @@
           <p:cNvPr id="5" name="Date Placeholder 4">
             <a:extLst>
               <a:ext uri="{FF2B5EF4-FFF2-40B4-BE49-F238E27FC236}">
-                <a16:creationId xmlns:a16="http://schemas.microsoft.com/office/drawing/2014/main" id="{0E2F2318-5467-B915-C836-99770E7460EB}"/>
+                <a16:creationId xmlns:a16="http://schemas.microsoft.com/office/drawing/2014/main" id="{5568DAAE-A21D-377B-3C23-26F4F2800341}"/>
               </a:ext>
             </a:extLst>
           </p:cNvPr>
@@ -2689,7 +2690,7 @@
           <a:bodyPr/>
           <a:lstStyle/>
           <a:p>
-            <a:fld id="{D4051D6F-EB83-4791-9603-9BFA514B43E5}" type="datetimeFigureOut">
+            <a:fld id="{BA1A73AE-57F4-4E25-ACDC-6E406F4E1640}" type="datetimeFigureOut">
               <a:rPr lang="ru-KZ" smtClean="0"/>
               <a:t>11.09.2026</a:t>
             </a:fld>
@@ -2702,7 +2703,7 @@
           <p:cNvPr id="6" name="Footer Placeholder 5">
             <a:extLst>
               <a:ext uri="{FF2B5EF4-FFF2-40B4-BE49-F238E27FC236}">
-                <a16:creationId xmlns:a16="http://schemas.microsoft.com/office/drawing/2014/main" id="{EC82F2DA-2958-EF7C-EC11-381BB5579C22}"/>
+                <a16:creationId xmlns:a16="http://schemas.microsoft.com/office/drawing/2014/main" id="{DA0F98B4-2AAE-5509-3964-C6AF8BE30723}"/>
               </a:ext>
             </a:extLst>
           </p:cNvPr>
@@ -2727,7 +2728,7 @@
           <p:cNvPr id="7" name="Slide Number Placeholder 6">
             <a:extLst>
               <a:ext uri="{FF2B5EF4-FFF2-40B4-BE49-F238E27FC236}">
-                <a16:creationId xmlns:a16="http://schemas.microsoft.com/office/drawing/2014/main" id="{E79D4D97-B8B8-86A4-44E7-9539DC2BF3CA}"/>
+                <a16:creationId xmlns:a16="http://schemas.microsoft.com/office/drawing/2014/main" id="{F4EF528B-7C5E-ED44-554D-E5DE25844BB9}"/>
               </a:ext>
             </a:extLst>
           </p:cNvPr>
@@ -2743,7 +2744,7 @@
           <a:bodyPr/>
           <a:lstStyle/>
           <a:p>
-            <a:fld id="{21271898-F9C6-488E-B99E-0EA1E1C1DD53}" type="slidenum">
+            <a:fld id="{07362F00-6D5B-489D-B048-14A4A912D4F4}" type="slidenum">
               <a:rPr lang="ru-KZ" smtClean="0"/>
               <a:t>‹#›</a:t>
             </a:fld>
@@ -2754,7 +2755,7 @@
     </p:spTree>
     <p:extLst>
       <p:ext uri="{BB962C8B-B14F-4D97-AF65-F5344CB8AC3E}">
-        <p14:creationId xmlns:p14="http://schemas.microsoft.com/office/powerpoint/2010/main" val="2092694701"/>
+        <p14:creationId xmlns:p14="http://schemas.microsoft.com/office/powerpoint/2010/main" val="1071769164"/>
       </p:ext>
     </p:extLst>
   </p:cSld>
@@ -2791,7 +2792,7 @@
           <p:cNvPr id="2" name="Title Placeholder 1">
             <a:extLst>
               <a:ext uri="{FF2B5EF4-FFF2-40B4-BE49-F238E27FC236}">
-                <a16:creationId xmlns:a16="http://schemas.microsoft.com/office/drawing/2014/main" id="{85A225A8-DD6D-D9E0-6C57-DDF765A8A0E6}"/>
+                <a16:creationId xmlns:a16="http://schemas.microsoft.com/office/drawing/2014/main" id="{F484993A-5E8C-DB42-99BF-0AD08CF9F8FB}"/>
               </a:ext>
             </a:extLst>
           </p:cNvPr>
@@ -2830,7 +2831,7 @@
           <p:cNvPr id="3" name="Text Placeholder 2">
             <a:extLst>
               <a:ext uri="{FF2B5EF4-FFF2-40B4-BE49-F238E27FC236}">
-                <a16:creationId xmlns:a16="http://schemas.microsoft.com/office/drawing/2014/main" id="{2E3FC0BD-69F1-F55B-3F85-2AF86AC9D6ED}"/>
+                <a16:creationId xmlns:a16="http://schemas.microsoft.com/office/drawing/2014/main" id="{96AE5E5A-A84A-F193-6FED-F4EBA5F29F34}"/>
               </a:ext>
             </a:extLst>
           </p:cNvPr>
@@ -2898,7 +2899,7 @@
           <p:cNvPr id="4" name="Date Placeholder 3">
             <a:extLst>
               <a:ext uri="{FF2B5EF4-FFF2-40B4-BE49-F238E27FC236}">
-                <a16:creationId xmlns:a16="http://schemas.microsoft.com/office/drawing/2014/main" id="{31F25DB5-00CC-E1B2-F5E0-ED91D13C23CB}"/>
+                <a16:creationId xmlns:a16="http://schemas.microsoft.com/office/drawing/2014/main" id="{30DD2255-DF92-C679-469D-389F62D105E5}"/>
               </a:ext>
             </a:extLst>
           </p:cNvPr>
@@ -2932,7 +2933,7 @@
             </a:lvl1pPr>
           </a:lstStyle>
           <a:p>
-            <a:fld id="{D4051D6F-EB83-4791-9603-9BFA514B43E5}" type="datetimeFigureOut">
+            <a:fld id="{BA1A73AE-57F4-4E25-ACDC-6E406F4E1640}" type="datetimeFigureOut">
               <a:rPr lang="ru-KZ" smtClean="0"/>
               <a:t>11.09.2026</a:t>
             </a:fld>
@@ -2945,7 +2946,7 @@
           <p:cNvPr id="5" name="Footer Placeholder 4">
             <a:extLst>
               <a:ext uri="{FF2B5EF4-FFF2-40B4-BE49-F238E27FC236}">
-                <a16:creationId xmlns:a16="http://schemas.microsoft.com/office/drawing/2014/main" id="{B3667AEA-0814-BAB0-7217-49A07B7DE551}"/>
+                <a16:creationId xmlns:a16="http://schemas.microsoft.com/office/drawing/2014/main" id="{424A10EC-4862-FF4B-4E84-ED4C3CAC366A}"/>
               </a:ext>
             </a:extLst>
           </p:cNvPr>
@@ -2988,7 +2989,7 @@
           <p:cNvPr id="6" name="Slide Number Placeholder 5">
             <a:extLst>
               <a:ext uri="{FF2B5EF4-FFF2-40B4-BE49-F238E27FC236}">
-                <a16:creationId xmlns:a16="http://schemas.microsoft.com/office/drawing/2014/main" id="{8848D4B4-BAB1-A4BE-37D6-45097909FF1B}"/>
+                <a16:creationId xmlns:a16="http://schemas.microsoft.com/office/drawing/2014/main" id="{01CF3234-2A91-09EF-80A8-FCD44A9042DF}"/>
               </a:ext>
             </a:extLst>
           </p:cNvPr>
@@ -3022,7 +3023,7 @@
             </a:lvl1pPr>
           </a:lstStyle>
           <a:p>
-            <a:fld id="{21271898-F9C6-488E-B99E-0EA1E1C1DD53}" type="slidenum">
+            <a:fld id="{07362F00-6D5B-489D-B048-14A4A912D4F4}" type="slidenum">
               <a:rPr lang="ru-KZ" smtClean="0"/>
               <a:t>‹#›</a:t>
             </a:fld>
@@ -3033,7 +3034,7 @@
     </p:spTree>
     <p:extLst>
       <p:ext uri="{BB962C8B-B14F-4D97-AF65-F5344CB8AC3E}">
-        <p14:creationId xmlns:p14="http://schemas.microsoft.com/office/powerpoint/2010/main" val="1696980401"/>
+        <p14:creationId xmlns:p14="http://schemas.microsoft.com/office/powerpoint/2010/main" val="1718631453"/>
       </p:ext>
     </p:extLst>
   </p:cSld>
@@ -3356,7 +3357,7 @@
           <p:cNvPr id="2" name="Rectangle 1">
             <a:extLst>
               <a:ext uri="{FF2B5EF4-FFF2-40B4-BE49-F238E27FC236}">
-                <a16:creationId xmlns:a16="http://schemas.microsoft.com/office/drawing/2014/main" id="{BA530C7E-2E96-C78E-B76D-2A8B056600F1}"/>
+                <a16:creationId xmlns:a16="http://schemas.microsoft.com/office/drawing/2014/main" id="{E417D153-9797-51F4-4A61-5AEF082CC258}"/>
               </a:ext>
             </a:extLst>
           </p:cNvPr>
@@ -3424,7 +3425,7 @@
           <p:cNvPr id="3" name="Rectangle 2">
             <a:extLst>
               <a:ext uri="{FF2B5EF4-FFF2-40B4-BE49-F238E27FC236}">
-                <a16:creationId xmlns:a16="http://schemas.microsoft.com/office/drawing/2014/main" id="{14C9FBE9-6C15-5EB4-9CB3-382291FF3F3C}"/>
+                <a16:creationId xmlns:a16="http://schemas.microsoft.com/office/drawing/2014/main" id="{946E042C-34CA-07F9-955B-860452DB4EA8}"/>
               </a:ext>
             </a:extLst>
           </p:cNvPr>
@@ -3492,7 +3493,7 @@
           <p:cNvPr id="4" name="Rectangle: Rounded Corners 3">
             <a:extLst>
               <a:ext uri="{FF2B5EF4-FFF2-40B4-BE49-F238E27FC236}">
-                <a16:creationId xmlns:a16="http://schemas.microsoft.com/office/drawing/2014/main" id="{20347D2A-5B6F-7C4D-C0D8-CCFA549B8E94}"/>
+                <a16:creationId xmlns:a16="http://schemas.microsoft.com/office/drawing/2014/main" id="{6104BFC2-7DDA-6589-6846-16439DDEAEAF}"/>
               </a:ext>
             </a:extLst>
           </p:cNvPr>
@@ -3560,7 +3561,7 @@
           <p:cNvPr id="5" name="Rectangle: Rounded Corners 4">
             <a:extLst>
               <a:ext uri="{FF2B5EF4-FFF2-40B4-BE49-F238E27FC236}">
-                <a16:creationId xmlns:a16="http://schemas.microsoft.com/office/drawing/2014/main" id="{366ADABF-9DD7-7CF4-85FD-EF30C81E27DB}"/>
+                <a16:creationId xmlns:a16="http://schemas.microsoft.com/office/drawing/2014/main" id="{03E4AB87-CDAE-17D5-EBBC-F873C90C3523}"/>
               </a:ext>
             </a:extLst>
           </p:cNvPr>
@@ -3628,7 +3629,7 @@
           <p:cNvPr id="6" name="TextBox 5">
             <a:extLst>
               <a:ext uri="{FF2B5EF4-FFF2-40B4-BE49-F238E27FC236}">
-                <a16:creationId xmlns:a16="http://schemas.microsoft.com/office/drawing/2014/main" id="{619D3591-255D-1D8E-FEB8-ED342635D838}"/>
+                <a16:creationId xmlns:a16="http://schemas.microsoft.com/office/drawing/2014/main" id="{ECFD5654-6D12-2C06-F532-D5A000666A3E}"/>
               </a:ext>
             </a:extLst>
           </p:cNvPr>
@@ -3668,7 +3669,7 @@
           <p:cNvPr id="7" name="TextBox 6">
             <a:extLst>
               <a:ext uri="{FF2B5EF4-FFF2-40B4-BE49-F238E27FC236}">
-                <a16:creationId xmlns:a16="http://schemas.microsoft.com/office/drawing/2014/main" id="{CF485A16-8EAF-0897-0176-4CBA3AE5ABB2}"/>
+                <a16:creationId xmlns:a16="http://schemas.microsoft.com/office/drawing/2014/main" id="{67ED73F2-F853-121E-79F1-6A599D150E87}"/>
               </a:ext>
             </a:extLst>
           </p:cNvPr>
@@ -3714,7 +3715,7 @@
           <p:cNvPr id="8" name="TextBox 7">
             <a:extLst>
               <a:ext uri="{FF2B5EF4-FFF2-40B4-BE49-F238E27FC236}">
-                <a16:creationId xmlns:a16="http://schemas.microsoft.com/office/drawing/2014/main" id="{70B3B8DF-4900-0B05-58EA-E037C944095D}"/>
+                <a16:creationId xmlns:a16="http://schemas.microsoft.com/office/drawing/2014/main" id="{DB04A9CC-17DC-57F1-F647-0A56E50392E1}"/>
               </a:ext>
             </a:extLst>
           </p:cNvPr>
@@ -3760,7 +3761,7 @@
           <p:cNvPr id="9" name="TextBox 8">
             <a:extLst>
               <a:ext uri="{FF2B5EF4-FFF2-40B4-BE49-F238E27FC236}">
-                <a16:creationId xmlns:a16="http://schemas.microsoft.com/office/drawing/2014/main" id="{083A1F15-7205-5438-33C6-600E32043D24}"/>
+                <a16:creationId xmlns:a16="http://schemas.microsoft.com/office/drawing/2014/main" id="{DA904D0C-B2C0-0DA9-07F8-43A791E1C122}"/>
               </a:ext>
             </a:extLst>
           </p:cNvPr>
@@ -3806,7 +3807,7 @@
           <p:cNvPr id="10" name="TextBox 9">
             <a:extLst>
               <a:ext uri="{FF2B5EF4-FFF2-40B4-BE49-F238E27FC236}">
-                <a16:creationId xmlns:a16="http://schemas.microsoft.com/office/drawing/2014/main" id="{8EB683B8-B5CD-C14A-FAE0-7E89B440E92F}"/>
+                <a16:creationId xmlns:a16="http://schemas.microsoft.com/office/drawing/2014/main" id="{AC76CE97-4A4B-A7ED-4F62-1F40FF843844}"/>
               </a:ext>
             </a:extLst>
           </p:cNvPr>
@@ -3899,7 +3900,7 @@
           <p:cNvPr id="11" name="TextBox 10">
             <a:extLst>
               <a:ext uri="{FF2B5EF4-FFF2-40B4-BE49-F238E27FC236}">
-                <a16:creationId xmlns:a16="http://schemas.microsoft.com/office/drawing/2014/main" id="{52EEBA2F-90AC-8A79-CF0D-9E6614BC5FEF}"/>
+                <a16:creationId xmlns:a16="http://schemas.microsoft.com/office/drawing/2014/main" id="{8D4CA399-2FBD-A7FC-03B3-1500B6ED872C}"/>
               </a:ext>
             </a:extLst>
           </p:cNvPr>
@@ -3937,7 +3938,7 @@
     </p:spTree>
     <p:extLst>
       <p:ext uri="{BB962C8B-B14F-4D97-AF65-F5344CB8AC3E}">
-        <p14:creationId xmlns:p14="http://schemas.microsoft.com/office/powerpoint/2010/main" val="2506089301"/>
+        <p14:creationId xmlns:p14="http://schemas.microsoft.com/office/powerpoint/2010/main" val="2799633204"/>
       </p:ext>
     </p:extLst>
   </p:cSld>
@@ -3969,7 +3970,7 @@
           <p:cNvPr id="2" name="TextBox 1">
             <a:extLst>
               <a:ext uri="{FF2B5EF4-FFF2-40B4-BE49-F238E27FC236}">
-                <a16:creationId xmlns:a16="http://schemas.microsoft.com/office/drawing/2014/main" id="{BC853D80-149D-9470-EEF8-03CB82965550}"/>
+                <a16:creationId xmlns:a16="http://schemas.microsoft.com/office/drawing/2014/main" id="{BBA1A512-173C-2D0E-5BDC-AD6D15D1DC04}"/>
               </a:ext>
             </a:extLst>
           </p:cNvPr>
@@ -4015,7 +4016,7 @@
           <p:cNvPr id="3" name="TextBox 2">
             <a:extLst>
               <a:ext uri="{FF2B5EF4-FFF2-40B4-BE49-F238E27FC236}">
-                <a16:creationId xmlns:a16="http://schemas.microsoft.com/office/drawing/2014/main" id="{F0745947-CFDB-F315-9C52-309DBCA880B3}"/>
+                <a16:creationId xmlns:a16="http://schemas.microsoft.com/office/drawing/2014/main" id="{0B870D73-0BBC-8993-D6B4-F24BB431928E}"/>
               </a:ext>
             </a:extLst>
           </p:cNvPr>
@@ -4061,7 +4062,7 @@
           <p:cNvPr id="4" name="TextBox 3">
             <a:extLst>
               <a:ext uri="{FF2B5EF4-FFF2-40B4-BE49-F238E27FC236}">
-                <a16:creationId xmlns:a16="http://schemas.microsoft.com/office/drawing/2014/main" id="{E5A8D496-F60D-6E52-6BB9-5DBE98A9904B}"/>
+                <a16:creationId xmlns:a16="http://schemas.microsoft.com/office/drawing/2014/main" id="{A519CAF5-347E-F92F-91CD-FD26D40AAE4F}"/>
               </a:ext>
             </a:extLst>
           </p:cNvPr>
@@ -4101,7 +4102,7 @@
           <p:cNvPr id="5" name="Straight Connector 4">
             <a:extLst>
               <a:ext uri="{FF2B5EF4-FFF2-40B4-BE49-F238E27FC236}">
-                <a16:creationId xmlns:a16="http://schemas.microsoft.com/office/drawing/2014/main" id="{5616DDF3-8B92-D52B-DB33-54A0CE887DBC}"/>
+                <a16:creationId xmlns:a16="http://schemas.microsoft.com/office/drawing/2014/main" id="{FA9A2488-0BFB-B264-2D86-B3DC5D407789}"/>
               </a:ext>
             </a:extLst>
           </p:cNvPr>
@@ -4142,7 +4143,7 @@
           <p:cNvPr id="6" name="TextBox 5">
             <a:extLst>
               <a:ext uri="{FF2B5EF4-FFF2-40B4-BE49-F238E27FC236}">
-                <a16:creationId xmlns:a16="http://schemas.microsoft.com/office/drawing/2014/main" id="{2767A5EE-6D00-E870-FDFC-68E3778A07E4}"/>
+                <a16:creationId xmlns:a16="http://schemas.microsoft.com/office/drawing/2014/main" id="{57823EF0-5AD9-13E9-8A67-424682261DD2}"/>
               </a:ext>
             </a:extLst>
           </p:cNvPr>
@@ -4188,7 +4189,7 @@
           <p:cNvPr id="7" name="Rectangle: Rounded Corners 6">
             <a:extLst>
               <a:ext uri="{FF2B5EF4-FFF2-40B4-BE49-F238E27FC236}">
-                <a16:creationId xmlns:a16="http://schemas.microsoft.com/office/drawing/2014/main" id="{157B2486-97FA-0176-E804-E78565410DCB}"/>
+                <a16:creationId xmlns:a16="http://schemas.microsoft.com/office/drawing/2014/main" id="{23315592-6874-36FE-E62F-1DCC82CC0735}"/>
               </a:ext>
             </a:extLst>
           </p:cNvPr>
@@ -4262,7 +4263,7 @@
           <p:cNvPr id="8" name="TextBox 7">
             <a:extLst>
               <a:ext uri="{FF2B5EF4-FFF2-40B4-BE49-F238E27FC236}">
-                <a16:creationId xmlns:a16="http://schemas.microsoft.com/office/drawing/2014/main" id="{38F13E22-7B9F-ECF0-A1CA-4651DAA4D18D}"/>
+                <a16:creationId xmlns:a16="http://schemas.microsoft.com/office/drawing/2014/main" id="{A80BC359-30BE-374F-8330-E01C360E135F}"/>
               </a:ext>
             </a:extLst>
           </p:cNvPr>
@@ -4302,7 +4303,7 @@
           <p:cNvPr id="9" name="TextBox 8">
             <a:extLst>
               <a:ext uri="{FF2B5EF4-FFF2-40B4-BE49-F238E27FC236}">
-                <a16:creationId xmlns:a16="http://schemas.microsoft.com/office/drawing/2014/main" id="{A0531079-B9FA-C825-A1D5-37C7F4E92ACD}"/>
+                <a16:creationId xmlns:a16="http://schemas.microsoft.com/office/drawing/2014/main" id="{2DC05812-EB92-D2B1-E54F-1D1BEB6EA907}"/>
               </a:ext>
             </a:extLst>
           </p:cNvPr>
@@ -4348,7 +4349,7 @@
           <p:cNvPr id="10" name="TextBox 9">
             <a:extLst>
               <a:ext uri="{FF2B5EF4-FFF2-40B4-BE49-F238E27FC236}">
-                <a16:creationId xmlns:a16="http://schemas.microsoft.com/office/drawing/2014/main" id="{256BC9ED-F27F-856F-79E5-4FBB49684CD2}"/>
+                <a16:creationId xmlns:a16="http://schemas.microsoft.com/office/drawing/2014/main" id="{43284202-0043-350C-5771-85D80F3575CC}"/>
               </a:ext>
             </a:extLst>
           </p:cNvPr>
@@ -4421,7 +4422,7 @@
           <p:cNvPr id="11" name="Rectangle: Rounded Corners 10">
             <a:extLst>
               <a:ext uri="{FF2B5EF4-FFF2-40B4-BE49-F238E27FC236}">
-                <a16:creationId xmlns:a16="http://schemas.microsoft.com/office/drawing/2014/main" id="{0CDCFECD-5C08-6CA5-7CBD-A870605B2BBE}"/>
+                <a16:creationId xmlns:a16="http://schemas.microsoft.com/office/drawing/2014/main" id="{1B0F363E-184E-0CA5-9551-FBAEB3FAB7C6}"/>
               </a:ext>
             </a:extLst>
           </p:cNvPr>
@@ -4495,7 +4496,7 @@
           <p:cNvPr id="12" name="TextBox 11">
             <a:extLst>
               <a:ext uri="{FF2B5EF4-FFF2-40B4-BE49-F238E27FC236}">
-                <a16:creationId xmlns:a16="http://schemas.microsoft.com/office/drawing/2014/main" id="{A5EFFC31-C392-D0C7-FB13-0CCEF58B0705}"/>
+                <a16:creationId xmlns:a16="http://schemas.microsoft.com/office/drawing/2014/main" id="{6671254D-CB55-4646-4E01-EEBF555E1413}"/>
               </a:ext>
             </a:extLst>
           </p:cNvPr>
@@ -4535,7 +4536,7 @@
           <p:cNvPr id="13" name="TextBox 12">
             <a:extLst>
               <a:ext uri="{FF2B5EF4-FFF2-40B4-BE49-F238E27FC236}">
-                <a16:creationId xmlns:a16="http://schemas.microsoft.com/office/drawing/2014/main" id="{3087C9F0-5E8B-EBAD-07E2-3FCBF023BEB4}"/>
+                <a16:creationId xmlns:a16="http://schemas.microsoft.com/office/drawing/2014/main" id="{60CD97F0-400F-00E5-4589-19C5C75B5F6F}"/>
               </a:ext>
             </a:extLst>
           </p:cNvPr>
@@ -4581,7 +4582,7 @@
           <p:cNvPr id="14" name="TextBox 13">
             <a:extLst>
               <a:ext uri="{FF2B5EF4-FFF2-40B4-BE49-F238E27FC236}">
-                <a16:creationId xmlns:a16="http://schemas.microsoft.com/office/drawing/2014/main" id="{D4338A11-6B5F-EF7A-0A49-956147E9A180}"/>
+                <a16:creationId xmlns:a16="http://schemas.microsoft.com/office/drawing/2014/main" id="{1EC3EC48-385C-E8C6-C91C-A958D3F4196C}"/>
               </a:ext>
             </a:extLst>
           </p:cNvPr>
@@ -4645,7 +4646,7 @@
           <p:cNvPr id="15" name="Rectangle: Rounded Corners 14">
             <a:extLst>
               <a:ext uri="{FF2B5EF4-FFF2-40B4-BE49-F238E27FC236}">
-                <a16:creationId xmlns:a16="http://schemas.microsoft.com/office/drawing/2014/main" id="{A7F71F77-9627-3C10-ABC3-34BB1ED143ED}"/>
+                <a16:creationId xmlns:a16="http://schemas.microsoft.com/office/drawing/2014/main" id="{346A992D-1A06-00AD-B801-816DD7081F44}"/>
               </a:ext>
             </a:extLst>
           </p:cNvPr>
@@ -4719,7 +4720,7 @@
           <p:cNvPr id="16" name="TextBox 15">
             <a:extLst>
               <a:ext uri="{FF2B5EF4-FFF2-40B4-BE49-F238E27FC236}">
-                <a16:creationId xmlns:a16="http://schemas.microsoft.com/office/drawing/2014/main" id="{D2B3B765-49B6-D8E2-C6FC-66845B4BF776}"/>
+                <a16:creationId xmlns:a16="http://schemas.microsoft.com/office/drawing/2014/main" id="{F73FBF11-04E9-105D-4573-01011A24637A}"/>
               </a:ext>
             </a:extLst>
           </p:cNvPr>
@@ -4759,7 +4760,7 @@
           <p:cNvPr id="17" name="TextBox 16">
             <a:extLst>
               <a:ext uri="{FF2B5EF4-FFF2-40B4-BE49-F238E27FC236}">
-                <a16:creationId xmlns:a16="http://schemas.microsoft.com/office/drawing/2014/main" id="{7EC29AFA-0C56-62BC-81EB-2426323091A8}"/>
+                <a16:creationId xmlns:a16="http://schemas.microsoft.com/office/drawing/2014/main" id="{611102C1-AA31-DD99-E860-EC4159B1AAB8}"/>
               </a:ext>
             </a:extLst>
           </p:cNvPr>
@@ -4805,7 +4806,7 @@
           <p:cNvPr id="18" name="TextBox 17">
             <a:extLst>
               <a:ext uri="{FF2B5EF4-FFF2-40B4-BE49-F238E27FC236}">
-                <a16:creationId xmlns:a16="http://schemas.microsoft.com/office/drawing/2014/main" id="{8C31AEE3-1CA7-5203-0D7F-268DC9646426}"/>
+                <a16:creationId xmlns:a16="http://schemas.microsoft.com/office/drawing/2014/main" id="{D42B7944-D1F3-A8C0-BE14-F2EF1F2671CF}"/>
               </a:ext>
             </a:extLst>
           </p:cNvPr>
@@ -4851,7 +4852,7 @@
           <p:cNvPr id="19" name="Rectangle: Rounded Corners 18">
             <a:extLst>
               <a:ext uri="{FF2B5EF4-FFF2-40B4-BE49-F238E27FC236}">
-                <a16:creationId xmlns:a16="http://schemas.microsoft.com/office/drawing/2014/main" id="{0CCBFF4D-1D57-3E8D-0B17-BB88DABB1C82}"/>
+                <a16:creationId xmlns:a16="http://schemas.microsoft.com/office/drawing/2014/main" id="{BC28BBC0-443B-0534-A0A9-287158902240}"/>
               </a:ext>
             </a:extLst>
           </p:cNvPr>
@@ -4919,7 +4920,7 @@
           <p:cNvPr id="20" name="TextBox 19">
             <a:extLst>
               <a:ext uri="{FF2B5EF4-FFF2-40B4-BE49-F238E27FC236}">
-                <a16:creationId xmlns:a16="http://schemas.microsoft.com/office/drawing/2014/main" id="{A53DFD4A-6A39-53A0-497B-3AEEB203F8B9}"/>
+                <a16:creationId xmlns:a16="http://schemas.microsoft.com/office/drawing/2014/main" id="{DF78677F-2420-0B62-0038-3FBC3E628B4C}"/>
               </a:ext>
             </a:extLst>
           </p:cNvPr>
@@ -4963,7 +4964,851 @@
     </p:spTree>
     <p:extLst>
       <p:ext uri="{BB962C8B-B14F-4D97-AF65-F5344CB8AC3E}">
-        <p14:creationId xmlns:p14="http://schemas.microsoft.com/office/powerpoint/2010/main" val="618469313"/>
+        <p14:creationId xmlns:p14="http://schemas.microsoft.com/office/powerpoint/2010/main" val="3691323570"/>
+      </p:ext>
+    </p:extLst>
+  </p:cSld>
+  <p:clrMapOvr>
+    <a:masterClrMapping/>
+  </p:clrMapOvr>
+</p:sld>
+</file>
+
+<file path=ppt/slides/slide11.xml><?xml version="1.0" encoding="utf-8"?>
+<p:sld xmlns:a="http://schemas.openxmlformats.org/drawingml/2006/main" xmlns:r="http://schemas.openxmlformats.org/officeDocument/2006/relationships" xmlns:p="http://schemas.openxmlformats.org/presentationml/2006/main">
+  <p:cSld>
+    <p:spTree>
+      <p:nvGrpSpPr>
+        <p:cNvPr id="1" name=""/>
+        <p:cNvGrpSpPr/>
+        <p:nvPr/>
+      </p:nvGrpSpPr>
+      <p:grpSpPr>
+        <a:xfrm>
+          <a:off x="0" y="0"/>
+          <a:ext cx="0" cy="0"/>
+          <a:chOff x="0" y="0"/>
+          <a:chExt cx="0" cy="0"/>
+        </a:xfrm>
+      </p:grpSpPr>
+      <p:sp>
+        <p:nvSpPr>
+          <p:cNvPr id="2" name="TextBox 1">
+            <a:extLst>
+              <a:ext uri="{FF2B5EF4-FFF2-40B4-BE49-F238E27FC236}">
+                <a16:creationId xmlns:a16="http://schemas.microsoft.com/office/drawing/2014/main" id="{B42A3DBA-7CBD-8AAD-4806-C08752929F06}"/>
+              </a:ext>
+            </a:extLst>
+          </p:cNvPr>
+          <p:cNvSpPr txBox="1"/>
+          <p:nvPr/>
+        </p:nvSpPr>
+        <p:spPr>
+          <a:xfrm>
+            <a:off x="685800" y="381000"/>
+            <a:ext cx="2540000" cy="230832"/>
+          </a:xfrm>
+          <a:prstGeom prst="rect">
+            <a:avLst/>
+          </a:prstGeom>
+          <a:noFill/>
+        </p:spPr>
+        <p:txBody>
+          <a:bodyPr vert="horz" wrap="square" lIns="0" tIns="0" rIns="0" bIns="0" rtlCol="0">
+            <a:spAutoFit/>
+          </a:bodyPr>
+          <a:lstStyle/>
+          <a:p>
+            <a:r>
+              <a:rPr lang="en-US" sz="1500" b="1">
+                <a:solidFill>
+                  <a:srgbClr val="16C6B7"/>
+                </a:solidFill>
+                <a:latin typeface="Aptos" panose="020B0004020202020204" pitchFamily="34" charset="0"/>
+              </a:rPr>
+              <a:t>GEOWATCH AI</a:t>
+            </a:r>
+            <a:endParaRPr lang="ru-KZ" sz="1500" b="1">
+              <a:solidFill>
+                <a:srgbClr val="16C6B7"/>
+              </a:solidFill>
+              <a:latin typeface="Aptos" panose="020B0004020202020204" pitchFamily="34" charset="0"/>
+            </a:endParaRPr>
+          </a:p>
+        </p:txBody>
+      </p:sp>
+      <p:sp>
+        <p:nvSpPr>
+          <p:cNvPr id="3" name="TextBox 2">
+            <a:extLst>
+              <a:ext uri="{FF2B5EF4-FFF2-40B4-BE49-F238E27FC236}">
+                <a16:creationId xmlns:a16="http://schemas.microsoft.com/office/drawing/2014/main" id="{BC61FF85-0ED6-58AB-86EF-D4740A1AA3AD}"/>
+              </a:ext>
+            </a:extLst>
+          </p:cNvPr>
+          <p:cNvSpPr txBox="1"/>
+          <p:nvPr/>
+        </p:nvSpPr>
+        <p:spPr>
+          <a:xfrm>
+            <a:off x="685800" y="1041400"/>
+            <a:ext cx="13970000" cy="430887"/>
+          </a:xfrm>
+          <a:prstGeom prst="rect">
+            <a:avLst/>
+          </a:prstGeom>
+          <a:noFill/>
+        </p:spPr>
+        <p:txBody>
+          <a:bodyPr vert="horz" wrap="square" lIns="0" tIns="0" rIns="0" bIns="0" rtlCol="0">
+            <a:spAutoFit/>
+          </a:bodyPr>
+          <a:lstStyle/>
+          <a:p>
+            <a:r>
+              <a:rPr lang="ru-KZ" sz="2800" b="1">
+                <a:solidFill>
+                  <a:srgbClr val="102639"/>
+                </a:solidFill>
+                <a:latin typeface="Aptos" panose="020B0004020202020204" pitchFamily="34" charset="0"/>
+              </a:rPr>
+              <a:t>Проверки и тестовое </a:t>
+            </a:r>
+            <a:r>
+              <a:rPr lang="en-US" sz="2800" b="1">
+                <a:solidFill>
+                  <a:srgbClr val="102639"/>
+                </a:solidFill>
+                <a:latin typeface="Aptos" panose="020B0004020202020204" pitchFamily="34" charset="0"/>
+              </a:rPr>
+              <a:t>evidence</a:t>
+            </a:r>
+            <a:endParaRPr lang="ru-KZ" sz="2800" b="1">
+              <a:solidFill>
+                <a:srgbClr val="102639"/>
+              </a:solidFill>
+              <a:latin typeface="Aptos" panose="020B0004020202020204" pitchFamily="34" charset="0"/>
+            </a:endParaRPr>
+          </a:p>
+        </p:txBody>
+      </p:sp>
+      <p:sp>
+        <p:nvSpPr>
+          <p:cNvPr id="4" name="TextBox 3">
+            <a:extLst>
+              <a:ext uri="{FF2B5EF4-FFF2-40B4-BE49-F238E27FC236}">
+                <a16:creationId xmlns:a16="http://schemas.microsoft.com/office/drawing/2014/main" id="{0F8EDC6E-BA3B-9FEE-9B1A-6D0549C7E37F}"/>
+              </a:ext>
+            </a:extLst>
+          </p:cNvPr>
+          <p:cNvSpPr txBox="1"/>
+          <p:nvPr/>
+        </p:nvSpPr>
+        <p:spPr>
+          <a:xfrm>
+            <a:off x="14909800" y="406400"/>
+            <a:ext cx="660400" cy="207749"/>
+          </a:xfrm>
+          <a:prstGeom prst="rect">
+            <a:avLst/>
+          </a:prstGeom>
+          <a:noFill/>
+        </p:spPr>
+        <p:txBody>
+          <a:bodyPr vert="horz" wrap="square" lIns="0" tIns="0" rIns="0" bIns="0" rtlCol="0">
+            <a:spAutoFit/>
+          </a:bodyPr>
+          <a:lstStyle/>
+          <a:p>
+            <a:r>
+              <a:rPr lang="ru-KZ" sz="1300" b="1">
+                <a:solidFill>
+                  <a:srgbClr val="526778"/>
+                </a:solidFill>
+                <a:latin typeface="Aptos" panose="020B0004020202020204" pitchFamily="34" charset="0"/>
+              </a:rPr>
+              <a:t>11</a:t>
+            </a:r>
+          </a:p>
+        </p:txBody>
+      </p:sp>
+      <p:cxnSp>
+        <p:nvCxnSpPr>
+          <p:cNvPr id="5" name="Straight Connector 4">
+            <a:extLst>
+              <a:ext uri="{FF2B5EF4-FFF2-40B4-BE49-F238E27FC236}">
+                <a16:creationId xmlns:a16="http://schemas.microsoft.com/office/drawing/2014/main" id="{C66A0570-FDF8-5802-2442-EFC842DF653B}"/>
+              </a:ext>
+            </a:extLst>
+          </p:cNvPr>
+          <p:cNvCxnSpPr/>
+          <p:nvPr/>
+        </p:nvCxnSpPr>
+        <p:spPr>
+          <a:xfrm>
+            <a:off x="685800" y="1841500"/>
+            <a:ext cx="14871700" cy="0"/>
+          </a:xfrm>
+          <a:prstGeom prst="line">
+            <a:avLst/>
+          </a:prstGeom>
+          <a:ln w="12700">
+            <a:solidFill>
+              <a:srgbClr val="DAE2ED"/>
+            </a:solidFill>
+          </a:ln>
+        </p:spPr>
+        <p:style>
+          <a:lnRef idx="2">
+            <a:schemeClr val="accent1"/>
+          </a:lnRef>
+          <a:fillRef idx="0">
+            <a:schemeClr val="accent1"/>
+          </a:fillRef>
+          <a:effectRef idx="1">
+            <a:schemeClr val="accent1"/>
+          </a:effectRef>
+          <a:fontRef idx="minor">
+            <a:schemeClr val="tx1"/>
+          </a:fontRef>
+        </p:style>
+      </p:cxnSp>
+      <p:sp>
+        <p:nvSpPr>
+          <p:cNvPr id="6" name="TextBox 5">
+            <a:extLst>
+              <a:ext uri="{FF2B5EF4-FFF2-40B4-BE49-F238E27FC236}">
+                <a16:creationId xmlns:a16="http://schemas.microsoft.com/office/drawing/2014/main" id="{8887F121-47AA-3FEE-C6FC-621F1D83A138}"/>
+              </a:ext>
+            </a:extLst>
+          </p:cNvPr>
+          <p:cNvSpPr txBox="1"/>
+          <p:nvPr/>
+        </p:nvSpPr>
+        <p:spPr>
+          <a:xfrm>
+            <a:off x="685800" y="2260600"/>
+            <a:ext cx="13208000" cy="677108"/>
+          </a:xfrm>
+          <a:prstGeom prst="rect">
+            <a:avLst/>
+          </a:prstGeom>
+          <a:noFill/>
+        </p:spPr>
+        <p:txBody>
+          <a:bodyPr vert="horz" wrap="square" lIns="0" tIns="0" rIns="0" bIns="0" rtlCol="0">
+            <a:spAutoFit/>
+          </a:bodyPr>
+          <a:lstStyle/>
+          <a:p>
+            <a:r>
+              <a:rPr lang="ru-RU" sz="2200" b="1">
+                <a:solidFill>
+                  <a:srgbClr val="102639"/>
+                </a:solidFill>
+                <a:latin typeface="Aptos" panose="020B0004020202020204" pitchFamily="34" charset="0"/>
+              </a:rPr>
+              <a:t>Тестовый контур покрывает критичные пользовательские сценарии и правила безопасной аналитики.</a:t>
+            </a:r>
+            <a:endParaRPr lang="ru-KZ" sz="2200" b="1">
+              <a:solidFill>
+                <a:srgbClr val="102639"/>
+              </a:solidFill>
+              <a:latin typeface="Aptos" panose="020B0004020202020204" pitchFamily="34" charset="0"/>
+            </a:endParaRPr>
+          </a:p>
+        </p:txBody>
+      </p:sp>
+      <p:sp>
+        <p:nvSpPr>
+          <p:cNvPr id="7" name="Rectangle: Rounded Corners 6">
+            <a:extLst>
+              <a:ext uri="{FF2B5EF4-FFF2-40B4-BE49-F238E27FC236}">
+                <a16:creationId xmlns:a16="http://schemas.microsoft.com/office/drawing/2014/main" id="{74EBE812-AC86-5E3A-5BD9-CD4969E4082D}"/>
+              </a:ext>
+            </a:extLst>
+          </p:cNvPr>
+          <p:cNvSpPr/>
+          <p:nvPr/>
+        </p:nvSpPr>
+        <p:spPr>
+          <a:xfrm>
+            <a:off x="685800" y="3048000"/>
+            <a:ext cx="6350000" cy="4394200"/>
+          </a:xfrm>
+          <a:prstGeom prst="roundRect">
+            <a:avLst/>
+          </a:prstGeom>
+          <a:solidFill>
+            <a:srgbClr val="FFFFFF"/>
+          </a:solidFill>
+          <a:ln w="19050" cap="flat" cmpd="sng" algn="ctr">
+            <a:noFill/>
+            <a:prstDash val="solid"/>
+            <a:miter lim="800000"/>
+          </a:ln>
+          <a:effectLst>
+            <a:outerShdw blurRad="63500" dist="37357" dir="2700000" rotWithShape="0">
+              <a:srgbClr val="CAD4E2">
+                <a:alpha val="25000"/>
+              </a:srgbClr>
+            </a:outerShdw>
+          </a:effectLst>
+          <a:extLst>
+            <a:ext uri="{91240B29-F687-4F45-9708-019B960494DF}">
+              <a14:hiddenLine xmlns:a14="http://schemas.microsoft.com/office/drawing/2010/main" w="19050" cap="flat" cmpd="sng" algn="ctr">
+                <a:solidFill>
+                  <a:schemeClr val="accent1">
+                    <a:shade val="15000"/>
+                  </a:schemeClr>
+                </a:solidFill>
+                <a:prstDash val="solid"/>
+                <a:miter lim="800000"/>
+              </a14:hiddenLine>
+            </a:ext>
+          </a:extLst>
+        </p:spPr>
+        <p:style>
+          <a:lnRef idx="2">
+            <a:schemeClr val="accent1">
+              <a:shade val="15000"/>
+            </a:schemeClr>
+          </a:lnRef>
+          <a:fillRef idx="1">
+            <a:schemeClr val="accent1"/>
+          </a:fillRef>
+          <a:effectRef idx="0">
+            <a:schemeClr val="accent1"/>
+          </a:effectRef>
+          <a:fontRef idx="minor">
+            <a:schemeClr val="lt1"/>
+          </a:fontRef>
+        </p:style>
+        <p:txBody>
+          <a:bodyPr rtlCol="0" anchor="ctr"/>
+          <a:lstStyle/>
+          <a:p>
+            <a:pPr algn="ctr"/>
+            <a:endParaRPr lang="ru-KZ"/>
+          </a:p>
+        </p:txBody>
+      </p:sp>
+      <p:sp>
+        <p:nvSpPr>
+          <p:cNvPr id="8" name="TextBox 7">
+            <a:extLst>
+              <a:ext uri="{FF2B5EF4-FFF2-40B4-BE49-F238E27FC236}">
+                <a16:creationId xmlns:a16="http://schemas.microsoft.com/office/drawing/2014/main" id="{F2A62B36-4425-7CFD-C088-4AEDA1B0F0C3}"/>
+              </a:ext>
+            </a:extLst>
+          </p:cNvPr>
+          <p:cNvSpPr txBox="1"/>
+          <p:nvPr/>
+        </p:nvSpPr>
+        <p:spPr>
+          <a:xfrm>
+            <a:off x="1066800" y="3454400"/>
+            <a:ext cx="4064000" cy="323165"/>
+          </a:xfrm>
+          <a:prstGeom prst="rect">
+            <a:avLst/>
+          </a:prstGeom>
+          <a:noFill/>
+        </p:spPr>
+        <p:txBody>
+          <a:bodyPr vert="horz" wrap="square" lIns="0" tIns="0" rIns="0" bIns="0" rtlCol="0">
+            <a:spAutoFit/>
+          </a:bodyPr>
+          <a:lstStyle/>
+          <a:p>
+            <a:r>
+              <a:rPr lang="ru-KZ" sz="2100" b="1">
+                <a:solidFill>
+                  <a:srgbClr val="102639"/>
+                </a:solidFill>
+                <a:latin typeface="Aptos" panose="020B0004020202020204" pitchFamily="34" charset="0"/>
+              </a:rPr>
+              <a:t>Зафиксированная проверка</a:t>
+            </a:r>
+          </a:p>
+        </p:txBody>
+      </p:sp>
+      <p:sp>
+        <p:nvSpPr>
+          <p:cNvPr id="9" name="Rectangle: Rounded Corners 8">
+            <a:extLst>
+              <a:ext uri="{FF2B5EF4-FFF2-40B4-BE49-F238E27FC236}">
+                <a16:creationId xmlns:a16="http://schemas.microsoft.com/office/drawing/2014/main" id="{1E866054-9EA8-3E49-FD3D-15D41900FD60}"/>
+              </a:ext>
+            </a:extLst>
+          </p:cNvPr>
+          <p:cNvSpPr/>
+          <p:nvPr/>
+        </p:nvSpPr>
+        <p:spPr>
+          <a:xfrm>
+            <a:off x="1066800" y="4089400"/>
+            <a:ext cx="5562600" cy="2057400"/>
+          </a:xfrm>
+          <a:prstGeom prst="roundRect">
+            <a:avLst/>
+          </a:prstGeom>
+          <a:solidFill>
+            <a:srgbClr val="061827"/>
+          </a:solidFill>
+          <a:ln w="19050" cap="flat" cmpd="sng" algn="ctr">
+            <a:noFill/>
+            <a:prstDash val="solid"/>
+            <a:miter lim="800000"/>
+          </a:ln>
+          <a:effectLst/>
+          <a:extLst>
+            <a:ext uri="{91240B29-F687-4F45-9708-019B960494DF}">
+              <a14:hiddenLine xmlns:a14="http://schemas.microsoft.com/office/drawing/2010/main" w="19050" cap="flat" cmpd="sng" algn="ctr">
+                <a:solidFill>
+                  <a:schemeClr val="accent1">
+                    <a:shade val="15000"/>
+                  </a:schemeClr>
+                </a:solidFill>
+                <a:prstDash val="solid"/>
+                <a:miter lim="800000"/>
+              </a14:hiddenLine>
+            </a:ext>
+          </a:extLst>
+        </p:spPr>
+        <p:style>
+          <a:lnRef idx="2">
+            <a:schemeClr val="accent1">
+              <a:shade val="15000"/>
+            </a:schemeClr>
+          </a:lnRef>
+          <a:fillRef idx="1">
+            <a:schemeClr val="accent1"/>
+          </a:fillRef>
+          <a:effectRef idx="0">
+            <a:schemeClr val="accent1"/>
+          </a:effectRef>
+          <a:fontRef idx="minor">
+            <a:schemeClr val="lt1"/>
+          </a:fontRef>
+        </p:style>
+        <p:txBody>
+          <a:bodyPr rtlCol="0" anchor="ctr"/>
+          <a:lstStyle/>
+          <a:p>
+            <a:pPr algn="ctr"/>
+            <a:endParaRPr lang="ru-KZ"/>
+          </a:p>
+        </p:txBody>
+      </p:sp>
+      <p:sp>
+        <p:nvSpPr>
+          <p:cNvPr id="10" name="TextBox 9">
+            <a:extLst>
+              <a:ext uri="{FF2B5EF4-FFF2-40B4-BE49-F238E27FC236}">
+                <a16:creationId xmlns:a16="http://schemas.microsoft.com/office/drawing/2014/main" id="{357C7215-AE07-963F-F07C-1161ED8F7B6F}"/>
+              </a:ext>
+            </a:extLst>
+          </p:cNvPr>
+          <p:cNvSpPr txBox="1"/>
+          <p:nvPr/>
+        </p:nvSpPr>
+        <p:spPr>
+          <a:xfrm>
+            <a:off x="1371600" y="4445000"/>
+            <a:ext cx="4953000" cy="984885"/>
+          </a:xfrm>
+          <a:prstGeom prst="rect">
+            <a:avLst/>
+          </a:prstGeom>
+          <a:noFill/>
+        </p:spPr>
+        <p:txBody>
+          <a:bodyPr vert="horz" wrap="square" lIns="0" tIns="0" rIns="0" bIns="0" rtlCol="0">
+            <a:spAutoFit/>
+          </a:bodyPr>
+          <a:lstStyle/>
+          <a:p>
+            <a:r>
+              <a:rPr lang="en-US" sz="1600">
+                <a:solidFill>
+                  <a:srgbClr val="FFFFFF"/>
+                </a:solidFill>
+                <a:latin typeface="Aptos" panose="020B0004020202020204" pitchFamily="34" charset="0"/>
+              </a:rPr>
+              <a:t>PS&gt; pytest -q
+........................................
+........................................
+95 passed, 2 warnings</a:t>
+            </a:r>
+            <a:endParaRPr lang="ru-KZ" sz="1600">
+              <a:solidFill>
+                <a:srgbClr val="FFFFFF"/>
+              </a:solidFill>
+              <a:latin typeface="Aptos" panose="020B0004020202020204" pitchFamily="34" charset="0"/>
+            </a:endParaRPr>
+          </a:p>
+        </p:txBody>
+      </p:sp>
+      <p:sp>
+        <p:nvSpPr>
+          <p:cNvPr id="11" name="TextBox 10">
+            <a:extLst>
+              <a:ext uri="{FF2B5EF4-FFF2-40B4-BE49-F238E27FC236}">
+                <a16:creationId xmlns:a16="http://schemas.microsoft.com/office/drawing/2014/main" id="{B5622893-8C27-419A-BEA7-9454553B5306}"/>
+              </a:ext>
+            </a:extLst>
+          </p:cNvPr>
+          <p:cNvSpPr txBox="1"/>
+          <p:nvPr/>
+        </p:nvSpPr>
+        <p:spPr>
+          <a:xfrm>
+            <a:off x="1066800" y="6489700"/>
+            <a:ext cx="5232400" cy="646331"/>
+          </a:xfrm>
+          <a:prstGeom prst="rect">
+            <a:avLst/>
+          </a:prstGeom>
+          <a:noFill/>
+        </p:spPr>
+        <p:txBody>
+          <a:bodyPr vert="horz" wrap="square" lIns="0" tIns="0" rIns="0" bIns="0" rtlCol="0">
+            <a:spAutoFit/>
+          </a:bodyPr>
+          <a:lstStyle/>
+          <a:p>
+            <a:r>
+              <a:rPr lang="ru-RU" sz="1400">
+                <a:solidFill>
+                  <a:srgbClr val="526778"/>
+                </a:solidFill>
+                <a:latin typeface="Aptos" panose="020B0004020202020204" pitchFamily="34" charset="0"/>
+              </a:rPr>
+              <a:t>Это зафиксированный локальный прогон из docs/submission_readiness.md; не новый запуск на машине Demo Day.</a:t>
+            </a:r>
+            <a:endParaRPr lang="ru-KZ" sz="1400">
+              <a:solidFill>
+                <a:srgbClr val="526778"/>
+              </a:solidFill>
+              <a:latin typeface="Aptos" panose="020B0004020202020204" pitchFamily="34" charset="0"/>
+            </a:endParaRPr>
+          </a:p>
+        </p:txBody>
+      </p:sp>
+      <p:sp>
+        <p:nvSpPr>
+          <p:cNvPr id="12" name="Rectangle: Rounded Corners 11">
+            <a:extLst>
+              <a:ext uri="{FF2B5EF4-FFF2-40B4-BE49-F238E27FC236}">
+                <a16:creationId xmlns:a16="http://schemas.microsoft.com/office/drawing/2014/main" id="{AE4C04FD-F8E8-F565-235F-12A88ED22AEB}"/>
+              </a:ext>
+            </a:extLst>
+          </p:cNvPr>
+          <p:cNvSpPr/>
+          <p:nvPr/>
+        </p:nvSpPr>
+        <p:spPr>
+          <a:xfrm>
+            <a:off x="7747000" y="3048000"/>
+            <a:ext cx="7823200" cy="4394200"/>
+          </a:xfrm>
+          <a:prstGeom prst="roundRect">
+            <a:avLst/>
+          </a:prstGeom>
+          <a:solidFill>
+            <a:srgbClr val="FFFFFF"/>
+          </a:solidFill>
+          <a:ln w="19050" cap="flat" cmpd="sng" algn="ctr">
+            <a:noFill/>
+            <a:prstDash val="solid"/>
+            <a:miter lim="800000"/>
+          </a:ln>
+          <a:effectLst>
+            <a:outerShdw blurRad="63500" dist="37357" dir="2700000" rotWithShape="0">
+              <a:srgbClr val="CAD4E2">
+                <a:alpha val="25000"/>
+              </a:srgbClr>
+            </a:outerShdw>
+          </a:effectLst>
+          <a:extLst>
+            <a:ext uri="{91240B29-F687-4F45-9708-019B960494DF}">
+              <a14:hiddenLine xmlns:a14="http://schemas.microsoft.com/office/drawing/2010/main" w="19050" cap="flat" cmpd="sng" algn="ctr">
+                <a:solidFill>
+                  <a:schemeClr val="accent1">
+                    <a:shade val="15000"/>
+                  </a:schemeClr>
+                </a:solidFill>
+                <a:prstDash val="solid"/>
+                <a:miter lim="800000"/>
+              </a14:hiddenLine>
+            </a:ext>
+          </a:extLst>
+        </p:spPr>
+        <p:style>
+          <a:lnRef idx="2">
+            <a:schemeClr val="accent1">
+              <a:shade val="15000"/>
+            </a:schemeClr>
+          </a:lnRef>
+          <a:fillRef idx="1">
+            <a:schemeClr val="accent1"/>
+          </a:fillRef>
+          <a:effectRef idx="0">
+            <a:schemeClr val="accent1"/>
+          </a:effectRef>
+          <a:fontRef idx="minor">
+            <a:schemeClr val="lt1"/>
+          </a:fontRef>
+        </p:style>
+        <p:txBody>
+          <a:bodyPr rtlCol="0" anchor="ctr"/>
+          <a:lstStyle/>
+          <a:p>
+            <a:pPr algn="ctr"/>
+            <a:endParaRPr lang="ru-KZ"/>
+          </a:p>
+        </p:txBody>
+      </p:sp>
+      <p:sp>
+        <p:nvSpPr>
+          <p:cNvPr id="13" name="TextBox 12">
+            <a:extLst>
+              <a:ext uri="{FF2B5EF4-FFF2-40B4-BE49-F238E27FC236}">
+                <a16:creationId xmlns:a16="http://schemas.microsoft.com/office/drawing/2014/main" id="{57FEF510-3D30-CEF3-7F22-E15C1F612935}"/>
+              </a:ext>
+            </a:extLst>
+          </p:cNvPr>
+          <p:cNvSpPr txBox="1"/>
+          <p:nvPr/>
+        </p:nvSpPr>
+        <p:spPr>
+          <a:xfrm>
+            <a:off x="8128000" y="3454400"/>
+            <a:ext cx="5969000" cy="323165"/>
+          </a:xfrm>
+          <a:prstGeom prst="rect">
+            <a:avLst/>
+          </a:prstGeom>
+          <a:noFill/>
+        </p:spPr>
+        <p:txBody>
+          <a:bodyPr vert="horz" wrap="square" lIns="0" tIns="0" rIns="0" bIns="0" rtlCol="0">
+            <a:spAutoFit/>
+          </a:bodyPr>
+          <a:lstStyle/>
+          <a:p>
+            <a:r>
+              <a:rPr lang="ru-RU" sz="2100" b="1">
+                <a:solidFill>
+                  <a:srgbClr val="102639"/>
+                </a:solidFill>
+                <a:latin typeface="Aptos" panose="020B0004020202020204" pitchFamily="34" charset="0"/>
+              </a:rPr>
+              <a:t>Что покрывают реальные модули tests/</a:t>
+            </a:r>
+            <a:endParaRPr lang="ru-KZ" sz="2100" b="1">
+              <a:solidFill>
+                <a:srgbClr val="102639"/>
+              </a:solidFill>
+              <a:latin typeface="Aptos" panose="020B0004020202020204" pitchFamily="34" charset="0"/>
+            </a:endParaRPr>
+          </a:p>
+        </p:txBody>
+      </p:sp>
+      <p:sp>
+        <p:nvSpPr>
+          <p:cNvPr id="14" name="TextBox 13">
+            <a:extLst>
+              <a:ext uri="{FF2B5EF4-FFF2-40B4-BE49-F238E27FC236}">
+                <a16:creationId xmlns:a16="http://schemas.microsoft.com/office/drawing/2014/main" id="{9AF4EC53-D52D-E1D5-D583-603A6AF471E3}"/>
+              </a:ext>
+            </a:extLst>
+          </p:cNvPr>
+          <p:cNvSpPr txBox="1"/>
+          <p:nvPr/>
+        </p:nvSpPr>
+        <p:spPr>
+          <a:xfrm>
+            <a:off x="8128000" y="4064000"/>
+            <a:ext cx="6604000" cy="1846659"/>
+          </a:xfrm>
+          <a:prstGeom prst="rect">
+            <a:avLst/>
+          </a:prstGeom>
+          <a:noFill/>
+        </p:spPr>
+        <p:txBody>
+          <a:bodyPr vert="horz" wrap="square" lIns="0" tIns="0" rIns="0" bIns="0" rtlCol="0">
+            <a:spAutoFit/>
+          </a:bodyPr>
+          <a:lstStyle/>
+          <a:p>
+            <a:r>
+              <a:rPr lang="en-US" sz="1500">
+                <a:solidFill>
+                  <a:srgbClr val="526778"/>
+                </a:solidFill>
+                <a:latin typeface="Aptos" panose="020B0004020202020204" pitchFamily="34" charset="0"/>
+              </a:rPr>
+              <a:t>API </a:t>
+            </a:r>
+            <a:r>
+              <a:rPr lang="ru-KZ" sz="1500">
+                <a:solidFill>
+                  <a:srgbClr val="526778"/>
+                </a:solidFill>
+                <a:latin typeface="Aptos" panose="020B0004020202020204" pitchFamily="34" charset="0"/>
+              </a:rPr>
+              <a:t>и пользовательский </a:t>
+            </a:r>
+            <a:r>
+              <a:rPr lang="en-US" sz="1500">
+                <a:solidFill>
+                  <a:srgbClr val="526778"/>
+                </a:solidFill>
+                <a:latin typeface="Aptos" panose="020B0004020202020204" pitchFamily="34" charset="0"/>
+              </a:rPr>
+              <a:t>smoke-flow
+  test_api_smoke.py, test_image_store.py, test_job_queue.py
+Temporal-</a:t>
+            </a:r>
+            <a:r>
+              <a:rPr lang="ru-KZ" sz="1500">
+                <a:solidFill>
+                  <a:srgbClr val="526778"/>
+                </a:solidFill>
+                <a:latin typeface="Aptos" panose="020B0004020202020204" pitchFamily="34" charset="0"/>
+              </a:rPr>
+              <a:t>логика и безопасность пары
+  </a:t>
+            </a:r>
+            <a:r>
+              <a:rPr lang="en-US" sz="1500">
+                <a:solidFill>
+                  <a:srgbClr val="526778"/>
+                </a:solidFill>
+                <a:latin typeface="Aptos" panose="020B0004020202020204" pitchFamily="34" charset="0"/>
+              </a:rPr>
+              <a:t>test_temporal_ui.py, test_pair_validation.py, test_change_detection.py
+Review, </a:t>
+            </a:r>
+            <a:r>
+              <a:rPr lang="ru-KZ" sz="1500">
+                <a:solidFill>
+                  <a:srgbClr val="526778"/>
+                </a:solidFill>
+                <a:latin typeface="Aptos" panose="020B0004020202020204" pitchFamily="34" charset="0"/>
+              </a:rPr>
+              <a:t>кейсы и выгрузки
+  </a:t>
+            </a:r>
+            <a:r>
+              <a:rPr lang="en-US" sz="1500">
+                <a:solidFill>
+                  <a:srgbClr val="526778"/>
+                </a:solidFill>
+                <a:latin typeface="Aptos" panose="020B0004020202020204" pitchFamily="34" charset="0"/>
+              </a:rPr>
+              <a:t>test_review.py, test_cases.py, test_case_export.py
+</a:t>
+            </a:r>
+            <a:r>
+              <a:rPr lang="ru-KZ" sz="1500">
+                <a:solidFill>
+                  <a:srgbClr val="526778"/>
+                </a:solidFill>
+                <a:latin typeface="Aptos" panose="020B0004020202020204" pitchFamily="34" charset="0"/>
+              </a:rPr>
+              <a:t>Модель, </a:t>
+            </a:r>
+            <a:r>
+              <a:rPr lang="en-US" sz="1500">
+                <a:solidFill>
+                  <a:srgbClr val="526778"/>
+                </a:solidFill>
+                <a:latin typeface="Aptos" panose="020B0004020202020204" pitchFamily="34" charset="0"/>
+              </a:rPr>
+              <a:t>evidence </a:t>
+            </a:r>
+            <a:r>
+              <a:rPr lang="ru-KZ" sz="1500">
+                <a:solidFill>
+                  <a:srgbClr val="526778"/>
+                </a:solidFill>
+                <a:latin typeface="Aptos" panose="020B0004020202020204" pitchFamily="34" charset="0"/>
+              </a:rPr>
+              <a:t>и </a:t>
+            </a:r>
+            <a:r>
+              <a:rPr lang="en-US" sz="1500">
+                <a:solidFill>
+                  <a:srgbClr val="526778"/>
+                </a:solidFill>
+                <a:latin typeface="Aptos" panose="020B0004020202020204" pitchFamily="34" charset="0"/>
+              </a:rPr>
+              <a:t>quality gates
+  test_model_audit.py, test_model_evidence.py, test_image_quality.py</a:t>
+            </a:r>
+            <a:endParaRPr lang="ru-KZ" sz="1500">
+              <a:solidFill>
+                <a:srgbClr val="526778"/>
+              </a:solidFill>
+              <a:latin typeface="Aptos" panose="020B0004020202020204" pitchFamily="34" charset="0"/>
+            </a:endParaRPr>
+          </a:p>
+        </p:txBody>
+      </p:sp>
+      <p:sp>
+        <p:nvSpPr>
+          <p:cNvPr id="15" name="TextBox 14">
+            <a:extLst>
+              <a:ext uri="{FF2B5EF4-FFF2-40B4-BE49-F238E27FC236}">
+                <a16:creationId xmlns:a16="http://schemas.microsoft.com/office/drawing/2014/main" id="{CB5F38E3-E322-7C89-6F35-E1C3CD3D1360}"/>
+              </a:ext>
+            </a:extLst>
+          </p:cNvPr>
+          <p:cNvSpPr txBox="1"/>
+          <p:nvPr/>
+        </p:nvSpPr>
+        <p:spPr>
+          <a:xfrm>
+            <a:off x="685800" y="8001000"/>
+            <a:ext cx="14097000" cy="246221"/>
+          </a:xfrm>
+          <a:prstGeom prst="rect">
+            <a:avLst/>
+          </a:prstGeom>
+          <a:noFill/>
+        </p:spPr>
+        <p:txBody>
+          <a:bodyPr vert="horz" wrap="square" lIns="0" tIns="0" rIns="0" bIns="0" rtlCol="0">
+            <a:spAutoFit/>
+          </a:bodyPr>
+          <a:lstStyle/>
+          <a:p>
+            <a:r>
+              <a:rPr lang="ru-RU" sz="1600" b="1">
+                <a:solidFill>
+                  <a:srgbClr val="16C6B7"/>
+                </a:solidFill>
+                <a:latin typeface="Aptos" panose="020B0004020202020204" pitchFamily="34" charset="0"/>
+              </a:rPr>
+              <a:t>Повторный запуск перед показом: python -m pytest -q  •  результат прикладывается к комплекту как актуальный лог.</a:t>
+            </a:r>
+            <a:endParaRPr lang="ru-KZ" sz="1600" b="1">
+              <a:solidFill>
+                <a:srgbClr val="16C6B7"/>
+              </a:solidFill>
+              <a:latin typeface="Aptos" panose="020B0004020202020204" pitchFamily="34" charset="0"/>
+            </a:endParaRPr>
+          </a:p>
+        </p:txBody>
+      </p:sp>
+    </p:spTree>
+    <p:extLst>
+      <p:ext uri="{BB962C8B-B14F-4D97-AF65-F5344CB8AC3E}">
+        <p14:creationId xmlns:p14="http://schemas.microsoft.com/office/powerpoint/2010/main" val="363135939"/>
       </p:ext>
     </p:extLst>
   </p:cSld>
@@ -4995,7 +5840,7 @@
           <p:cNvPr id="2" name="TextBox 1">
             <a:extLst>
               <a:ext uri="{FF2B5EF4-FFF2-40B4-BE49-F238E27FC236}">
-                <a16:creationId xmlns:a16="http://schemas.microsoft.com/office/drawing/2014/main" id="{5E3CFAED-0C9F-FD25-7C55-8F1C6014B513}"/>
+                <a16:creationId xmlns:a16="http://schemas.microsoft.com/office/drawing/2014/main" id="{91273B1A-61B4-DDEB-D8A9-766EE2BFB02C}"/>
               </a:ext>
             </a:extLst>
           </p:cNvPr>
@@ -5041,7 +5886,7 @@
           <p:cNvPr id="3" name="TextBox 2">
             <a:extLst>
               <a:ext uri="{FF2B5EF4-FFF2-40B4-BE49-F238E27FC236}">
-                <a16:creationId xmlns:a16="http://schemas.microsoft.com/office/drawing/2014/main" id="{A6C793B4-6CD3-95D0-1650-6C24A55E2961}"/>
+                <a16:creationId xmlns:a16="http://schemas.microsoft.com/office/drawing/2014/main" id="{6AE83690-2BEE-B08F-4D1E-54FCD5615C89}"/>
               </a:ext>
             </a:extLst>
           </p:cNvPr>
@@ -5081,7 +5926,7 @@
           <p:cNvPr id="4" name="TextBox 3">
             <a:extLst>
               <a:ext uri="{FF2B5EF4-FFF2-40B4-BE49-F238E27FC236}">
-                <a16:creationId xmlns:a16="http://schemas.microsoft.com/office/drawing/2014/main" id="{1622A20B-8661-8E15-3AF2-A67B561555ED}"/>
+                <a16:creationId xmlns:a16="http://schemas.microsoft.com/office/drawing/2014/main" id="{27CB389F-7162-670F-4CD0-CAB4BDFDAA14}"/>
               </a:ext>
             </a:extLst>
           </p:cNvPr>
@@ -5121,7 +5966,7 @@
           <p:cNvPr id="5" name="Straight Connector 4">
             <a:extLst>
               <a:ext uri="{FF2B5EF4-FFF2-40B4-BE49-F238E27FC236}">
-                <a16:creationId xmlns:a16="http://schemas.microsoft.com/office/drawing/2014/main" id="{A91EDEF2-96C1-AC0D-8B83-7C4BB0AB0F9E}"/>
+                <a16:creationId xmlns:a16="http://schemas.microsoft.com/office/drawing/2014/main" id="{FBDC578F-A862-3BAF-D8EA-37D98969E6F8}"/>
               </a:ext>
             </a:extLst>
           </p:cNvPr>
@@ -5162,7 +6007,7 @@
           <p:cNvPr id="6" name="TextBox 5">
             <a:extLst>
               <a:ext uri="{FF2B5EF4-FFF2-40B4-BE49-F238E27FC236}">
-                <a16:creationId xmlns:a16="http://schemas.microsoft.com/office/drawing/2014/main" id="{26A69736-7A8E-4205-C1C6-11B2E57D8E3C}"/>
+                <a16:creationId xmlns:a16="http://schemas.microsoft.com/office/drawing/2014/main" id="{A67D876C-1396-8F46-785B-3382BC0F3C58}"/>
               </a:ext>
             </a:extLst>
           </p:cNvPr>
@@ -5208,7 +6053,7 @@
           <p:cNvPr id="7" name="Rectangle: Rounded Corners 6">
             <a:extLst>
               <a:ext uri="{FF2B5EF4-FFF2-40B4-BE49-F238E27FC236}">
-                <a16:creationId xmlns:a16="http://schemas.microsoft.com/office/drawing/2014/main" id="{8EA2FD67-EFD6-2CDF-2B7F-330FD3ED2DF7}"/>
+                <a16:creationId xmlns:a16="http://schemas.microsoft.com/office/drawing/2014/main" id="{7E198745-500D-CD8F-A400-246673D4C1B6}"/>
               </a:ext>
             </a:extLst>
           </p:cNvPr>
@@ -5282,7 +6127,7 @@
           <p:cNvPr id="8" name="TextBox 7">
             <a:extLst>
               <a:ext uri="{FF2B5EF4-FFF2-40B4-BE49-F238E27FC236}">
-                <a16:creationId xmlns:a16="http://schemas.microsoft.com/office/drawing/2014/main" id="{8C2C3D5D-3C1F-9333-7EA8-8A2D8EE51A86}"/>
+                <a16:creationId xmlns:a16="http://schemas.microsoft.com/office/drawing/2014/main" id="{0C5D9856-89B9-D9FA-A70D-F8707C45BA38}"/>
               </a:ext>
             </a:extLst>
           </p:cNvPr>
@@ -5322,7 +6167,7 @@
           <p:cNvPr id="9" name="TextBox 8">
             <a:extLst>
               <a:ext uri="{FF2B5EF4-FFF2-40B4-BE49-F238E27FC236}">
-                <a16:creationId xmlns:a16="http://schemas.microsoft.com/office/drawing/2014/main" id="{BDCAEE65-2737-360F-7245-54F504BA6C5E}"/>
+                <a16:creationId xmlns:a16="http://schemas.microsoft.com/office/drawing/2014/main" id="{BA519369-8ACC-F769-C709-673BDD756FE0}"/>
               </a:ext>
             </a:extLst>
           </p:cNvPr>
@@ -5362,7 +6207,7 @@
           <p:cNvPr id="10" name="TextBox 9">
             <a:extLst>
               <a:ext uri="{FF2B5EF4-FFF2-40B4-BE49-F238E27FC236}">
-                <a16:creationId xmlns:a16="http://schemas.microsoft.com/office/drawing/2014/main" id="{6827DF1B-1819-717B-7078-FB50733795EC}"/>
+                <a16:creationId xmlns:a16="http://schemas.microsoft.com/office/drawing/2014/main" id="{AA6B1805-F025-E061-B532-081C1AE3C175}"/>
               </a:ext>
             </a:extLst>
           </p:cNvPr>
@@ -5408,7 +6253,7 @@
           <p:cNvPr id="11" name="Rectangle: Rounded Corners 10">
             <a:extLst>
               <a:ext uri="{FF2B5EF4-FFF2-40B4-BE49-F238E27FC236}">
-                <a16:creationId xmlns:a16="http://schemas.microsoft.com/office/drawing/2014/main" id="{9A161C9F-25E1-08E8-31E3-A260AF713EDC}"/>
+                <a16:creationId xmlns:a16="http://schemas.microsoft.com/office/drawing/2014/main" id="{BD0E21DE-EECD-9471-F459-037C28844972}"/>
               </a:ext>
             </a:extLst>
           </p:cNvPr>
@@ -5482,7 +6327,7 @@
           <p:cNvPr id="12" name="TextBox 11">
             <a:extLst>
               <a:ext uri="{FF2B5EF4-FFF2-40B4-BE49-F238E27FC236}">
-                <a16:creationId xmlns:a16="http://schemas.microsoft.com/office/drawing/2014/main" id="{35B5D30E-5415-1CA0-70F2-C634CED3086C}"/>
+                <a16:creationId xmlns:a16="http://schemas.microsoft.com/office/drawing/2014/main" id="{50374B56-A0C1-8282-C271-944B0D34EC3B}"/>
               </a:ext>
             </a:extLst>
           </p:cNvPr>
@@ -5522,7 +6367,7 @@
           <p:cNvPr id="13" name="TextBox 12">
             <a:extLst>
               <a:ext uri="{FF2B5EF4-FFF2-40B4-BE49-F238E27FC236}">
-                <a16:creationId xmlns:a16="http://schemas.microsoft.com/office/drawing/2014/main" id="{1653D494-BC72-F835-4065-917B9CDDF4EA}"/>
+                <a16:creationId xmlns:a16="http://schemas.microsoft.com/office/drawing/2014/main" id="{C2B1E0F9-A7EE-C298-E897-8C88C1F6C722}"/>
               </a:ext>
             </a:extLst>
           </p:cNvPr>
@@ -5562,7 +6407,7 @@
           <p:cNvPr id="14" name="TextBox 13">
             <a:extLst>
               <a:ext uri="{FF2B5EF4-FFF2-40B4-BE49-F238E27FC236}">
-                <a16:creationId xmlns:a16="http://schemas.microsoft.com/office/drawing/2014/main" id="{2FC4BBF4-B926-2E72-A2B9-2CC6B0AF8B02}"/>
+                <a16:creationId xmlns:a16="http://schemas.microsoft.com/office/drawing/2014/main" id="{2DD18E95-1F84-6D4B-7355-21348AAEFA30}"/>
               </a:ext>
             </a:extLst>
           </p:cNvPr>
@@ -5608,7 +6453,7 @@
           <p:cNvPr id="15" name="Rectangle: Rounded Corners 14">
             <a:extLst>
               <a:ext uri="{FF2B5EF4-FFF2-40B4-BE49-F238E27FC236}">
-                <a16:creationId xmlns:a16="http://schemas.microsoft.com/office/drawing/2014/main" id="{2F5B1D3E-DCAA-29B4-844C-7138D5AC097A}"/>
+                <a16:creationId xmlns:a16="http://schemas.microsoft.com/office/drawing/2014/main" id="{6856407A-0CA8-A25F-7E4C-D6293A813AC6}"/>
               </a:ext>
             </a:extLst>
           </p:cNvPr>
@@ -5682,7 +6527,7 @@
           <p:cNvPr id="16" name="TextBox 15">
             <a:extLst>
               <a:ext uri="{FF2B5EF4-FFF2-40B4-BE49-F238E27FC236}">
-                <a16:creationId xmlns:a16="http://schemas.microsoft.com/office/drawing/2014/main" id="{834C77E9-4905-095E-F6A3-E9CB2E5BD2B5}"/>
+                <a16:creationId xmlns:a16="http://schemas.microsoft.com/office/drawing/2014/main" id="{E085CD78-332A-E732-DC15-640772C379AD}"/>
               </a:ext>
             </a:extLst>
           </p:cNvPr>
@@ -5722,7 +6567,7 @@
           <p:cNvPr id="17" name="TextBox 16">
             <a:extLst>
               <a:ext uri="{FF2B5EF4-FFF2-40B4-BE49-F238E27FC236}">
-                <a16:creationId xmlns:a16="http://schemas.microsoft.com/office/drawing/2014/main" id="{48A0C3E8-9372-639B-08A5-882469A11674}"/>
+                <a16:creationId xmlns:a16="http://schemas.microsoft.com/office/drawing/2014/main" id="{ECA68735-D95F-E352-D46C-0AE2F157C0B9}"/>
               </a:ext>
             </a:extLst>
           </p:cNvPr>
@@ -5762,7 +6607,7 @@
           <p:cNvPr id="18" name="TextBox 17">
             <a:extLst>
               <a:ext uri="{FF2B5EF4-FFF2-40B4-BE49-F238E27FC236}">
-                <a16:creationId xmlns:a16="http://schemas.microsoft.com/office/drawing/2014/main" id="{82FB76E5-63EB-D66F-4CFB-B0928CD8BF24}"/>
+                <a16:creationId xmlns:a16="http://schemas.microsoft.com/office/drawing/2014/main" id="{ECB15C3F-2DB8-AAA2-CDBD-AE575159FDCF}"/>
               </a:ext>
             </a:extLst>
           </p:cNvPr>
@@ -5806,7 +6651,7 @@
     </p:spTree>
     <p:extLst>
       <p:ext uri="{BB962C8B-B14F-4D97-AF65-F5344CB8AC3E}">
-        <p14:creationId xmlns:p14="http://schemas.microsoft.com/office/powerpoint/2010/main" val="1493388112"/>
+        <p14:creationId xmlns:p14="http://schemas.microsoft.com/office/powerpoint/2010/main" val="551180029"/>
       </p:ext>
     </p:extLst>
   </p:cSld>
@@ -5838,7 +6683,7 @@
           <p:cNvPr id="2" name="TextBox 1">
             <a:extLst>
               <a:ext uri="{FF2B5EF4-FFF2-40B4-BE49-F238E27FC236}">
-                <a16:creationId xmlns:a16="http://schemas.microsoft.com/office/drawing/2014/main" id="{9528082A-8E3B-378E-53BD-602408DE38D0}"/>
+                <a16:creationId xmlns:a16="http://schemas.microsoft.com/office/drawing/2014/main" id="{5DFC1177-0A62-16B8-ABF5-7E6F096C2054}"/>
               </a:ext>
             </a:extLst>
           </p:cNvPr>
@@ -5884,7 +6729,7 @@
           <p:cNvPr id="3" name="TextBox 2">
             <a:extLst>
               <a:ext uri="{FF2B5EF4-FFF2-40B4-BE49-F238E27FC236}">
-                <a16:creationId xmlns:a16="http://schemas.microsoft.com/office/drawing/2014/main" id="{5EC93B1E-6283-BE06-752D-F1D32C87BF22}"/>
+                <a16:creationId xmlns:a16="http://schemas.microsoft.com/office/drawing/2014/main" id="{4C3F3B0F-2651-608C-99D4-2F8C143624CD}"/>
               </a:ext>
             </a:extLst>
           </p:cNvPr>
@@ -5939,7 +6784,7 @@
           <p:cNvPr id="4" name="TextBox 3">
             <a:extLst>
               <a:ext uri="{FF2B5EF4-FFF2-40B4-BE49-F238E27FC236}">
-                <a16:creationId xmlns:a16="http://schemas.microsoft.com/office/drawing/2014/main" id="{F8B2C377-56CA-9968-5338-1CF883B0FD22}"/>
+                <a16:creationId xmlns:a16="http://schemas.microsoft.com/office/drawing/2014/main" id="{A68DCFC3-589F-406B-F55C-F3F48167884B}"/>
               </a:ext>
             </a:extLst>
           </p:cNvPr>
@@ -5979,7 +6824,7 @@
           <p:cNvPr id="5" name="Straight Connector 4">
             <a:extLst>
               <a:ext uri="{FF2B5EF4-FFF2-40B4-BE49-F238E27FC236}">
-                <a16:creationId xmlns:a16="http://schemas.microsoft.com/office/drawing/2014/main" id="{79055AC5-9112-AEE0-C9EB-407B2C7A5CCE}"/>
+                <a16:creationId xmlns:a16="http://schemas.microsoft.com/office/drawing/2014/main" id="{E48C992B-815E-A6DF-3C2C-F47D5A30C216}"/>
               </a:ext>
             </a:extLst>
           </p:cNvPr>
@@ -6020,7 +6865,7 @@
           <p:cNvPr id="6" name="TextBox 5">
             <a:extLst>
               <a:ext uri="{FF2B5EF4-FFF2-40B4-BE49-F238E27FC236}">
-                <a16:creationId xmlns:a16="http://schemas.microsoft.com/office/drawing/2014/main" id="{79ECFECC-5BDC-D09D-F90C-B24121CB6226}"/>
+                <a16:creationId xmlns:a16="http://schemas.microsoft.com/office/drawing/2014/main" id="{6976DCFF-7A10-A9CC-E1D8-CFCF86D241F2}"/>
               </a:ext>
             </a:extLst>
           </p:cNvPr>
@@ -6066,7 +6911,7 @@
           <p:cNvPr id="7" name="TextBox 6">
             <a:extLst>
               <a:ext uri="{FF2B5EF4-FFF2-40B4-BE49-F238E27FC236}">
-                <a16:creationId xmlns:a16="http://schemas.microsoft.com/office/drawing/2014/main" id="{62EC4839-D512-48FC-A526-C41F91AE772F}"/>
+                <a16:creationId xmlns:a16="http://schemas.microsoft.com/office/drawing/2014/main" id="{11590C6B-39E6-199E-718F-B6D05B925AF3}"/>
               </a:ext>
             </a:extLst>
           </p:cNvPr>
@@ -6121,7 +6966,7 @@
           <p:cNvPr id="8" name="TextBox 7">
             <a:extLst>
               <a:ext uri="{FF2B5EF4-FFF2-40B4-BE49-F238E27FC236}">
-                <a16:creationId xmlns:a16="http://schemas.microsoft.com/office/drawing/2014/main" id="{E5D94F09-C301-17FB-A6C0-56E961FFDED4}"/>
+                <a16:creationId xmlns:a16="http://schemas.microsoft.com/office/drawing/2014/main" id="{C1DED96C-D243-53E6-F58C-8331322D2B4B}"/>
               </a:ext>
             </a:extLst>
           </p:cNvPr>
@@ -6161,7 +7006,7 @@
           <p:cNvPr id="9" name="TextBox 8">
             <a:extLst>
               <a:ext uri="{FF2B5EF4-FFF2-40B4-BE49-F238E27FC236}">
-                <a16:creationId xmlns:a16="http://schemas.microsoft.com/office/drawing/2014/main" id="{FA40B60A-EA2D-59A1-D8A9-E2EE4325E5DA}"/>
+                <a16:creationId xmlns:a16="http://schemas.microsoft.com/office/drawing/2014/main" id="{580094E2-A04D-6913-B809-B6316498E9E7}"/>
               </a:ext>
             </a:extLst>
           </p:cNvPr>
@@ -6210,7 +7055,7 @@
           <p:cNvPr id="10" name="TextBox 9">
             <a:extLst>
               <a:ext uri="{FF2B5EF4-FFF2-40B4-BE49-F238E27FC236}">
-                <a16:creationId xmlns:a16="http://schemas.microsoft.com/office/drawing/2014/main" id="{3CFD8CC7-B84F-38B5-0047-917FDD6C901F}"/>
+                <a16:creationId xmlns:a16="http://schemas.microsoft.com/office/drawing/2014/main" id="{209ED16C-EBE9-5CF9-309F-7B06CA92DDD5}"/>
               </a:ext>
             </a:extLst>
           </p:cNvPr>
@@ -6250,7 +7095,7 @@
           <p:cNvPr id="11" name="TextBox 10">
             <a:extLst>
               <a:ext uri="{FF2B5EF4-FFF2-40B4-BE49-F238E27FC236}">
-                <a16:creationId xmlns:a16="http://schemas.microsoft.com/office/drawing/2014/main" id="{5E65DDE6-D0B2-F67F-5A20-5A6EA64C9452}"/>
+                <a16:creationId xmlns:a16="http://schemas.microsoft.com/office/drawing/2014/main" id="{5F89AD95-C427-0441-47F1-6DF113D02DB6}"/>
               </a:ext>
             </a:extLst>
           </p:cNvPr>
@@ -6290,7 +7135,7 @@
           <p:cNvPr id="12" name="Rectangle: Rounded Corners 11">
             <a:extLst>
               <a:ext uri="{FF2B5EF4-FFF2-40B4-BE49-F238E27FC236}">
-                <a16:creationId xmlns:a16="http://schemas.microsoft.com/office/drawing/2014/main" id="{FD63F827-5C38-2640-7F76-B319800A44C8}"/>
+                <a16:creationId xmlns:a16="http://schemas.microsoft.com/office/drawing/2014/main" id="{394C63F2-799D-65C7-D89D-EA75D3FCC678}"/>
               </a:ext>
             </a:extLst>
           </p:cNvPr>
@@ -6358,7 +7203,7 @@
           <p:cNvPr id="13" name="Rectangle: Rounded Corners 12">
             <a:extLst>
               <a:ext uri="{FF2B5EF4-FFF2-40B4-BE49-F238E27FC236}">
-                <a16:creationId xmlns:a16="http://schemas.microsoft.com/office/drawing/2014/main" id="{DE70150C-D6E9-E7B7-9DEF-7B210E5888B2}"/>
+                <a16:creationId xmlns:a16="http://schemas.microsoft.com/office/drawing/2014/main" id="{CDD986C3-8CEC-3967-72F5-23176672BF11}"/>
               </a:ext>
             </a:extLst>
           </p:cNvPr>
@@ -6426,7 +7271,7 @@
           <p:cNvPr id="14" name="Rectangle: Rounded Corners 13">
             <a:extLst>
               <a:ext uri="{FF2B5EF4-FFF2-40B4-BE49-F238E27FC236}">
-                <a16:creationId xmlns:a16="http://schemas.microsoft.com/office/drawing/2014/main" id="{715FB2DF-14CD-BEEA-C271-0CA64E77AABD}"/>
+                <a16:creationId xmlns:a16="http://schemas.microsoft.com/office/drawing/2014/main" id="{96615E8C-FD81-7B9E-9ED1-0E3FB4CE5FCE}"/>
               </a:ext>
             </a:extLst>
           </p:cNvPr>
@@ -6494,7 +7339,7 @@
           <p:cNvPr id="15" name="Rectangle: Rounded Corners 14">
             <a:extLst>
               <a:ext uri="{FF2B5EF4-FFF2-40B4-BE49-F238E27FC236}">
-                <a16:creationId xmlns:a16="http://schemas.microsoft.com/office/drawing/2014/main" id="{9031A1E0-2C1F-B445-E89F-3A2401819999}"/>
+                <a16:creationId xmlns:a16="http://schemas.microsoft.com/office/drawing/2014/main" id="{CE9B2174-80FD-214B-6C65-581DD9C2B5FD}"/>
               </a:ext>
             </a:extLst>
           </p:cNvPr>
@@ -6562,7 +7407,7 @@
           <p:cNvPr id="16" name="Rectangle: Rounded Corners 15">
             <a:extLst>
               <a:ext uri="{FF2B5EF4-FFF2-40B4-BE49-F238E27FC236}">
-                <a16:creationId xmlns:a16="http://schemas.microsoft.com/office/drawing/2014/main" id="{694A8513-FFE0-0781-AF81-1D41A09AB858}"/>
+                <a16:creationId xmlns:a16="http://schemas.microsoft.com/office/drawing/2014/main" id="{9C1BD572-FAEC-41D9-8CCB-B92F7630C354}"/>
               </a:ext>
             </a:extLst>
           </p:cNvPr>
@@ -6630,7 +7475,7 @@
           <p:cNvPr id="17" name="Straight Connector 16">
             <a:extLst>
               <a:ext uri="{FF2B5EF4-FFF2-40B4-BE49-F238E27FC236}">
-                <a16:creationId xmlns:a16="http://schemas.microsoft.com/office/drawing/2014/main" id="{52A6480A-AD2C-DF06-9F1F-16EA17F71337}"/>
+                <a16:creationId xmlns:a16="http://schemas.microsoft.com/office/drawing/2014/main" id="{AB754772-FEBB-99F4-F406-1C2A387E52CB}"/>
               </a:ext>
             </a:extLst>
           </p:cNvPr>
@@ -6671,7 +7516,7 @@
           <p:cNvPr id="18" name="Straight Connector 17">
             <a:extLst>
               <a:ext uri="{FF2B5EF4-FFF2-40B4-BE49-F238E27FC236}">
-                <a16:creationId xmlns:a16="http://schemas.microsoft.com/office/drawing/2014/main" id="{46CF5F9A-068C-3D2D-7EC7-262A8098728E}"/>
+                <a16:creationId xmlns:a16="http://schemas.microsoft.com/office/drawing/2014/main" id="{9E65C8B8-6174-BFC3-EFDD-CD098394773E}"/>
               </a:ext>
             </a:extLst>
           </p:cNvPr>
@@ -6712,7 +7557,7 @@
           <p:cNvPr id="19" name="Straight Connector 18">
             <a:extLst>
               <a:ext uri="{FF2B5EF4-FFF2-40B4-BE49-F238E27FC236}">
-                <a16:creationId xmlns:a16="http://schemas.microsoft.com/office/drawing/2014/main" id="{060102E8-8F48-4CA6-C4FD-7CB247E2DB8B}"/>
+                <a16:creationId xmlns:a16="http://schemas.microsoft.com/office/drawing/2014/main" id="{AAD99323-E227-A431-C275-EAAA81563D36}"/>
               </a:ext>
             </a:extLst>
           </p:cNvPr>
@@ -6753,7 +7598,7 @@
           <p:cNvPr id="20" name="Straight Connector 19">
             <a:extLst>
               <a:ext uri="{FF2B5EF4-FFF2-40B4-BE49-F238E27FC236}">
-                <a16:creationId xmlns:a16="http://schemas.microsoft.com/office/drawing/2014/main" id="{479213D9-C383-CB31-30FC-6543BA0F385B}"/>
+                <a16:creationId xmlns:a16="http://schemas.microsoft.com/office/drawing/2014/main" id="{6EEF8A7F-9607-5818-BB25-7144EBB0B77F}"/>
               </a:ext>
             </a:extLst>
           </p:cNvPr>
@@ -6794,7 +7639,7 @@
           <p:cNvPr id="21" name="TextBox 20">
             <a:extLst>
               <a:ext uri="{FF2B5EF4-FFF2-40B4-BE49-F238E27FC236}">
-                <a16:creationId xmlns:a16="http://schemas.microsoft.com/office/drawing/2014/main" id="{54AE88E8-75A7-B7BC-9716-4ED5749B950D}"/>
+                <a16:creationId xmlns:a16="http://schemas.microsoft.com/office/drawing/2014/main" id="{5D11197E-583F-0D03-5A97-748866DCF1BF}"/>
               </a:ext>
             </a:extLst>
           </p:cNvPr>
@@ -6849,7 +7694,7 @@
           <p:cNvPr id="22" name="TextBox 21">
             <a:extLst>
               <a:ext uri="{FF2B5EF4-FFF2-40B4-BE49-F238E27FC236}">
-                <a16:creationId xmlns:a16="http://schemas.microsoft.com/office/drawing/2014/main" id="{163F728B-4782-7057-194D-221FC0198D43}"/>
+                <a16:creationId xmlns:a16="http://schemas.microsoft.com/office/drawing/2014/main" id="{38ACFE6E-B568-BEE0-71D7-630992D9EAE9}"/>
               </a:ext>
             </a:extLst>
           </p:cNvPr>
@@ -6898,7 +7743,7 @@
           <p:cNvPr id="23" name="TextBox 22">
             <a:extLst>
               <a:ext uri="{FF2B5EF4-FFF2-40B4-BE49-F238E27FC236}">
-                <a16:creationId xmlns:a16="http://schemas.microsoft.com/office/drawing/2014/main" id="{13B7889C-F02D-B7D1-2F5C-BAB54CB3A7FB}"/>
+                <a16:creationId xmlns:a16="http://schemas.microsoft.com/office/drawing/2014/main" id="{24BA9201-2113-4016-6FEB-5E1DB42FE13F}"/>
               </a:ext>
             </a:extLst>
           </p:cNvPr>
@@ -6965,7 +7810,7 @@
           <p:cNvPr id="24" name="TextBox 23">
             <a:extLst>
               <a:ext uri="{FF2B5EF4-FFF2-40B4-BE49-F238E27FC236}">
-                <a16:creationId xmlns:a16="http://schemas.microsoft.com/office/drawing/2014/main" id="{B5F9DF1D-94E7-CD64-5B69-257604A7398C}"/>
+                <a16:creationId xmlns:a16="http://schemas.microsoft.com/office/drawing/2014/main" id="{05769EDE-B5E1-1A57-C24D-CD25AD6369D1}"/>
               </a:ext>
             </a:extLst>
           </p:cNvPr>
@@ -7011,7 +7856,7 @@
           <p:cNvPr id="25" name="TextBox 24">
             <a:extLst>
               <a:ext uri="{FF2B5EF4-FFF2-40B4-BE49-F238E27FC236}">
-                <a16:creationId xmlns:a16="http://schemas.microsoft.com/office/drawing/2014/main" id="{944D2DE0-F82F-2A67-9E4C-E4AFE935A182}"/>
+                <a16:creationId xmlns:a16="http://schemas.microsoft.com/office/drawing/2014/main" id="{83B9B9AC-206C-21F6-5258-5BD2F8B2C674}"/>
               </a:ext>
             </a:extLst>
           </p:cNvPr>
@@ -7057,7 +7902,7 @@
           <p:cNvPr id="26" name="TextBox 25">
             <a:extLst>
               <a:ext uri="{FF2B5EF4-FFF2-40B4-BE49-F238E27FC236}">
-                <a16:creationId xmlns:a16="http://schemas.microsoft.com/office/drawing/2014/main" id="{694749C3-0A58-CAB3-602C-F44950D6579D}"/>
+                <a16:creationId xmlns:a16="http://schemas.microsoft.com/office/drawing/2014/main" id="{4F88DC25-A4A7-6F68-C631-4BEB60CD36ED}"/>
               </a:ext>
             </a:extLst>
           </p:cNvPr>
@@ -7101,7 +7946,7 @@
     </p:spTree>
     <p:extLst>
       <p:ext uri="{BB962C8B-B14F-4D97-AF65-F5344CB8AC3E}">
-        <p14:creationId xmlns:p14="http://schemas.microsoft.com/office/powerpoint/2010/main" val="2949255063"/>
+        <p14:creationId xmlns:p14="http://schemas.microsoft.com/office/powerpoint/2010/main" val="3022317809"/>
       </p:ext>
     </p:extLst>
   </p:cSld>
@@ -7133,7 +7978,7 @@
           <p:cNvPr id="2" name="TextBox 1">
             <a:extLst>
               <a:ext uri="{FF2B5EF4-FFF2-40B4-BE49-F238E27FC236}">
-                <a16:creationId xmlns:a16="http://schemas.microsoft.com/office/drawing/2014/main" id="{5F5CBA7A-FF9D-11FC-F423-5E73069F9B45}"/>
+                <a16:creationId xmlns:a16="http://schemas.microsoft.com/office/drawing/2014/main" id="{A120EA93-2557-C607-9D08-D979C0E130EE}"/>
               </a:ext>
             </a:extLst>
           </p:cNvPr>
@@ -7179,7 +8024,7 @@
           <p:cNvPr id="3" name="TextBox 2">
             <a:extLst>
               <a:ext uri="{FF2B5EF4-FFF2-40B4-BE49-F238E27FC236}">
-                <a16:creationId xmlns:a16="http://schemas.microsoft.com/office/drawing/2014/main" id="{927F49CF-FB9B-BB18-11F9-C871A15185F8}"/>
+                <a16:creationId xmlns:a16="http://schemas.microsoft.com/office/drawing/2014/main" id="{D65080E7-E372-F689-708D-8F80FC3236EF}"/>
               </a:ext>
             </a:extLst>
           </p:cNvPr>
@@ -7225,7 +8070,7 @@
           <p:cNvPr id="4" name="TextBox 3">
             <a:extLst>
               <a:ext uri="{FF2B5EF4-FFF2-40B4-BE49-F238E27FC236}">
-                <a16:creationId xmlns:a16="http://schemas.microsoft.com/office/drawing/2014/main" id="{E1094B18-F548-5D5B-7523-913F96F16635}"/>
+                <a16:creationId xmlns:a16="http://schemas.microsoft.com/office/drawing/2014/main" id="{12C61A70-9F20-AAF2-4645-98372E1A7E2E}"/>
               </a:ext>
             </a:extLst>
           </p:cNvPr>
@@ -7265,7 +8110,7 @@
           <p:cNvPr id="5" name="Straight Connector 4">
             <a:extLst>
               <a:ext uri="{FF2B5EF4-FFF2-40B4-BE49-F238E27FC236}">
-                <a16:creationId xmlns:a16="http://schemas.microsoft.com/office/drawing/2014/main" id="{2A66117D-FBCD-EAD5-19B6-1777CD271885}"/>
+                <a16:creationId xmlns:a16="http://schemas.microsoft.com/office/drawing/2014/main" id="{6CD37A93-153D-DD42-931E-2BDD206F7872}"/>
               </a:ext>
             </a:extLst>
           </p:cNvPr>
@@ -7306,7 +8151,7 @@
           <p:cNvPr id="7" name="Picture 6">
             <a:extLst>
               <a:ext uri="{FF2B5EF4-FFF2-40B4-BE49-F238E27FC236}">
-                <a16:creationId xmlns:a16="http://schemas.microsoft.com/office/drawing/2014/main" id="{53AF01AC-3CED-1DD3-4065-A0F98D6121BA}"/>
+                <a16:creationId xmlns:a16="http://schemas.microsoft.com/office/drawing/2014/main" id="{FFDC0941-F975-D9E3-BC46-5F0544D8BD08}"/>
               </a:ext>
             </a:extLst>
           </p:cNvPr>
@@ -7342,7 +8187,7 @@
           <p:cNvPr id="8" name="TextBox 7">
             <a:extLst>
               <a:ext uri="{FF2B5EF4-FFF2-40B4-BE49-F238E27FC236}">
-                <a16:creationId xmlns:a16="http://schemas.microsoft.com/office/drawing/2014/main" id="{6E89C1BD-6A58-4131-1560-775DCC5554AF}"/>
+                <a16:creationId xmlns:a16="http://schemas.microsoft.com/office/drawing/2014/main" id="{1BC3B0F6-A736-EC08-B174-C7A64F1D8B5A}"/>
               </a:ext>
             </a:extLst>
           </p:cNvPr>
@@ -7382,7 +8227,7 @@
           <p:cNvPr id="9" name="TextBox 8">
             <a:extLst>
               <a:ext uri="{FF2B5EF4-FFF2-40B4-BE49-F238E27FC236}">
-                <a16:creationId xmlns:a16="http://schemas.microsoft.com/office/drawing/2014/main" id="{B594703F-CF75-F8DC-182B-16F533837066}"/>
+                <a16:creationId xmlns:a16="http://schemas.microsoft.com/office/drawing/2014/main" id="{EE503607-BEBB-D485-01FA-362729F9C178}"/>
               </a:ext>
             </a:extLst>
           </p:cNvPr>
@@ -7431,7 +8276,7 @@
           <p:cNvPr id="10" name="Rectangle: Rounded Corners 9">
             <a:extLst>
               <a:ext uri="{FF2B5EF4-FFF2-40B4-BE49-F238E27FC236}">
-                <a16:creationId xmlns:a16="http://schemas.microsoft.com/office/drawing/2014/main" id="{8484BAE0-6498-094F-7CC3-2F9334495753}"/>
+                <a16:creationId xmlns:a16="http://schemas.microsoft.com/office/drawing/2014/main" id="{8C0BB6CE-0EDA-DDB6-4EAD-58E1F25E87B8}"/>
               </a:ext>
             </a:extLst>
           </p:cNvPr>
@@ -7499,7 +8344,7 @@
           <p:cNvPr id="11" name="TextBox 10">
             <a:extLst>
               <a:ext uri="{FF2B5EF4-FFF2-40B4-BE49-F238E27FC236}">
-                <a16:creationId xmlns:a16="http://schemas.microsoft.com/office/drawing/2014/main" id="{F557D406-8709-D543-1521-137FA24ACAB6}"/>
+                <a16:creationId xmlns:a16="http://schemas.microsoft.com/office/drawing/2014/main" id="{7DF89A41-7598-0205-D45F-16F3FF442410}"/>
               </a:ext>
             </a:extLst>
           </p:cNvPr>
@@ -7544,7 +8389,7 @@
     </p:spTree>
     <p:extLst>
       <p:ext uri="{BB962C8B-B14F-4D97-AF65-F5344CB8AC3E}">
-        <p14:creationId xmlns:p14="http://schemas.microsoft.com/office/powerpoint/2010/main" val="4147802479"/>
+        <p14:creationId xmlns:p14="http://schemas.microsoft.com/office/powerpoint/2010/main" val="3358806100"/>
       </p:ext>
     </p:extLst>
   </p:cSld>
@@ -7576,7 +8421,7 @@
           <p:cNvPr id="2" name="TextBox 1">
             <a:extLst>
               <a:ext uri="{FF2B5EF4-FFF2-40B4-BE49-F238E27FC236}">
-                <a16:creationId xmlns:a16="http://schemas.microsoft.com/office/drawing/2014/main" id="{27925D56-8DDC-2A96-C090-CE455CFC1674}"/>
+                <a16:creationId xmlns:a16="http://schemas.microsoft.com/office/drawing/2014/main" id="{DA7F30FC-F814-8042-F2C4-D3F1D4716374}"/>
               </a:ext>
             </a:extLst>
           </p:cNvPr>
@@ -7622,7 +8467,7 @@
           <p:cNvPr id="3" name="TextBox 2">
             <a:extLst>
               <a:ext uri="{FF2B5EF4-FFF2-40B4-BE49-F238E27FC236}">
-                <a16:creationId xmlns:a16="http://schemas.microsoft.com/office/drawing/2014/main" id="{8C3B24BB-5A34-60DF-C3CB-AA63584580E3}"/>
+                <a16:creationId xmlns:a16="http://schemas.microsoft.com/office/drawing/2014/main" id="{F7266DEE-B1E4-19F8-CAC2-B3E19678F801}"/>
               </a:ext>
             </a:extLst>
           </p:cNvPr>
@@ -7662,7 +8507,7 @@
           <p:cNvPr id="4" name="TextBox 3">
             <a:extLst>
               <a:ext uri="{FF2B5EF4-FFF2-40B4-BE49-F238E27FC236}">
-                <a16:creationId xmlns:a16="http://schemas.microsoft.com/office/drawing/2014/main" id="{E767E4DF-88DC-E0A7-7CF5-C4A2B9D37C99}"/>
+                <a16:creationId xmlns:a16="http://schemas.microsoft.com/office/drawing/2014/main" id="{32A23117-56C6-3AAC-949C-17CD1BF9BCE1}"/>
               </a:ext>
             </a:extLst>
           </p:cNvPr>
@@ -7702,7 +8547,7 @@
           <p:cNvPr id="5" name="Straight Connector 4">
             <a:extLst>
               <a:ext uri="{FF2B5EF4-FFF2-40B4-BE49-F238E27FC236}">
-                <a16:creationId xmlns:a16="http://schemas.microsoft.com/office/drawing/2014/main" id="{B1B8D167-2C7B-A985-5170-B3CD87FF15CA}"/>
+                <a16:creationId xmlns:a16="http://schemas.microsoft.com/office/drawing/2014/main" id="{B4FF9899-A82B-42CB-54C9-A8F970EE25BB}"/>
               </a:ext>
             </a:extLst>
           </p:cNvPr>
@@ -7743,7 +8588,7 @@
           <p:cNvPr id="6" name="TextBox 5">
             <a:extLst>
               <a:ext uri="{FF2B5EF4-FFF2-40B4-BE49-F238E27FC236}">
-                <a16:creationId xmlns:a16="http://schemas.microsoft.com/office/drawing/2014/main" id="{129704AE-FAC9-950B-C280-09D0B577E4FF}"/>
+                <a16:creationId xmlns:a16="http://schemas.microsoft.com/office/drawing/2014/main" id="{C1B31784-B2CA-20C2-7E08-EC0FEEDDCEF6}"/>
               </a:ext>
             </a:extLst>
           </p:cNvPr>
@@ -7789,7 +8634,7 @@
           <p:cNvPr id="8" name="Picture 7">
             <a:extLst>
               <a:ext uri="{FF2B5EF4-FFF2-40B4-BE49-F238E27FC236}">
-                <a16:creationId xmlns:a16="http://schemas.microsoft.com/office/drawing/2014/main" id="{37BD5C3C-C7E9-5B4B-4E67-DC59253FB425}"/>
+                <a16:creationId xmlns:a16="http://schemas.microsoft.com/office/drawing/2014/main" id="{A337EF95-B481-2DCA-1A5F-BF85022EAD38}"/>
               </a:ext>
             </a:extLst>
           </p:cNvPr>
@@ -7825,7 +8670,7 @@
           <p:cNvPr id="9" name="TextBox 8">
             <a:extLst>
               <a:ext uri="{FF2B5EF4-FFF2-40B4-BE49-F238E27FC236}">
-                <a16:creationId xmlns:a16="http://schemas.microsoft.com/office/drawing/2014/main" id="{B95753AC-A82C-A2B2-82DC-CF40782736FA}"/>
+                <a16:creationId xmlns:a16="http://schemas.microsoft.com/office/drawing/2014/main" id="{64EF61B1-5F9A-4C51-A12C-7610F2EFA269}"/>
               </a:ext>
             </a:extLst>
           </p:cNvPr>
@@ -7865,7 +8710,7 @@
           <p:cNvPr id="10" name="TextBox 9">
             <a:extLst>
               <a:ext uri="{FF2B5EF4-FFF2-40B4-BE49-F238E27FC236}">
-                <a16:creationId xmlns:a16="http://schemas.microsoft.com/office/drawing/2014/main" id="{E307DEAD-C31C-22F0-8A6D-9A4F77B9EFDA}"/>
+                <a16:creationId xmlns:a16="http://schemas.microsoft.com/office/drawing/2014/main" id="{7C0D291B-9070-305C-04DF-11DFE2D85E78}"/>
               </a:ext>
             </a:extLst>
           </p:cNvPr>
@@ -7914,7 +8759,7 @@
           <p:cNvPr id="11" name="Rectangle: Rounded Corners 10">
             <a:extLst>
               <a:ext uri="{FF2B5EF4-FFF2-40B4-BE49-F238E27FC236}">
-                <a16:creationId xmlns:a16="http://schemas.microsoft.com/office/drawing/2014/main" id="{7056013C-6D88-8CC1-2D82-92AF4CD16763}"/>
+                <a16:creationId xmlns:a16="http://schemas.microsoft.com/office/drawing/2014/main" id="{8027B488-869B-E37F-8DC9-BCE7538A0C80}"/>
               </a:ext>
             </a:extLst>
           </p:cNvPr>
@@ -7982,7 +8827,7 @@
           <p:cNvPr id="12" name="TextBox 11">
             <a:extLst>
               <a:ext uri="{FF2B5EF4-FFF2-40B4-BE49-F238E27FC236}">
-                <a16:creationId xmlns:a16="http://schemas.microsoft.com/office/drawing/2014/main" id="{5E18B78C-6BCE-FD75-1D53-2B4ACF7FDCEB}"/>
+                <a16:creationId xmlns:a16="http://schemas.microsoft.com/office/drawing/2014/main" id="{97AF2F12-24D5-9D70-F38E-AE13244D86FA}"/>
               </a:ext>
             </a:extLst>
           </p:cNvPr>
@@ -8027,7 +8872,7 @@
     </p:spTree>
     <p:extLst>
       <p:ext uri="{BB962C8B-B14F-4D97-AF65-F5344CB8AC3E}">
-        <p14:creationId xmlns:p14="http://schemas.microsoft.com/office/powerpoint/2010/main" val="866738222"/>
+        <p14:creationId xmlns:p14="http://schemas.microsoft.com/office/powerpoint/2010/main" val="743973461"/>
       </p:ext>
     </p:extLst>
   </p:cSld>
@@ -8059,7 +8904,7 @@
           <p:cNvPr id="2" name="TextBox 1">
             <a:extLst>
               <a:ext uri="{FF2B5EF4-FFF2-40B4-BE49-F238E27FC236}">
-                <a16:creationId xmlns:a16="http://schemas.microsoft.com/office/drawing/2014/main" id="{162D26DD-46D0-5E60-C90D-100B8E32C9E9}"/>
+                <a16:creationId xmlns:a16="http://schemas.microsoft.com/office/drawing/2014/main" id="{5A9B2C35-00DD-919F-88F0-A038B9248F41}"/>
               </a:ext>
             </a:extLst>
           </p:cNvPr>
@@ -8105,7 +8950,7 @@
           <p:cNvPr id="3" name="TextBox 2">
             <a:extLst>
               <a:ext uri="{FF2B5EF4-FFF2-40B4-BE49-F238E27FC236}">
-                <a16:creationId xmlns:a16="http://schemas.microsoft.com/office/drawing/2014/main" id="{23C60312-4CFC-2ECD-5E55-456DAEB64242}"/>
+                <a16:creationId xmlns:a16="http://schemas.microsoft.com/office/drawing/2014/main" id="{ADA776A4-1132-2A98-1F07-9A1D11C2B684}"/>
               </a:ext>
             </a:extLst>
           </p:cNvPr>
@@ -8160,7 +9005,7 @@
           <p:cNvPr id="4" name="TextBox 3">
             <a:extLst>
               <a:ext uri="{FF2B5EF4-FFF2-40B4-BE49-F238E27FC236}">
-                <a16:creationId xmlns:a16="http://schemas.microsoft.com/office/drawing/2014/main" id="{EAA10E6B-7CDC-E2AA-3CDF-BF58B81A3351}"/>
+                <a16:creationId xmlns:a16="http://schemas.microsoft.com/office/drawing/2014/main" id="{1B7705F1-9FD9-DD13-7CDB-4A074694A5A6}"/>
               </a:ext>
             </a:extLst>
           </p:cNvPr>
@@ -8200,7 +9045,7 @@
           <p:cNvPr id="5" name="Straight Connector 4">
             <a:extLst>
               <a:ext uri="{FF2B5EF4-FFF2-40B4-BE49-F238E27FC236}">
-                <a16:creationId xmlns:a16="http://schemas.microsoft.com/office/drawing/2014/main" id="{617BA531-68A3-6F13-F9D0-9A43A6BC4BBE}"/>
+                <a16:creationId xmlns:a16="http://schemas.microsoft.com/office/drawing/2014/main" id="{2E2C9CE3-54D6-6A79-5803-B3FE7331F577}"/>
               </a:ext>
             </a:extLst>
           </p:cNvPr>
@@ -8241,7 +9086,7 @@
           <p:cNvPr id="6" name="TextBox 5">
             <a:extLst>
               <a:ext uri="{FF2B5EF4-FFF2-40B4-BE49-F238E27FC236}">
-                <a16:creationId xmlns:a16="http://schemas.microsoft.com/office/drawing/2014/main" id="{1408C082-E6BE-3CCD-056C-4F2163EDAD7F}"/>
+                <a16:creationId xmlns:a16="http://schemas.microsoft.com/office/drawing/2014/main" id="{037C5E06-11D4-F4BD-BAE6-CDB80DCA345E}"/>
               </a:ext>
             </a:extLst>
           </p:cNvPr>
@@ -8287,7 +9132,7 @@
           <p:cNvPr id="7" name="Rectangle: Rounded Corners 6">
             <a:extLst>
               <a:ext uri="{FF2B5EF4-FFF2-40B4-BE49-F238E27FC236}">
-                <a16:creationId xmlns:a16="http://schemas.microsoft.com/office/drawing/2014/main" id="{7C0318D0-34E1-BEBB-BFB6-9E0A8E6EE509}"/>
+                <a16:creationId xmlns:a16="http://schemas.microsoft.com/office/drawing/2014/main" id="{F028DF83-E760-965F-39CB-2D723A40ABCB}"/>
               </a:ext>
             </a:extLst>
           </p:cNvPr>
@@ -8361,7 +9206,7 @@
           <p:cNvPr id="8" name="Rectangle: Rounded Corners 7">
             <a:extLst>
               <a:ext uri="{FF2B5EF4-FFF2-40B4-BE49-F238E27FC236}">
-                <a16:creationId xmlns:a16="http://schemas.microsoft.com/office/drawing/2014/main" id="{F7893631-A47F-C2A5-C620-331F202C83E9}"/>
+                <a16:creationId xmlns:a16="http://schemas.microsoft.com/office/drawing/2014/main" id="{EE1E725A-E081-AAA0-BE42-ABD8AD5A1E30}"/>
               </a:ext>
             </a:extLst>
           </p:cNvPr>
@@ -8429,7 +9274,7 @@
           <p:cNvPr id="9" name="TextBox 8">
             <a:extLst>
               <a:ext uri="{FF2B5EF4-FFF2-40B4-BE49-F238E27FC236}">
-                <a16:creationId xmlns:a16="http://schemas.microsoft.com/office/drawing/2014/main" id="{EB231A49-6765-1EDF-8117-3994E3E5E766}"/>
+                <a16:creationId xmlns:a16="http://schemas.microsoft.com/office/drawing/2014/main" id="{06AA8EEF-6FC4-775C-30D8-9339A5A090E3}"/>
               </a:ext>
             </a:extLst>
           </p:cNvPr>
@@ -8469,7 +9314,7 @@
           <p:cNvPr id="10" name="TextBox 9">
             <a:extLst>
               <a:ext uri="{FF2B5EF4-FFF2-40B4-BE49-F238E27FC236}">
-                <a16:creationId xmlns:a16="http://schemas.microsoft.com/office/drawing/2014/main" id="{91454815-C8AB-32C8-F553-68577B210F85}"/>
+                <a16:creationId xmlns:a16="http://schemas.microsoft.com/office/drawing/2014/main" id="{EAFF2825-A0A1-4FB0-353B-59CB5C52242D}"/>
               </a:ext>
             </a:extLst>
           </p:cNvPr>
@@ -8515,7 +9360,7 @@
           <p:cNvPr id="11" name="TextBox 10">
             <a:extLst>
               <a:ext uri="{FF2B5EF4-FFF2-40B4-BE49-F238E27FC236}">
-                <a16:creationId xmlns:a16="http://schemas.microsoft.com/office/drawing/2014/main" id="{32912DAF-F8D1-B191-A92D-F2DE760051DE}"/>
+                <a16:creationId xmlns:a16="http://schemas.microsoft.com/office/drawing/2014/main" id="{7ED49DD6-3E58-E3A3-A8A2-69E1325EE1B7}"/>
               </a:ext>
             </a:extLst>
           </p:cNvPr>
@@ -8573,7 +9418,7 @@
           <p:cNvPr id="12" name="Rectangle: Rounded Corners 11">
             <a:extLst>
               <a:ext uri="{FF2B5EF4-FFF2-40B4-BE49-F238E27FC236}">
-                <a16:creationId xmlns:a16="http://schemas.microsoft.com/office/drawing/2014/main" id="{4BBD3F7E-8CD5-8052-24FB-4A74C95A1B56}"/>
+                <a16:creationId xmlns:a16="http://schemas.microsoft.com/office/drawing/2014/main" id="{05D7AD0B-9214-8BC6-A668-0347D32431DD}"/>
               </a:ext>
             </a:extLst>
           </p:cNvPr>
@@ -8647,7 +9492,7 @@
           <p:cNvPr id="13" name="Rectangle: Rounded Corners 12">
             <a:extLst>
               <a:ext uri="{FF2B5EF4-FFF2-40B4-BE49-F238E27FC236}">
-                <a16:creationId xmlns:a16="http://schemas.microsoft.com/office/drawing/2014/main" id="{D9208FBD-AFF0-3D89-B801-725B904E9068}"/>
+                <a16:creationId xmlns:a16="http://schemas.microsoft.com/office/drawing/2014/main" id="{8EA30CBE-C00B-6D86-0F5D-EA34B528B2C2}"/>
               </a:ext>
             </a:extLst>
           </p:cNvPr>
@@ -8715,7 +9560,7 @@
           <p:cNvPr id="14" name="TextBox 13">
             <a:extLst>
               <a:ext uri="{FF2B5EF4-FFF2-40B4-BE49-F238E27FC236}">
-                <a16:creationId xmlns:a16="http://schemas.microsoft.com/office/drawing/2014/main" id="{7AB79BF4-7F30-06B5-A140-25FB52629EBE}"/>
+                <a16:creationId xmlns:a16="http://schemas.microsoft.com/office/drawing/2014/main" id="{300CCC19-B66D-5DBF-1763-776154FE09E1}"/>
               </a:ext>
             </a:extLst>
           </p:cNvPr>
@@ -8755,7 +9600,7 @@
           <p:cNvPr id="15" name="TextBox 14">
             <a:extLst>
               <a:ext uri="{FF2B5EF4-FFF2-40B4-BE49-F238E27FC236}">
-                <a16:creationId xmlns:a16="http://schemas.microsoft.com/office/drawing/2014/main" id="{0C771B66-31AF-5C50-954A-426A8FDDDFA3}"/>
+                <a16:creationId xmlns:a16="http://schemas.microsoft.com/office/drawing/2014/main" id="{C0B801C7-045B-C8C9-B92B-485FCC319696}"/>
               </a:ext>
             </a:extLst>
           </p:cNvPr>
@@ -8801,7 +9646,7 @@
           <p:cNvPr id="16" name="TextBox 15">
             <a:extLst>
               <a:ext uri="{FF2B5EF4-FFF2-40B4-BE49-F238E27FC236}">
-                <a16:creationId xmlns:a16="http://schemas.microsoft.com/office/drawing/2014/main" id="{3CED97A3-76E9-B4C3-6BC8-B33018FDFDAE}"/>
+                <a16:creationId xmlns:a16="http://schemas.microsoft.com/office/drawing/2014/main" id="{FD473AB1-112A-BAE1-E8B5-A674C6E3F44A}"/>
               </a:ext>
             </a:extLst>
           </p:cNvPr>
@@ -8874,7 +9719,7 @@
           <p:cNvPr id="17" name="Rectangle: Rounded Corners 16">
             <a:extLst>
               <a:ext uri="{FF2B5EF4-FFF2-40B4-BE49-F238E27FC236}">
-                <a16:creationId xmlns:a16="http://schemas.microsoft.com/office/drawing/2014/main" id="{6351C980-CE09-F1A7-E825-C82137ABDDAC}"/>
+                <a16:creationId xmlns:a16="http://schemas.microsoft.com/office/drawing/2014/main" id="{7E31AFEA-1F82-2A49-4581-C237D9B1D567}"/>
               </a:ext>
             </a:extLst>
           </p:cNvPr>
@@ -8948,7 +9793,7 @@
           <p:cNvPr id="18" name="Rectangle: Rounded Corners 17">
             <a:extLst>
               <a:ext uri="{FF2B5EF4-FFF2-40B4-BE49-F238E27FC236}">
-                <a16:creationId xmlns:a16="http://schemas.microsoft.com/office/drawing/2014/main" id="{F6A477CE-7531-A314-2056-8B91E98DDF43}"/>
+                <a16:creationId xmlns:a16="http://schemas.microsoft.com/office/drawing/2014/main" id="{53C513EF-50FF-70D7-4D45-349B1CA9E549}"/>
               </a:ext>
             </a:extLst>
           </p:cNvPr>
@@ -9016,7 +9861,7 @@
           <p:cNvPr id="19" name="TextBox 18">
             <a:extLst>
               <a:ext uri="{FF2B5EF4-FFF2-40B4-BE49-F238E27FC236}">
-                <a16:creationId xmlns:a16="http://schemas.microsoft.com/office/drawing/2014/main" id="{FE7B837F-CEC9-DE47-25B6-A26EAABE268C}"/>
+                <a16:creationId xmlns:a16="http://schemas.microsoft.com/office/drawing/2014/main" id="{4C191365-A1B7-3CFE-A2F4-92D493B66DED}"/>
               </a:ext>
             </a:extLst>
           </p:cNvPr>
@@ -9056,7 +9901,7 @@
           <p:cNvPr id="20" name="TextBox 19">
             <a:extLst>
               <a:ext uri="{FF2B5EF4-FFF2-40B4-BE49-F238E27FC236}">
-                <a16:creationId xmlns:a16="http://schemas.microsoft.com/office/drawing/2014/main" id="{A8319796-847F-50C6-404F-D59A239C753A}"/>
+                <a16:creationId xmlns:a16="http://schemas.microsoft.com/office/drawing/2014/main" id="{0C5CC128-DE7B-8F18-4A19-F7556D40EC3E}"/>
               </a:ext>
             </a:extLst>
           </p:cNvPr>
@@ -9102,7 +9947,7 @@
           <p:cNvPr id="21" name="TextBox 20">
             <a:extLst>
               <a:ext uri="{FF2B5EF4-FFF2-40B4-BE49-F238E27FC236}">
-                <a16:creationId xmlns:a16="http://schemas.microsoft.com/office/drawing/2014/main" id="{DEE13869-054A-7C70-8FBB-7457FEE2808D}"/>
+                <a16:creationId xmlns:a16="http://schemas.microsoft.com/office/drawing/2014/main" id="{4A0EF075-2627-3FC8-7120-0CB13FBEE677}"/>
               </a:ext>
             </a:extLst>
           </p:cNvPr>
@@ -9148,7 +9993,7 @@
           <p:cNvPr id="22" name="Rectangle: Rounded Corners 21">
             <a:extLst>
               <a:ext uri="{FF2B5EF4-FFF2-40B4-BE49-F238E27FC236}">
-                <a16:creationId xmlns:a16="http://schemas.microsoft.com/office/drawing/2014/main" id="{F21C6827-7494-6773-42E4-D0CBC1B65C14}"/>
+                <a16:creationId xmlns:a16="http://schemas.microsoft.com/office/drawing/2014/main" id="{039F8470-3592-FD66-C781-BDA86D69CA4C}"/>
               </a:ext>
             </a:extLst>
           </p:cNvPr>
@@ -9222,7 +10067,7 @@
           <p:cNvPr id="23" name="Rectangle: Rounded Corners 22">
             <a:extLst>
               <a:ext uri="{FF2B5EF4-FFF2-40B4-BE49-F238E27FC236}">
-                <a16:creationId xmlns:a16="http://schemas.microsoft.com/office/drawing/2014/main" id="{B59B59FA-90CA-48ED-0F8B-CF2788ADB34D}"/>
+                <a16:creationId xmlns:a16="http://schemas.microsoft.com/office/drawing/2014/main" id="{469C1B8A-DE87-DD35-5CF2-2902884B9AE6}"/>
               </a:ext>
             </a:extLst>
           </p:cNvPr>
@@ -9290,7 +10135,7 @@
           <p:cNvPr id="24" name="TextBox 23">
             <a:extLst>
               <a:ext uri="{FF2B5EF4-FFF2-40B4-BE49-F238E27FC236}">
-                <a16:creationId xmlns:a16="http://schemas.microsoft.com/office/drawing/2014/main" id="{5A1FB440-73D2-ABF2-7831-418CBD0F9150}"/>
+                <a16:creationId xmlns:a16="http://schemas.microsoft.com/office/drawing/2014/main" id="{D67EFBA6-31B7-F89D-8B90-1EE1F6B7A852}"/>
               </a:ext>
             </a:extLst>
           </p:cNvPr>
@@ -9330,7 +10175,7 @@
           <p:cNvPr id="25" name="TextBox 24">
             <a:extLst>
               <a:ext uri="{FF2B5EF4-FFF2-40B4-BE49-F238E27FC236}">
-                <a16:creationId xmlns:a16="http://schemas.microsoft.com/office/drawing/2014/main" id="{C5872DAA-2F87-938E-BA41-C12F04960D6E}"/>
+                <a16:creationId xmlns:a16="http://schemas.microsoft.com/office/drawing/2014/main" id="{A23C3D69-A6B4-AB53-4595-6AFFD057A47F}"/>
               </a:ext>
             </a:extLst>
           </p:cNvPr>
@@ -9376,7 +10221,7 @@
           <p:cNvPr id="26" name="TextBox 25">
             <a:extLst>
               <a:ext uri="{FF2B5EF4-FFF2-40B4-BE49-F238E27FC236}">
-                <a16:creationId xmlns:a16="http://schemas.microsoft.com/office/drawing/2014/main" id="{35558894-6C3E-2E2D-501C-ED53A11FEB37}"/>
+                <a16:creationId xmlns:a16="http://schemas.microsoft.com/office/drawing/2014/main" id="{26F7BB63-39D1-872D-27B2-E91A5B490A74}"/>
               </a:ext>
             </a:extLst>
           </p:cNvPr>
@@ -9431,7 +10276,7 @@
           <p:cNvPr id="27" name="TextBox 26">
             <a:extLst>
               <a:ext uri="{FF2B5EF4-FFF2-40B4-BE49-F238E27FC236}">
-                <a16:creationId xmlns:a16="http://schemas.microsoft.com/office/drawing/2014/main" id="{BCEDA002-694A-5B1C-19F2-E1870661DBC0}"/>
+                <a16:creationId xmlns:a16="http://schemas.microsoft.com/office/drawing/2014/main" id="{CD22E8D0-E62F-F124-00F9-1C1920A0607A}"/>
               </a:ext>
             </a:extLst>
           </p:cNvPr>
@@ -9496,7 +10341,7 @@
     </p:spTree>
     <p:extLst>
       <p:ext uri="{BB962C8B-B14F-4D97-AF65-F5344CB8AC3E}">
-        <p14:creationId xmlns:p14="http://schemas.microsoft.com/office/powerpoint/2010/main" val="1750840376"/>
+        <p14:creationId xmlns:p14="http://schemas.microsoft.com/office/powerpoint/2010/main" val="3938066349"/>
       </p:ext>
     </p:extLst>
   </p:cSld>
@@ -9528,7 +10373,7 @@
           <p:cNvPr id="2" name="TextBox 1">
             <a:extLst>
               <a:ext uri="{FF2B5EF4-FFF2-40B4-BE49-F238E27FC236}">
-                <a16:creationId xmlns:a16="http://schemas.microsoft.com/office/drawing/2014/main" id="{3AC104B9-74B6-F679-B360-F2C0E683C663}"/>
+                <a16:creationId xmlns:a16="http://schemas.microsoft.com/office/drawing/2014/main" id="{AF5FF272-7E08-6106-427D-AC63668C68DE}"/>
               </a:ext>
             </a:extLst>
           </p:cNvPr>
@@ -9574,7 +10419,7 @@
           <p:cNvPr id="3" name="TextBox 2">
             <a:extLst>
               <a:ext uri="{FF2B5EF4-FFF2-40B4-BE49-F238E27FC236}">
-                <a16:creationId xmlns:a16="http://schemas.microsoft.com/office/drawing/2014/main" id="{BB778192-B1C0-263B-4BFB-14558D965082}"/>
+                <a16:creationId xmlns:a16="http://schemas.microsoft.com/office/drawing/2014/main" id="{31253F3F-DF3F-F09A-644C-902FCA4DE309}"/>
               </a:ext>
             </a:extLst>
           </p:cNvPr>
@@ -9623,7 +10468,7 @@
           <p:cNvPr id="4" name="TextBox 3">
             <a:extLst>
               <a:ext uri="{FF2B5EF4-FFF2-40B4-BE49-F238E27FC236}">
-                <a16:creationId xmlns:a16="http://schemas.microsoft.com/office/drawing/2014/main" id="{7BD0C7ED-3831-2721-4504-01EF339E0F92}"/>
+                <a16:creationId xmlns:a16="http://schemas.microsoft.com/office/drawing/2014/main" id="{F54A353D-F9FE-9C48-786A-41C26C2D29ED}"/>
               </a:ext>
             </a:extLst>
           </p:cNvPr>
@@ -9663,7 +10508,7 @@
           <p:cNvPr id="5" name="Straight Connector 4">
             <a:extLst>
               <a:ext uri="{FF2B5EF4-FFF2-40B4-BE49-F238E27FC236}">
-                <a16:creationId xmlns:a16="http://schemas.microsoft.com/office/drawing/2014/main" id="{CA84E421-4611-9FC5-6E7F-17AF1AAD0391}"/>
+                <a16:creationId xmlns:a16="http://schemas.microsoft.com/office/drawing/2014/main" id="{3EB6F1C4-DE05-B801-42F6-82C61653B98D}"/>
               </a:ext>
             </a:extLst>
           </p:cNvPr>
@@ -9704,7 +10549,7 @@
           <p:cNvPr id="6" name="Rectangle: Rounded Corners 5">
             <a:extLst>
               <a:ext uri="{FF2B5EF4-FFF2-40B4-BE49-F238E27FC236}">
-                <a16:creationId xmlns:a16="http://schemas.microsoft.com/office/drawing/2014/main" id="{78D1F47A-6026-ECA7-CCBD-732204630D4C}"/>
+                <a16:creationId xmlns:a16="http://schemas.microsoft.com/office/drawing/2014/main" id="{A7271BE7-246B-BE2A-8489-590C79D44B12}"/>
               </a:ext>
             </a:extLst>
           </p:cNvPr>
@@ -9778,7 +10623,7 @@
           <p:cNvPr id="7" name="TextBox 6">
             <a:extLst>
               <a:ext uri="{FF2B5EF4-FFF2-40B4-BE49-F238E27FC236}">
-                <a16:creationId xmlns:a16="http://schemas.microsoft.com/office/drawing/2014/main" id="{99EADF97-21E8-A673-B0FA-C7287070B5AD}"/>
+                <a16:creationId xmlns:a16="http://schemas.microsoft.com/office/drawing/2014/main" id="{BD8F066E-38E9-F086-3C21-F2E1B5A1EB03}"/>
               </a:ext>
             </a:extLst>
           </p:cNvPr>
@@ -9833,7 +10678,7 @@
           <p:cNvPr id="8" name="TextBox 7">
             <a:extLst>
               <a:ext uri="{FF2B5EF4-FFF2-40B4-BE49-F238E27FC236}">
-                <a16:creationId xmlns:a16="http://schemas.microsoft.com/office/drawing/2014/main" id="{25ADBD3B-83A5-625A-F95A-9534A5F1B82A}"/>
+                <a16:creationId xmlns:a16="http://schemas.microsoft.com/office/drawing/2014/main" id="{9C0C7671-D0B5-1C2C-D8F3-ADCCD9645107}"/>
               </a:ext>
             </a:extLst>
           </p:cNvPr>
@@ -9898,7 +10743,7 @@
           <p:cNvPr id="9" name="TextBox 8">
             <a:extLst>
               <a:ext uri="{FF2B5EF4-FFF2-40B4-BE49-F238E27FC236}">
-                <a16:creationId xmlns:a16="http://schemas.microsoft.com/office/drawing/2014/main" id="{58B651C6-2791-9195-51AE-D14CEED0A5C6}"/>
+                <a16:creationId xmlns:a16="http://schemas.microsoft.com/office/drawing/2014/main" id="{110C4F4F-140B-1660-5950-A66243A98DD0}"/>
               </a:ext>
             </a:extLst>
           </p:cNvPr>
@@ -9953,7 +10798,7 @@
           <p:cNvPr id="10" name="TextBox 9">
             <a:extLst>
               <a:ext uri="{FF2B5EF4-FFF2-40B4-BE49-F238E27FC236}">
-                <a16:creationId xmlns:a16="http://schemas.microsoft.com/office/drawing/2014/main" id="{816B289D-D026-8FCF-212F-D4A7CEDC2C0F}"/>
+                <a16:creationId xmlns:a16="http://schemas.microsoft.com/office/drawing/2014/main" id="{E7004F3F-7C07-027B-EAE9-15C875F091F6}"/>
               </a:ext>
             </a:extLst>
           </p:cNvPr>
@@ -10003,7 +10848,7 @@
           <p:cNvPr id="11" name="Rectangle: Rounded Corners 10">
             <a:extLst>
               <a:ext uri="{FF2B5EF4-FFF2-40B4-BE49-F238E27FC236}">
-                <a16:creationId xmlns:a16="http://schemas.microsoft.com/office/drawing/2014/main" id="{C84584ED-2815-DBB9-2EF0-22501F8A0CF4}"/>
+                <a16:creationId xmlns:a16="http://schemas.microsoft.com/office/drawing/2014/main" id="{6FFF8C5F-F4D7-6CA4-559D-7B92A92DE4FE}"/>
               </a:ext>
             </a:extLst>
           </p:cNvPr>
@@ -10077,7 +10922,7 @@
           <p:cNvPr id="12" name="TextBox 11">
             <a:extLst>
               <a:ext uri="{FF2B5EF4-FFF2-40B4-BE49-F238E27FC236}">
-                <a16:creationId xmlns:a16="http://schemas.microsoft.com/office/drawing/2014/main" id="{3CBF3215-FD93-06D4-82F3-1C7B5C9FADC8}"/>
+                <a16:creationId xmlns:a16="http://schemas.microsoft.com/office/drawing/2014/main" id="{D2EADFCF-BB6F-D104-DB96-E6E136A53FE3}"/>
               </a:ext>
             </a:extLst>
           </p:cNvPr>
@@ -10117,7 +10962,7 @@
           <p:cNvPr id="13" name="TextBox 12">
             <a:extLst>
               <a:ext uri="{FF2B5EF4-FFF2-40B4-BE49-F238E27FC236}">
-                <a16:creationId xmlns:a16="http://schemas.microsoft.com/office/drawing/2014/main" id="{58DB23F4-9013-4387-4D21-FA76388FA4E7}"/>
+                <a16:creationId xmlns:a16="http://schemas.microsoft.com/office/drawing/2014/main" id="{1347E526-9BAA-34C7-06FA-DA4D84C633B4}"/>
               </a:ext>
             </a:extLst>
           </p:cNvPr>
@@ -10163,7 +11008,7 @@
           <p:cNvPr id="14" name="TextBox 13">
             <a:extLst>
               <a:ext uri="{FF2B5EF4-FFF2-40B4-BE49-F238E27FC236}">
-                <a16:creationId xmlns:a16="http://schemas.microsoft.com/office/drawing/2014/main" id="{1C9973A7-CD3D-0AB9-664F-15ED1078B7A4}"/>
+                <a16:creationId xmlns:a16="http://schemas.microsoft.com/office/drawing/2014/main" id="{9990402A-B420-9185-96A5-FC4EE2199439}"/>
               </a:ext>
             </a:extLst>
           </p:cNvPr>
@@ -10209,7 +11054,7 @@
           <p:cNvPr id="15" name="TextBox 14">
             <a:extLst>
               <a:ext uri="{FF2B5EF4-FFF2-40B4-BE49-F238E27FC236}">
-                <a16:creationId xmlns:a16="http://schemas.microsoft.com/office/drawing/2014/main" id="{5547077A-E1FD-BC59-6616-A8E2A0526387}"/>
+                <a16:creationId xmlns:a16="http://schemas.microsoft.com/office/drawing/2014/main" id="{164F15B3-AAB9-C629-9340-04F66CEF1C4A}"/>
               </a:ext>
             </a:extLst>
           </p:cNvPr>
@@ -10255,7 +11100,7 @@
           <p:cNvPr id="16" name="TextBox 15">
             <a:extLst>
               <a:ext uri="{FF2B5EF4-FFF2-40B4-BE49-F238E27FC236}">
-                <a16:creationId xmlns:a16="http://schemas.microsoft.com/office/drawing/2014/main" id="{5245BDA2-BA1E-2EE1-3C54-686A1E918D77}"/>
+                <a16:creationId xmlns:a16="http://schemas.microsoft.com/office/drawing/2014/main" id="{334C189A-F3EF-A4BB-1BA7-808FFCABF173}"/>
               </a:ext>
             </a:extLst>
           </p:cNvPr>
@@ -10299,7 +11144,7 @@
     </p:spTree>
     <p:extLst>
       <p:ext uri="{BB962C8B-B14F-4D97-AF65-F5344CB8AC3E}">
-        <p14:creationId xmlns:p14="http://schemas.microsoft.com/office/powerpoint/2010/main" val="999039554"/>
+        <p14:creationId xmlns:p14="http://schemas.microsoft.com/office/powerpoint/2010/main" val="360686462"/>
       </p:ext>
     </p:extLst>
   </p:cSld>
@@ -10331,7 +11176,7 @@
           <p:cNvPr id="2" name="TextBox 1">
             <a:extLst>
               <a:ext uri="{FF2B5EF4-FFF2-40B4-BE49-F238E27FC236}">
-                <a16:creationId xmlns:a16="http://schemas.microsoft.com/office/drawing/2014/main" id="{3E7AF989-DC31-479E-0A37-EE62494BFADF}"/>
+                <a16:creationId xmlns:a16="http://schemas.microsoft.com/office/drawing/2014/main" id="{51D7450E-A7C8-35D4-8529-3FA8121309AD}"/>
               </a:ext>
             </a:extLst>
           </p:cNvPr>
@@ -10377,7 +11222,7 @@
           <p:cNvPr id="3" name="TextBox 2">
             <a:extLst>
               <a:ext uri="{FF2B5EF4-FFF2-40B4-BE49-F238E27FC236}">
-                <a16:creationId xmlns:a16="http://schemas.microsoft.com/office/drawing/2014/main" id="{CCC8659B-4E8D-9378-0B56-68B356303A3B}"/>
+                <a16:creationId xmlns:a16="http://schemas.microsoft.com/office/drawing/2014/main" id="{9AF3BBC9-9828-9130-7E94-EB36DA760144}"/>
               </a:ext>
             </a:extLst>
           </p:cNvPr>
@@ -10417,7 +11262,7 @@
           <p:cNvPr id="4" name="TextBox 3">
             <a:extLst>
               <a:ext uri="{FF2B5EF4-FFF2-40B4-BE49-F238E27FC236}">
-                <a16:creationId xmlns:a16="http://schemas.microsoft.com/office/drawing/2014/main" id="{E9409958-4D73-38D0-0B6D-F2DC22089AF4}"/>
+                <a16:creationId xmlns:a16="http://schemas.microsoft.com/office/drawing/2014/main" id="{1CC0D3C0-94CC-84A1-612F-A213424FB97F}"/>
               </a:ext>
             </a:extLst>
           </p:cNvPr>
@@ -10457,7 +11302,7 @@
           <p:cNvPr id="5" name="Straight Connector 4">
             <a:extLst>
               <a:ext uri="{FF2B5EF4-FFF2-40B4-BE49-F238E27FC236}">
-                <a16:creationId xmlns:a16="http://schemas.microsoft.com/office/drawing/2014/main" id="{04B31270-75B5-20A6-54AF-2A6C1E2A7F44}"/>
+                <a16:creationId xmlns:a16="http://schemas.microsoft.com/office/drawing/2014/main" id="{C558F56A-F972-0A07-3BD3-098D9003413C}"/>
               </a:ext>
             </a:extLst>
           </p:cNvPr>
@@ -10498,7 +11343,7 @@
           <p:cNvPr id="6" name="Rectangle: Rounded Corners 5">
             <a:extLst>
               <a:ext uri="{FF2B5EF4-FFF2-40B4-BE49-F238E27FC236}">
-                <a16:creationId xmlns:a16="http://schemas.microsoft.com/office/drawing/2014/main" id="{73EB6F7B-B662-252B-95DA-3F46F452CD73}"/>
+                <a16:creationId xmlns:a16="http://schemas.microsoft.com/office/drawing/2014/main" id="{E009D402-0BFD-9B6C-E130-337EFDA5A99C}"/>
               </a:ext>
             </a:extLst>
           </p:cNvPr>
@@ -10566,7 +11411,7 @@
           <p:cNvPr id="7" name="TextBox 6">
             <a:extLst>
               <a:ext uri="{FF2B5EF4-FFF2-40B4-BE49-F238E27FC236}">
-                <a16:creationId xmlns:a16="http://schemas.microsoft.com/office/drawing/2014/main" id="{1EC1CF33-DC70-04FD-294E-135A30FEF44E}"/>
+                <a16:creationId xmlns:a16="http://schemas.microsoft.com/office/drawing/2014/main" id="{F19C445C-8C79-D418-F488-16FF25EFB2DD}"/>
               </a:ext>
             </a:extLst>
           </p:cNvPr>
@@ -10606,7 +11451,7 @@
           <p:cNvPr id="8" name="TextBox 7">
             <a:extLst>
               <a:ext uri="{FF2B5EF4-FFF2-40B4-BE49-F238E27FC236}">
-                <a16:creationId xmlns:a16="http://schemas.microsoft.com/office/drawing/2014/main" id="{F82A984A-E69C-3BFF-5663-690CBBA28C94}"/>
+                <a16:creationId xmlns:a16="http://schemas.microsoft.com/office/drawing/2014/main" id="{C3712873-A7DB-C15B-95DE-7BDBE4C70A98}"/>
               </a:ext>
             </a:extLst>
           </p:cNvPr>
@@ -10646,7 +11491,7 @@
           <p:cNvPr id="9" name="TextBox 8">
             <a:extLst>
               <a:ext uri="{FF2B5EF4-FFF2-40B4-BE49-F238E27FC236}">
-                <a16:creationId xmlns:a16="http://schemas.microsoft.com/office/drawing/2014/main" id="{C44EBE0B-9BA0-A8B8-DA84-E65E71F569FA}"/>
+                <a16:creationId xmlns:a16="http://schemas.microsoft.com/office/drawing/2014/main" id="{76258C75-2A1F-5B46-734B-F28D45BA5E89}"/>
               </a:ext>
             </a:extLst>
           </p:cNvPr>
@@ -10686,7 +11531,7 @@
           <p:cNvPr id="10" name="Rectangle 9">
             <a:extLst>
               <a:ext uri="{FF2B5EF4-FFF2-40B4-BE49-F238E27FC236}">
-                <a16:creationId xmlns:a16="http://schemas.microsoft.com/office/drawing/2014/main" id="{19250DAF-E20D-C813-99B9-3A3D81E52470}"/>
+                <a16:creationId xmlns:a16="http://schemas.microsoft.com/office/drawing/2014/main" id="{AAA87692-FE8D-9901-E5E6-33208B66C206}"/>
               </a:ext>
             </a:extLst>
           </p:cNvPr>
@@ -10754,7 +11599,7 @@
           <p:cNvPr id="11" name="TextBox 10">
             <a:extLst>
               <a:ext uri="{FF2B5EF4-FFF2-40B4-BE49-F238E27FC236}">
-                <a16:creationId xmlns:a16="http://schemas.microsoft.com/office/drawing/2014/main" id="{A7693323-70E6-49F2-F7C9-30E78567C76F}"/>
+                <a16:creationId xmlns:a16="http://schemas.microsoft.com/office/drawing/2014/main" id="{DFF7CA4F-16BD-2CD1-3F78-AFE649F41BE9}"/>
               </a:ext>
             </a:extLst>
           </p:cNvPr>
@@ -10809,7 +11654,7 @@
           <p:cNvPr id="12" name="TextBox 11">
             <a:extLst>
               <a:ext uri="{FF2B5EF4-FFF2-40B4-BE49-F238E27FC236}">
-                <a16:creationId xmlns:a16="http://schemas.microsoft.com/office/drawing/2014/main" id="{178853D6-7711-1DE8-107A-B5215DA6AD62}"/>
+                <a16:creationId xmlns:a16="http://schemas.microsoft.com/office/drawing/2014/main" id="{5D1043D2-D936-DC7F-93B3-60AEB71CB5F8}"/>
               </a:ext>
             </a:extLst>
           </p:cNvPr>
@@ -10849,7 +11694,7 @@
           <p:cNvPr id="13" name="TextBox 12">
             <a:extLst>
               <a:ext uri="{FF2B5EF4-FFF2-40B4-BE49-F238E27FC236}">
-                <a16:creationId xmlns:a16="http://schemas.microsoft.com/office/drawing/2014/main" id="{980AB91A-461E-5E3D-DD8A-3692E2CAAFD1}"/>
+                <a16:creationId xmlns:a16="http://schemas.microsoft.com/office/drawing/2014/main" id="{8A22E822-D1DC-FF61-4F1A-EDC8307B36C6}"/>
               </a:ext>
             </a:extLst>
           </p:cNvPr>
@@ -10895,7 +11740,7 @@
           <p:cNvPr id="14" name="Rectangle 13">
             <a:extLst>
               <a:ext uri="{FF2B5EF4-FFF2-40B4-BE49-F238E27FC236}">
-                <a16:creationId xmlns:a16="http://schemas.microsoft.com/office/drawing/2014/main" id="{3052D9EA-077B-0593-D03E-3716C7EB2F9F}"/>
+                <a16:creationId xmlns:a16="http://schemas.microsoft.com/office/drawing/2014/main" id="{832B613C-C9D6-47A9-ABFF-15888AD0F6B6}"/>
               </a:ext>
             </a:extLst>
           </p:cNvPr>
@@ -10963,7 +11808,7 @@
           <p:cNvPr id="15" name="TextBox 14">
             <a:extLst>
               <a:ext uri="{FF2B5EF4-FFF2-40B4-BE49-F238E27FC236}">
-                <a16:creationId xmlns:a16="http://schemas.microsoft.com/office/drawing/2014/main" id="{24905406-3D4C-E047-0449-FDABE143B183}"/>
+                <a16:creationId xmlns:a16="http://schemas.microsoft.com/office/drawing/2014/main" id="{FDAE1BCD-418F-FF97-1CAB-5DB79A4A8B9D}"/>
               </a:ext>
             </a:extLst>
           </p:cNvPr>
@@ -11018,7 +11863,7 @@
           <p:cNvPr id="16" name="TextBox 15">
             <a:extLst>
               <a:ext uri="{FF2B5EF4-FFF2-40B4-BE49-F238E27FC236}">
-                <a16:creationId xmlns:a16="http://schemas.microsoft.com/office/drawing/2014/main" id="{A52FD376-22A3-A912-D029-D0525BCC0FDB}"/>
+                <a16:creationId xmlns:a16="http://schemas.microsoft.com/office/drawing/2014/main" id="{1355512B-F3BB-99EB-D408-722B826427AE}"/>
               </a:ext>
             </a:extLst>
           </p:cNvPr>
@@ -11058,7 +11903,7 @@
           <p:cNvPr id="17" name="TextBox 16">
             <a:extLst>
               <a:ext uri="{FF2B5EF4-FFF2-40B4-BE49-F238E27FC236}">
-                <a16:creationId xmlns:a16="http://schemas.microsoft.com/office/drawing/2014/main" id="{E99AA58B-A963-CF54-8F53-DBFE99A28ABF}"/>
+                <a16:creationId xmlns:a16="http://schemas.microsoft.com/office/drawing/2014/main" id="{DB0A59B8-1110-83D2-8E00-631D63180DEC}"/>
               </a:ext>
             </a:extLst>
           </p:cNvPr>
@@ -11104,7 +11949,7 @@
           <p:cNvPr id="18" name="Rectangle 17">
             <a:extLst>
               <a:ext uri="{FF2B5EF4-FFF2-40B4-BE49-F238E27FC236}">
-                <a16:creationId xmlns:a16="http://schemas.microsoft.com/office/drawing/2014/main" id="{6F3C3DC4-68C5-9578-9CBA-A04E711DA7F8}"/>
+                <a16:creationId xmlns:a16="http://schemas.microsoft.com/office/drawing/2014/main" id="{13D259C0-ECC9-C93C-73D5-2AC2B65C3AD1}"/>
               </a:ext>
             </a:extLst>
           </p:cNvPr>
@@ -11172,7 +12017,7 @@
           <p:cNvPr id="19" name="TextBox 18">
             <a:extLst>
               <a:ext uri="{FF2B5EF4-FFF2-40B4-BE49-F238E27FC236}">
-                <a16:creationId xmlns:a16="http://schemas.microsoft.com/office/drawing/2014/main" id="{019A1AB7-B3FB-4F62-1450-30CB41A12A63}"/>
+                <a16:creationId xmlns:a16="http://schemas.microsoft.com/office/drawing/2014/main" id="{636EB049-54AF-4D1E-A7D3-13A9666EEC0D}"/>
               </a:ext>
             </a:extLst>
           </p:cNvPr>
@@ -11218,7 +12063,7 @@
           <p:cNvPr id="20" name="TextBox 19">
             <a:extLst>
               <a:ext uri="{FF2B5EF4-FFF2-40B4-BE49-F238E27FC236}">
-                <a16:creationId xmlns:a16="http://schemas.microsoft.com/office/drawing/2014/main" id="{B1D45A9A-6F72-6E61-76D7-5E1C2209930A}"/>
+                <a16:creationId xmlns:a16="http://schemas.microsoft.com/office/drawing/2014/main" id="{C80479FC-C6B9-967D-918D-AE6F56DD8BEC}"/>
               </a:ext>
             </a:extLst>
           </p:cNvPr>
@@ -11258,7 +12103,7 @@
           <p:cNvPr id="21" name="TextBox 20">
             <a:extLst>
               <a:ext uri="{FF2B5EF4-FFF2-40B4-BE49-F238E27FC236}">
-                <a16:creationId xmlns:a16="http://schemas.microsoft.com/office/drawing/2014/main" id="{CFCDC4CD-C894-5330-71D9-4CEEB0CFA37A}"/>
+                <a16:creationId xmlns:a16="http://schemas.microsoft.com/office/drawing/2014/main" id="{0034DE53-EA03-24A6-4E0C-036A768D72D7}"/>
               </a:ext>
             </a:extLst>
           </p:cNvPr>
@@ -11304,7 +12149,7 @@
           <p:cNvPr id="22" name="Rectangle 21">
             <a:extLst>
               <a:ext uri="{FF2B5EF4-FFF2-40B4-BE49-F238E27FC236}">
-                <a16:creationId xmlns:a16="http://schemas.microsoft.com/office/drawing/2014/main" id="{DECF1B1D-49A4-2596-1B1B-CF00E0FC3917}"/>
+                <a16:creationId xmlns:a16="http://schemas.microsoft.com/office/drawing/2014/main" id="{80C1B115-3819-DFB5-8894-D13476145029}"/>
               </a:ext>
             </a:extLst>
           </p:cNvPr>
@@ -11372,7 +12217,7 @@
           <p:cNvPr id="23" name="TextBox 22">
             <a:extLst>
               <a:ext uri="{FF2B5EF4-FFF2-40B4-BE49-F238E27FC236}">
-                <a16:creationId xmlns:a16="http://schemas.microsoft.com/office/drawing/2014/main" id="{4F95D508-CEB0-AF23-9667-C3C28BEF372E}"/>
+                <a16:creationId xmlns:a16="http://schemas.microsoft.com/office/drawing/2014/main" id="{45E02D6E-EF40-861D-FB09-073D6CEB3A6F}"/>
               </a:ext>
             </a:extLst>
           </p:cNvPr>
@@ -11412,7 +12257,7 @@
           <p:cNvPr id="24" name="TextBox 23">
             <a:extLst>
               <a:ext uri="{FF2B5EF4-FFF2-40B4-BE49-F238E27FC236}">
-                <a16:creationId xmlns:a16="http://schemas.microsoft.com/office/drawing/2014/main" id="{E7D8477C-0C4C-3F92-8ACB-C41BDF19F3FB}"/>
+                <a16:creationId xmlns:a16="http://schemas.microsoft.com/office/drawing/2014/main" id="{5B5A9482-B07F-467E-E60C-0DA79CF6B607}"/>
               </a:ext>
             </a:extLst>
           </p:cNvPr>
@@ -11452,7 +12297,7 @@
           <p:cNvPr id="25" name="TextBox 24">
             <a:extLst>
               <a:ext uri="{FF2B5EF4-FFF2-40B4-BE49-F238E27FC236}">
-                <a16:creationId xmlns:a16="http://schemas.microsoft.com/office/drawing/2014/main" id="{1086AE14-0DB7-9A91-A75A-807C41D5D5B1}"/>
+                <a16:creationId xmlns:a16="http://schemas.microsoft.com/office/drawing/2014/main" id="{68723B5D-7F8A-8CD2-4AE5-D5D731176D79}"/>
               </a:ext>
             </a:extLst>
           </p:cNvPr>
@@ -11498,7 +12343,7 @@
           <p:cNvPr id="26" name="Rectangle 25">
             <a:extLst>
               <a:ext uri="{FF2B5EF4-FFF2-40B4-BE49-F238E27FC236}">
-                <a16:creationId xmlns:a16="http://schemas.microsoft.com/office/drawing/2014/main" id="{B071F428-1243-DD9C-8E30-A92D4514D5CA}"/>
+                <a16:creationId xmlns:a16="http://schemas.microsoft.com/office/drawing/2014/main" id="{E704892C-56B2-DEC8-D172-A0380A07C14B}"/>
               </a:ext>
             </a:extLst>
           </p:cNvPr>
@@ -11566,7 +12411,7 @@
           <p:cNvPr id="27" name="TextBox 26">
             <a:extLst>
               <a:ext uri="{FF2B5EF4-FFF2-40B4-BE49-F238E27FC236}">
-                <a16:creationId xmlns:a16="http://schemas.microsoft.com/office/drawing/2014/main" id="{B23CF3DC-8B0E-1D03-F5B3-67DDDCB15FC2}"/>
+                <a16:creationId xmlns:a16="http://schemas.microsoft.com/office/drawing/2014/main" id="{EB6CA166-D251-BABE-72B7-E14C9F3C2A3C}"/>
               </a:ext>
             </a:extLst>
           </p:cNvPr>
@@ -11606,7 +12451,7 @@
           <p:cNvPr id="28" name="TextBox 27">
             <a:extLst>
               <a:ext uri="{FF2B5EF4-FFF2-40B4-BE49-F238E27FC236}">
-                <a16:creationId xmlns:a16="http://schemas.microsoft.com/office/drawing/2014/main" id="{43505D31-D99F-2503-6DDB-02F2EA0BA8CC}"/>
+                <a16:creationId xmlns:a16="http://schemas.microsoft.com/office/drawing/2014/main" id="{7447A2D7-184F-BB3C-0908-B7BCB233A2B1}"/>
               </a:ext>
             </a:extLst>
           </p:cNvPr>
@@ -11646,7 +12491,7 @@
           <p:cNvPr id="29" name="TextBox 28">
             <a:extLst>
               <a:ext uri="{FF2B5EF4-FFF2-40B4-BE49-F238E27FC236}">
-                <a16:creationId xmlns:a16="http://schemas.microsoft.com/office/drawing/2014/main" id="{0E088B6A-8D46-BF4F-A1FF-3DFBB33D323A}"/>
+                <a16:creationId xmlns:a16="http://schemas.microsoft.com/office/drawing/2014/main" id="{CC2AFC7A-D0A7-4A22-A760-F9C57C084D89}"/>
               </a:ext>
             </a:extLst>
           </p:cNvPr>
@@ -11710,7 +12555,7 @@
           <p:cNvPr id="30" name="Rectangle 29">
             <a:extLst>
               <a:ext uri="{FF2B5EF4-FFF2-40B4-BE49-F238E27FC236}">
-                <a16:creationId xmlns:a16="http://schemas.microsoft.com/office/drawing/2014/main" id="{177A502F-F104-D9C9-C270-153BC4AF1251}"/>
+                <a16:creationId xmlns:a16="http://schemas.microsoft.com/office/drawing/2014/main" id="{33E317A2-6B7A-0F09-CBDB-6E2B2F49A257}"/>
               </a:ext>
             </a:extLst>
           </p:cNvPr>
@@ -11778,7 +12623,7 @@
           <p:cNvPr id="31" name="TextBox 30">
             <a:extLst>
               <a:ext uri="{FF2B5EF4-FFF2-40B4-BE49-F238E27FC236}">
-                <a16:creationId xmlns:a16="http://schemas.microsoft.com/office/drawing/2014/main" id="{CBB141F7-81E1-DF07-91CE-69D690839B38}"/>
+                <a16:creationId xmlns:a16="http://schemas.microsoft.com/office/drawing/2014/main" id="{CDD5DED7-8174-A77D-15DD-49AF07CE4AFF}"/>
               </a:ext>
             </a:extLst>
           </p:cNvPr>
@@ -11824,7 +12669,7 @@
           <p:cNvPr id="32" name="TextBox 31">
             <a:extLst>
               <a:ext uri="{FF2B5EF4-FFF2-40B4-BE49-F238E27FC236}">
-                <a16:creationId xmlns:a16="http://schemas.microsoft.com/office/drawing/2014/main" id="{A63DABF1-4C19-9BE5-A6ED-8F8BE3699B18}"/>
+                <a16:creationId xmlns:a16="http://schemas.microsoft.com/office/drawing/2014/main" id="{132FB003-281A-4B6F-B080-66B7910BB883}"/>
               </a:ext>
             </a:extLst>
           </p:cNvPr>
@@ -11864,7 +12709,7 @@
           <p:cNvPr id="33" name="TextBox 32">
             <a:extLst>
               <a:ext uri="{FF2B5EF4-FFF2-40B4-BE49-F238E27FC236}">
-                <a16:creationId xmlns:a16="http://schemas.microsoft.com/office/drawing/2014/main" id="{969EB881-3108-BFE2-8CBE-3C9E3BEB263C}"/>
+                <a16:creationId xmlns:a16="http://schemas.microsoft.com/office/drawing/2014/main" id="{A9D4E28D-FB9D-C1A9-EF4B-7FCA28D35F12}"/>
               </a:ext>
             </a:extLst>
           </p:cNvPr>
@@ -11944,7 +12789,7 @@
     </p:spTree>
     <p:extLst>
       <p:ext uri="{BB962C8B-B14F-4D97-AF65-F5344CB8AC3E}">
-        <p14:creationId xmlns:p14="http://schemas.microsoft.com/office/powerpoint/2010/main" val="3105587004"/>
+        <p14:creationId xmlns:p14="http://schemas.microsoft.com/office/powerpoint/2010/main" val="3740164662"/>
       </p:ext>
     </p:extLst>
   </p:cSld>
@@ -11976,7 +12821,7 @@
           <p:cNvPr id="2" name="TextBox 1">
             <a:extLst>
               <a:ext uri="{FF2B5EF4-FFF2-40B4-BE49-F238E27FC236}">
-                <a16:creationId xmlns:a16="http://schemas.microsoft.com/office/drawing/2014/main" id="{457DCCC5-2B4F-0956-5E69-D973096E5C33}"/>
+                <a16:creationId xmlns:a16="http://schemas.microsoft.com/office/drawing/2014/main" id="{5D6AF517-C1A3-BF57-FB5C-23BB0107F1D5}"/>
               </a:ext>
             </a:extLst>
           </p:cNvPr>
@@ -12022,7 +12867,7 @@
           <p:cNvPr id="3" name="TextBox 2">
             <a:extLst>
               <a:ext uri="{FF2B5EF4-FFF2-40B4-BE49-F238E27FC236}">
-                <a16:creationId xmlns:a16="http://schemas.microsoft.com/office/drawing/2014/main" id="{6773616F-FBE4-FEDC-FED2-B7BF1FB55966}"/>
+                <a16:creationId xmlns:a16="http://schemas.microsoft.com/office/drawing/2014/main" id="{9F1E17A4-3F65-564E-DAF2-5B6F708E0FB0}"/>
               </a:ext>
             </a:extLst>
           </p:cNvPr>
@@ -12068,7 +12913,7 @@
           <p:cNvPr id="4" name="TextBox 3">
             <a:extLst>
               <a:ext uri="{FF2B5EF4-FFF2-40B4-BE49-F238E27FC236}">
-                <a16:creationId xmlns:a16="http://schemas.microsoft.com/office/drawing/2014/main" id="{90326656-D3CC-6854-B012-B8A0BC7D0782}"/>
+                <a16:creationId xmlns:a16="http://schemas.microsoft.com/office/drawing/2014/main" id="{46F31291-E808-0748-EC0E-E96AB0CC7381}"/>
               </a:ext>
             </a:extLst>
           </p:cNvPr>
@@ -12108,7 +12953,7 @@
           <p:cNvPr id="5" name="Straight Connector 4">
             <a:extLst>
               <a:ext uri="{FF2B5EF4-FFF2-40B4-BE49-F238E27FC236}">
-                <a16:creationId xmlns:a16="http://schemas.microsoft.com/office/drawing/2014/main" id="{2752A9D0-387D-AE32-1D9C-BE7B2D745A74}"/>
+                <a16:creationId xmlns:a16="http://schemas.microsoft.com/office/drawing/2014/main" id="{EEC30A39-E3CB-DC42-F405-1749EA41ADD7}"/>
               </a:ext>
             </a:extLst>
           </p:cNvPr>
@@ -12149,7 +12994,7 @@
           <p:cNvPr id="6" name="Rectangle: Rounded Corners 5">
             <a:extLst>
               <a:ext uri="{FF2B5EF4-FFF2-40B4-BE49-F238E27FC236}">
-                <a16:creationId xmlns:a16="http://schemas.microsoft.com/office/drawing/2014/main" id="{2E5243EB-A84F-CC60-0447-71CBFF74865C}"/>
+                <a16:creationId xmlns:a16="http://schemas.microsoft.com/office/drawing/2014/main" id="{43FFD002-E1F4-84BF-20E9-FC0E43415AEF}"/>
               </a:ext>
             </a:extLst>
           </p:cNvPr>
@@ -12217,7 +13062,7 @@
           <p:cNvPr id="7" name="TextBox 6">
             <a:extLst>
               <a:ext uri="{FF2B5EF4-FFF2-40B4-BE49-F238E27FC236}">
-                <a16:creationId xmlns:a16="http://schemas.microsoft.com/office/drawing/2014/main" id="{7F930BD8-932E-0B82-D344-5C71132A3510}"/>
+                <a16:creationId xmlns:a16="http://schemas.microsoft.com/office/drawing/2014/main" id="{1C62BB33-0A9B-332B-9366-F95D1633E6A9}"/>
               </a:ext>
             </a:extLst>
           </p:cNvPr>
@@ -12257,7 +13102,7 @@
           <p:cNvPr id="8" name="TextBox 7">
             <a:extLst>
               <a:ext uri="{FF2B5EF4-FFF2-40B4-BE49-F238E27FC236}">
-                <a16:creationId xmlns:a16="http://schemas.microsoft.com/office/drawing/2014/main" id="{D447CAC7-DE75-F538-10E9-7433A9E4DB5F}"/>
+                <a16:creationId xmlns:a16="http://schemas.microsoft.com/office/drawing/2014/main" id="{4CB02912-20A0-7898-DB49-ACBA5DA7410C}"/>
               </a:ext>
             </a:extLst>
           </p:cNvPr>
@@ -12297,7 +13142,7 @@
           <p:cNvPr id="9" name="TextBox 8">
             <a:extLst>
               <a:ext uri="{FF2B5EF4-FFF2-40B4-BE49-F238E27FC236}">
-                <a16:creationId xmlns:a16="http://schemas.microsoft.com/office/drawing/2014/main" id="{FF474C52-2BC5-592F-FD47-23A6D31E407A}"/>
+                <a16:creationId xmlns:a16="http://schemas.microsoft.com/office/drawing/2014/main" id="{CA7B4D50-030A-6731-6130-FB034C741F17}"/>
               </a:ext>
             </a:extLst>
           </p:cNvPr>
@@ -12343,7 +13188,7 @@
           <p:cNvPr id="10" name="Rectangle: Rounded Corners 9">
             <a:extLst>
               <a:ext uri="{FF2B5EF4-FFF2-40B4-BE49-F238E27FC236}">
-                <a16:creationId xmlns:a16="http://schemas.microsoft.com/office/drawing/2014/main" id="{B2E6AEA3-5C9C-B070-E7C5-F41A3DAEE6EA}"/>
+                <a16:creationId xmlns:a16="http://schemas.microsoft.com/office/drawing/2014/main" id="{8A4596D1-FA37-50EE-DE3E-A36A02FD80ED}"/>
               </a:ext>
             </a:extLst>
           </p:cNvPr>
@@ -12411,7 +13256,7 @@
           <p:cNvPr id="11" name="TextBox 10">
             <a:extLst>
               <a:ext uri="{FF2B5EF4-FFF2-40B4-BE49-F238E27FC236}">
-                <a16:creationId xmlns:a16="http://schemas.microsoft.com/office/drawing/2014/main" id="{5FFD06DC-F5DC-AED3-BF49-D3EE61C42C96}"/>
+                <a16:creationId xmlns:a16="http://schemas.microsoft.com/office/drawing/2014/main" id="{AAE27A72-A174-A207-D430-A27F217ABA9B}"/>
               </a:ext>
             </a:extLst>
           </p:cNvPr>
@@ -12451,7 +13296,7 @@
           <p:cNvPr id="12" name="TextBox 11">
             <a:extLst>
               <a:ext uri="{FF2B5EF4-FFF2-40B4-BE49-F238E27FC236}">
-                <a16:creationId xmlns:a16="http://schemas.microsoft.com/office/drawing/2014/main" id="{B2400EC3-4DDD-94CA-8530-4BA20A1E3206}"/>
+                <a16:creationId xmlns:a16="http://schemas.microsoft.com/office/drawing/2014/main" id="{22C7FF86-A469-92A6-5042-1BE0321A4101}"/>
               </a:ext>
             </a:extLst>
           </p:cNvPr>
@@ -12497,7 +13342,7 @@
           <p:cNvPr id="13" name="TextBox 12">
             <a:extLst>
               <a:ext uri="{FF2B5EF4-FFF2-40B4-BE49-F238E27FC236}">
-                <a16:creationId xmlns:a16="http://schemas.microsoft.com/office/drawing/2014/main" id="{C12A9168-DD19-DDDE-AF75-0793612D149C}"/>
+                <a16:creationId xmlns:a16="http://schemas.microsoft.com/office/drawing/2014/main" id="{C63C6360-060E-4230-71B5-FD831D90FC79}"/>
               </a:ext>
             </a:extLst>
           </p:cNvPr>
@@ -12543,7 +13388,7 @@
           <p:cNvPr id="14" name="Rectangle: Rounded Corners 13">
             <a:extLst>
               <a:ext uri="{FF2B5EF4-FFF2-40B4-BE49-F238E27FC236}">
-                <a16:creationId xmlns:a16="http://schemas.microsoft.com/office/drawing/2014/main" id="{6E2441C1-EA95-F6D4-5613-D87937FAC2AF}"/>
+                <a16:creationId xmlns:a16="http://schemas.microsoft.com/office/drawing/2014/main" id="{98B540A1-CC59-BA6C-5094-37568B03100A}"/>
               </a:ext>
             </a:extLst>
           </p:cNvPr>
@@ -12611,7 +13456,7 @@
           <p:cNvPr id="15" name="TextBox 14">
             <a:extLst>
               <a:ext uri="{FF2B5EF4-FFF2-40B4-BE49-F238E27FC236}">
-                <a16:creationId xmlns:a16="http://schemas.microsoft.com/office/drawing/2014/main" id="{5CD64E19-7A44-7509-8E1D-CDFE7644CE77}"/>
+                <a16:creationId xmlns:a16="http://schemas.microsoft.com/office/drawing/2014/main" id="{A6FA891B-015E-F542-B398-F6C2795E1F44}"/>
               </a:ext>
             </a:extLst>
           </p:cNvPr>
@@ -12651,7 +13496,7 @@
           <p:cNvPr id="16" name="TextBox 15">
             <a:extLst>
               <a:ext uri="{FF2B5EF4-FFF2-40B4-BE49-F238E27FC236}">
-                <a16:creationId xmlns:a16="http://schemas.microsoft.com/office/drawing/2014/main" id="{BA4F9849-D2FD-D36D-E2F1-2198955ED653}"/>
+                <a16:creationId xmlns:a16="http://schemas.microsoft.com/office/drawing/2014/main" id="{63057943-20C6-A4B9-64DF-292DF41E68AA}"/>
               </a:ext>
             </a:extLst>
           </p:cNvPr>
@@ -12697,7 +13542,7 @@
           <p:cNvPr id="17" name="TextBox 16">
             <a:extLst>
               <a:ext uri="{FF2B5EF4-FFF2-40B4-BE49-F238E27FC236}">
-                <a16:creationId xmlns:a16="http://schemas.microsoft.com/office/drawing/2014/main" id="{6ECB2D5E-F8A9-F271-076A-B030468A9442}"/>
+                <a16:creationId xmlns:a16="http://schemas.microsoft.com/office/drawing/2014/main" id="{FB5AA493-39B5-C264-748F-AA5D7A928A08}"/>
               </a:ext>
             </a:extLst>
           </p:cNvPr>
@@ -12743,7 +13588,7 @@
           <p:cNvPr id="18" name="Rectangle: Rounded Corners 17">
             <a:extLst>
               <a:ext uri="{FF2B5EF4-FFF2-40B4-BE49-F238E27FC236}">
-                <a16:creationId xmlns:a16="http://schemas.microsoft.com/office/drawing/2014/main" id="{699E6711-B3C2-24DA-2A9D-1CE50831667F}"/>
+                <a16:creationId xmlns:a16="http://schemas.microsoft.com/office/drawing/2014/main" id="{B842419E-04CD-70CA-5B8C-95691101E9CA}"/>
               </a:ext>
             </a:extLst>
           </p:cNvPr>
@@ -12811,7 +13656,7 @@
           <p:cNvPr id="19" name="TextBox 18">
             <a:extLst>
               <a:ext uri="{FF2B5EF4-FFF2-40B4-BE49-F238E27FC236}">
-                <a16:creationId xmlns:a16="http://schemas.microsoft.com/office/drawing/2014/main" id="{C853F52C-2A05-B378-150B-34E0B52CDB4A}"/>
+                <a16:creationId xmlns:a16="http://schemas.microsoft.com/office/drawing/2014/main" id="{A6284FAF-2BD7-D0E3-0BAE-97877BABE072}"/>
               </a:ext>
             </a:extLst>
           </p:cNvPr>
@@ -12851,7 +13696,7 @@
           <p:cNvPr id="20" name="TextBox 19">
             <a:extLst>
               <a:ext uri="{FF2B5EF4-FFF2-40B4-BE49-F238E27FC236}">
-                <a16:creationId xmlns:a16="http://schemas.microsoft.com/office/drawing/2014/main" id="{E6AF6536-2A6B-886A-148B-AFE996B1FD5B}"/>
+                <a16:creationId xmlns:a16="http://schemas.microsoft.com/office/drawing/2014/main" id="{A3C07CB9-814F-D0ED-2431-2806A8BF7C84}"/>
               </a:ext>
             </a:extLst>
           </p:cNvPr>
@@ -12897,7 +13742,7 @@
           <p:cNvPr id="21" name="TextBox 20">
             <a:extLst>
               <a:ext uri="{FF2B5EF4-FFF2-40B4-BE49-F238E27FC236}">
-                <a16:creationId xmlns:a16="http://schemas.microsoft.com/office/drawing/2014/main" id="{3E812D24-6108-781F-617E-EE23A5EDB0B8}"/>
+                <a16:creationId xmlns:a16="http://schemas.microsoft.com/office/drawing/2014/main" id="{1AC6D94A-770D-8C63-FCDE-B3C5DC4255C4}"/>
               </a:ext>
             </a:extLst>
           </p:cNvPr>
@@ -12970,7 +13815,7 @@
           <p:cNvPr id="22" name="Rectangle: Rounded Corners 21">
             <a:extLst>
               <a:ext uri="{FF2B5EF4-FFF2-40B4-BE49-F238E27FC236}">
-                <a16:creationId xmlns:a16="http://schemas.microsoft.com/office/drawing/2014/main" id="{744AB46F-A28A-DB0E-9198-B557392CB75E}"/>
+                <a16:creationId xmlns:a16="http://schemas.microsoft.com/office/drawing/2014/main" id="{4F41C862-11A3-1F0B-0DF9-A54CE42C9AB6}"/>
               </a:ext>
             </a:extLst>
           </p:cNvPr>
@@ -13038,7 +13883,7 @@
           <p:cNvPr id="23" name="TextBox 22">
             <a:extLst>
               <a:ext uri="{FF2B5EF4-FFF2-40B4-BE49-F238E27FC236}">
-                <a16:creationId xmlns:a16="http://schemas.microsoft.com/office/drawing/2014/main" id="{D472F878-F2C4-2ACC-E044-B5B830E49A7C}"/>
+                <a16:creationId xmlns:a16="http://schemas.microsoft.com/office/drawing/2014/main" id="{4F76B222-2A13-F496-99CA-48367E2995BE}"/>
               </a:ext>
             </a:extLst>
           </p:cNvPr>
@@ -13078,7 +13923,7 @@
           <p:cNvPr id="24" name="TextBox 23">
             <a:extLst>
               <a:ext uri="{FF2B5EF4-FFF2-40B4-BE49-F238E27FC236}">
-                <a16:creationId xmlns:a16="http://schemas.microsoft.com/office/drawing/2014/main" id="{C436F143-42AA-48D5-AA3F-D5F072DD0C1E}"/>
+                <a16:creationId xmlns:a16="http://schemas.microsoft.com/office/drawing/2014/main" id="{41B64ABE-BE2A-AF8F-8361-4EBD7F0C7D8B}"/>
               </a:ext>
             </a:extLst>
           </p:cNvPr>
@@ -13122,7 +13967,7 @@
     </p:spTree>
     <p:extLst>
       <p:ext uri="{BB962C8B-B14F-4D97-AF65-F5344CB8AC3E}">
-        <p14:creationId xmlns:p14="http://schemas.microsoft.com/office/powerpoint/2010/main" val="1414844467"/>
+        <p14:creationId xmlns:p14="http://schemas.microsoft.com/office/powerpoint/2010/main" val="3280600876"/>
       </p:ext>
     </p:extLst>
   </p:cSld>

</xml_diff>